<commit_message>
deck v2: real-data renders (live field cells, real route geometry, dose profile), formulas, browser-limits slide, hex motif under camera zone
Generated with [Devin](https://devin.ai)

Co-Authored-By: Devin <158243242+devin-ai-integration[bot]@users.noreply.github.com>
</commit_message>
<xml_diff>
--- a/docs/deck/ALive-tech.pptx
+++ b/docs/deck/ALive-tech.pptx
@@ -3270,8 +3270,8 @@
         </p:nvSpPr>
         <p:spPr>
           <a:xfrm>
-            <a:off x="201168" y="5897880"/>
-            <a:ext cx="1143000" cy="731520"/>
+            <a:off x="201168" y="5806440"/>
+            <a:ext cx="1143000" cy="548640"/>
           </a:xfrm>
           <a:prstGeom prst="rect">
             <a:avLst/>
@@ -3298,15 +3298,6 @@
               </a:rPr>
               <a:t>App coming</a:t>
             </a:r>
-            <a:r>
-              <a:rPr sz="1050" b="1">
-                <a:solidFill>
-                  <a:srgbClr val="9AA0AA"/>
-                </a:solidFill>
-                <a:latin typeface="Segoe UI"/>
-              </a:rPr>
-              <a:t/>
-            </a:r>
           </a:p>
           <a:p>
             <a:pPr algn="l">
@@ -3334,7 +3325,7 @@
         </p:nvSpPr>
         <p:spPr>
           <a:xfrm>
-            <a:off x="201168" y="6400800"/>
+            <a:off x="201168" y="6382512"/>
             <a:ext cx="1188720" cy="384048"/>
           </a:xfrm>
           <a:prstGeom prst="rect">
@@ -3361,15 +3352,6 @@
                 <a:latin typeface="Segoe UI"/>
               </a:rPr>
               <a:t>Open Source</a:t>
-            </a:r>
-            <a:r>
-              <a:rPr sz="850" b="0">
-                <a:solidFill>
-                  <a:srgbClr val="5C6470"/>
-                </a:solidFill>
-                <a:latin typeface="Segoe UI"/>
-              </a:rPr>
-              <a:t/>
             </a:r>
           </a:p>
           <a:p>
@@ -3574,9 +3556,72 @@
           </a:p>
         </p:txBody>
       </p:sp>
-      <p:sp>
-        <p:nvSpPr>
-          <p:cNvPr id="12" name="TextBox 11"/>
+      <p:pic>
+        <p:nvPicPr>
+          <p:cNvPr id="12" name="Picture 11" descr="deckimg_motif.png"/>
+          <p:cNvPicPr>
+            <a:picLocks noChangeAspect="1"/>
+          </p:cNvPicPr>
+          <p:nvPr/>
+        </p:nvPicPr>
+        <p:blipFill>
+          <a:blip r:embed="rId2"/>
+          <a:stretch>
+            <a:fillRect/>
+          </a:stretch>
+        </p:blipFill>
+        <p:spPr>
+          <a:xfrm>
+            <a:off x="9646920" y="137160"/>
+            <a:ext cx="2468880" cy="2194560"/>
+          </a:xfrm>
+          <a:prstGeom prst="rect">
+            <a:avLst/>
+          </a:prstGeom>
+        </p:spPr>
+      </p:pic>
+      <p:sp>
+        <p:nvSpPr>
+          <p:cNvPr id="13" name="TextBox 12"/>
+          <p:cNvSpPr txBox="1"/>
+          <p:nvPr/>
+        </p:nvSpPr>
+        <p:spPr>
+          <a:xfrm>
+            <a:off x="9710928" y="566928"/>
+            <a:ext cx="1280160" cy="274320"/>
+          </a:xfrm>
+          <a:prstGeom prst="rect">
+            <a:avLst/>
+          </a:prstGeom>
+          <a:noFill/>
+        </p:spPr>
+        <p:txBody>
+          <a:bodyPr wrap="square" anchor="t" lIns="0" rIns="0" tIns="0" bIns="0">
+            <a:spAutoFit/>
+          </a:bodyPr>
+          <a:lstStyle/>
+          <a:p>
+            <a:pPr algn="r">
+              <a:lnSpc>
+                <a:spcPct val="100000"/>
+              </a:lnSpc>
+            </a:pPr>
+            <a:r>
+              <a:rPr sz="1000" b="0" spc="200">
+                <a:solidFill>
+                  <a:srgbClr val="5C6470"/>
+                </a:solidFill>
+                <a:latin typeface="Segoe UI"/>
+              </a:rPr>
+              <a:t>01 / 04</a:t>
+            </a:r>
+          </a:p>
+        </p:txBody>
+      </p:sp>
+      <p:sp>
+        <p:nvSpPr>
+          <p:cNvPr id="14" name="TextBox 13"/>
           <p:cNvSpPr txBox="1"/>
           <p:nvPr/>
         </p:nvSpPr>
@@ -3608,21 +3653,21 @@
                 </a:solidFill>
                 <a:latin typeface="Segoe UI"/>
               </a:rPr>
-              <a:t>01 · ARCHITECTURE</a:t>
-            </a:r>
-          </a:p>
-        </p:txBody>
-      </p:sp>
-      <p:sp>
-        <p:nvSpPr>
-          <p:cNvPr id="13" name="TextBox 12"/>
+              <a:t>01 · SYSTEM</a:t>
+            </a:r>
+          </a:p>
+        </p:txBody>
+      </p:sp>
+      <p:sp>
+        <p:nvSpPr>
+          <p:cNvPr id="15" name="TextBox 14"/>
           <p:cNvSpPr txBox="1"/>
           <p:nvPr/>
         </p:nvSpPr>
         <p:spPr>
           <a:xfrm>
-            <a:off x="1828800" y="960120"/>
-            <a:ext cx="8778240" cy="1554480"/>
+            <a:off x="1828800" y="914400"/>
+            <a:ext cx="7589520" cy="1554480"/>
           </a:xfrm>
           <a:prstGeom prst="rect">
             <a:avLst/>
@@ -3641,13 +3686,13 @@
               </a:lnSpc>
             </a:pPr>
             <a:r>
-              <a:rPr sz="3300" b="1">
+              <a:rPr sz="3200" b="1">
                 <a:solidFill>
                   <a:srgbClr val="EDEBE4"/>
                 </a:solidFill>
                 <a:latin typeface="Segoe UI"/>
               </a:rPr>
-              <a:t>One question in —</a:t>
+              <a:t>A live exposure engine,</a:t>
             </a:r>
           </a:p>
           <a:p>
@@ -3657,27 +3702,27 @@
               </a:lnSpc>
             </a:pPr>
             <a:r>
-              <a:rPr sz="3300" b="1">
+              <a:rPr sz="3200" b="1">
                 <a:solidFill>
                   <a:srgbClr val="EDEBE4"/>
                 </a:solidFill>
                 <a:latin typeface="Segoe UI"/>
               </a:rPr>
-              <a:t>“what did this air do to me?”</a:t>
-            </a:r>
-          </a:p>
-        </p:txBody>
-      </p:sp>
-      <p:sp>
-        <p:nvSpPr>
-          <p:cNvPr id="14" name="TextBox 13"/>
+              <a:t>not a dashboard</a:t>
+            </a:r>
+          </a:p>
+        </p:txBody>
+      </p:sp>
+      <p:sp>
+        <p:nvSpPr>
+          <p:cNvPr id="16" name="TextBox 15"/>
           <p:cNvSpPr txBox="1"/>
           <p:nvPr/>
         </p:nvSpPr>
         <p:spPr>
           <a:xfrm>
-            <a:off x="1828800" y="2331720"/>
-            <a:ext cx="7680960" cy="822960"/>
+            <a:off x="1828800" y="2286000"/>
+            <a:ext cx="7498079" cy="822960"/>
           </a:xfrm>
           <a:prstGeom prst="rect">
             <a:avLst/>
@@ -3696,45 +3741,45 @@
               </a:lnSpc>
             </a:pPr>
             <a:r>
-              <a:rPr sz="1450" b="0">
+              <a:rPr sz="1400" b="0">
                 <a:solidFill>
                   <a:srgbClr val="9AA0AA"/>
                 </a:solidFill>
                 <a:latin typeface="Segoe UI"/>
               </a:rPr>
-              <a:t>Everything ALive shows is </a:t>
-            </a:r>
-            <a:r>
-              <a:rPr sz="1450" b="1">
+              <a:t>One question in — </a:t>
+            </a:r>
+            <a:r>
+              <a:rPr sz="1400" b="1">
                 <a:solidFill>
                   <a:srgbClr val="EDEBE4"/>
                 </a:solidFill>
                 <a:latin typeface="Segoe UI"/>
               </a:rPr>
-              <a:t>computed per-request</a:t>
-            </a:r>
-            <a:r>
-              <a:rPr sz="1450" b="0">
+              <a:t>“what did this air do to me?”</a:t>
+            </a:r>
+            <a:r>
+              <a:rPr sz="1400" b="0">
                 <a:solidFill>
                   <a:srgbClr val="9AA0AA"/>
                 </a:solidFill>
                 <a:latin typeface="Segoe UI"/>
               </a:rPr>
-              <a:t> from live feeds — no cached screenshots, no made-up numbers. A thin web app in front, a real engine on AWS behind it.</a:t>
-            </a:r>
-          </a:p>
-        </p:txBody>
-      </p:sp>
-      <p:sp>
-        <p:nvSpPr>
-          <p:cNvPr id="15" name="Rounded Rectangle 14"/>
+              <a:t> — answered per-request from live feeds. No screenshots, no canned numbers.</a:t>
+            </a:r>
+          </a:p>
+        </p:txBody>
+      </p:sp>
+      <p:sp>
+        <p:nvSpPr>
+          <p:cNvPr id="17" name="Rounded Rectangle 16"/>
           <p:cNvSpPr/>
           <p:nvPr/>
         </p:nvSpPr>
         <p:spPr>
           <a:xfrm>
-            <a:off x="1828800" y="3429000"/>
-            <a:ext cx="2514600" cy="1417320"/>
+            <a:off x="1828800" y="3200400"/>
+            <a:ext cx="2468880" cy="1463040"/>
           </a:xfrm>
           <a:prstGeom prst="roundRect">
             <a:avLst>
@@ -3775,14 +3820,14 @@
       </p:sp>
       <p:sp>
         <p:nvSpPr>
-          <p:cNvPr id="16" name="TextBox 15"/>
+          <p:cNvPr id="18" name="TextBox 17"/>
           <p:cNvSpPr txBox="1"/>
           <p:nvPr/>
         </p:nvSpPr>
         <p:spPr>
           <a:xfrm>
-            <a:off x="2048256" y="3611880"/>
-            <a:ext cx="2148840" cy="256032"/>
+            <a:off x="2029968" y="3364992"/>
+            <a:ext cx="2103120" cy="256032"/>
           </a:xfrm>
           <a:prstGeom prst="rect">
             <a:avLst/>
@@ -3814,14 +3859,14 @@
       </p:sp>
       <p:sp>
         <p:nvSpPr>
-          <p:cNvPr id="17" name="TextBox 16"/>
+          <p:cNvPr id="19" name="TextBox 18"/>
           <p:cNvSpPr txBox="1"/>
           <p:nvPr/>
         </p:nvSpPr>
         <p:spPr>
           <a:xfrm>
-            <a:off x="2048256" y="3867912"/>
-            <a:ext cx="2148840" cy="292608"/>
+            <a:off x="2029968" y="3621024"/>
+            <a:ext cx="2103120" cy="292608"/>
           </a:xfrm>
           <a:prstGeom prst="rect">
             <a:avLst/>
@@ -3840,7 +3885,7 @@
               </a:lnSpc>
             </a:pPr>
             <a:r>
-              <a:rPr sz="1450" b="1">
+              <a:rPr sz="1400" b="1">
                 <a:solidFill>
                   <a:srgbClr val="EDEBE4"/>
                 </a:solidFill>
@@ -3853,14 +3898,14 @@
       </p:sp>
       <p:sp>
         <p:nvSpPr>
-          <p:cNvPr id="18" name="TextBox 17"/>
+          <p:cNvPr id="20" name="TextBox 19"/>
           <p:cNvSpPr txBox="1"/>
           <p:nvPr/>
         </p:nvSpPr>
         <p:spPr>
           <a:xfrm>
-            <a:off x="2048256" y="4178808"/>
-            <a:ext cx="2130552" cy="640080"/>
+            <a:off x="2029968" y="3931920"/>
+            <a:ext cx="2121408" cy="685800"/>
           </a:xfrm>
           <a:prstGeom prst="rect">
             <a:avLst/>
@@ -3885,21 +3930,21 @@
                 </a:solidFill>
                 <a:latin typeface="Segoe UI"/>
               </a:rPr>
-              <a:t>GPS, the map, your trip — location never leaves the device</a:t>
-            </a:r>
-          </a:p>
-        </p:txBody>
-      </p:sp>
-      <p:sp>
-        <p:nvSpPr>
-          <p:cNvPr id="19" name="TextBox 18"/>
+              <a:t>GPS, map, trip math — your track never leaves the device</a:t>
+            </a:r>
+          </a:p>
+        </p:txBody>
+      </p:sp>
+      <p:sp>
+        <p:nvSpPr>
+          <p:cNvPr id="21" name="TextBox 20"/>
           <p:cNvSpPr txBox="1"/>
           <p:nvPr/>
         </p:nvSpPr>
         <p:spPr>
           <a:xfrm>
-            <a:off x="4416552" y="3931920"/>
-            <a:ext cx="411480" cy="457200"/>
+            <a:off x="4361688" y="3749040"/>
+            <a:ext cx="365760" cy="457200"/>
           </a:xfrm>
           <a:prstGeom prst="rect">
             <a:avLst/>
@@ -3918,7 +3963,7 @@
               </a:lnSpc>
             </a:pPr>
             <a:r>
-              <a:rPr sz="2000" b="0">
+              <a:rPr sz="1900" b="0">
                 <a:solidFill>
                   <a:srgbClr val="5C6470"/>
                 </a:solidFill>
@@ -3931,14 +3976,14 @@
       </p:sp>
       <p:sp>
         <p:nvSpPr>
-          <p:cNvPr id="20" name="Rounded Rectangle 19"/>
+          <p:cNvPr id="22" name="Rounded Rectangle 21"/>
           <p:cNvSpPr/>
           <p:nvPr/>
         </p:nvSpPr>
         <p:spPr>
           <a:xfrm>
-            <a:off x="4846320" y="3429000"/>
-            <a:ext cx="2514600" cy="1417320"/>
+            <a:off x="4754880" y="3200400"/>
+            <a:ext cx="2468880" cy="1463040"/>
           </a:xfrm>
           <a:prstGeom prst="roundRect">
             <a:avLst>
@@ -3979,14 +4024,14 @@
       </p:sp>
       <p:sp>
         <p:nvSpPr>
-          <p:cNvPr id="21" name="TextBox 20"/>
+          <p:cNvPr id="23" name="TextBox 22"/>
           <p:cNvSpPr txBox="1"/>
           <p:nvPr/>
         </p:nvSpPr>
         <p:spPr>
           <a:xfrm>
-            <a:off x="5065776" y="3611880"/>
-            <a:ext cx="2148840" cy="256032"/>
+            <a:off x="4956048" y="3364992"/>
+            <a:ext cx="2103120" cy="256032"/>
           </a:xfrm>
           <a:prstGeom prst="rect">
             <a:avLst/>
@@ -4018,14 +4063,14 @@
       </p:sp>
       <p:sp>
         <p:nvSpPr>
-          <p:cNvPr id="22" name="TextBox 21"/>
+          <p:cNvPr id="24" name="TextBox 23"/>
           <p:cNvSpPr txBox="1"/>
           <p:nvPr/>
         </p:nvSpPr>
         <p:spPr>
           <a:xfrm>
-            <a:off x="5065776" y="3867912"/>
-            <a:ext cx="2148840" cy="292608"/>
+            <a:off x="4956048" y="3621024"/>
+            <a:ext cx="2103120" cy="292608"/>
           </a:xfrm>
           <a:prstGeom prst="rect">
             <a:avLst/>
@@ -4044,7 +4089,7 @@
               </a:lnSpc>
             </a:pPr>
             <a:r>
-              <a:rPr sz="1450" b="1">
+              <a:rPr sz="1400" b="1">
                 <a:solidFill>
                   <a:srgbClr val="EDEBE4"/>
                 </a:solidFill>
@@ -4057,14 +4102,14 @@
       </p:sp>
       <p:sp>
         <p:nvSpPr>
-          <p:cNvPr id="23" name="TextBox 22"/>
+          <p:cNvPr id="25" name="TextBox 24"/>
           <p:cNvSpPr txBox="1"/>
           <p:nvPr/>
         </p:nvSpPr>
         <p:spPr>
           <a:xfrm>
-            <a:off x="5065776" y="4178808"/>
-            <a:ext cx="2130552" cy="640080"/>
+            <a:off x="4956048" y="3931920"/>
+            <a:ext cx="2121408" cy="685800"/>
           </a:xfrm>
           <a:prstGeom prst="rect">
             <a:avLst/>
@@ -4089,21 +4134,21 @@
                 </a:solidFill>
                 <a:latin typeface="Segoe UI"/>
               </a:rPr>
-              <a:t>Static shell + every API call proxied to the engine</a:t>
-            </a:r>
-          </a:p>
-        </p:txBody>
-      </p:sp>
-      <p:sp>
-        <p:nvSpPr>
-          <p:cNvPr id="24" name="TextBox 23"/>
+              <a:t>static shell + API proxy to the engine</a:t>
+            </a:r>
+          </a:p>
+        </p:txBody>
+      </p:sp>
+      <p:sp>
+        <p:nvSpPr>
+          <p:cNvPr id="26" name="TextBox 25"/>
           <p:cNvSpPr txBox="1"/>
           <p:nvPr/>
         </p:nvSpPr>
         <p:spPr>
           <a:xfrm>
-            <a:off x="7434072" y="3931920"/>
-            <a:ext cx="411480" cy="457200"/>
+            <a:off x="7287768" y="3749040"/>
+            <a:ext cx="365760" cy="457200"/>
           </a:xfrm>
           <a:prstGeom prst="rect">
             <a:avLst/>
@@ -4122,7 +4167,7 @@
               </a:lnSpc>
             </a:pPr>
             <a:r>
-              <a:rPr sz="2000" b="0">
+              <a:rPr sz="1900" b="0">
                 <a:solidFill>
                   <a:srgbClr val="5C6470"/>
                 </a:solidFill>
@@ -4135,14 +4180,14 @@
       </p:sp>
       <p:sp>
         <p:nvSpPr>
-          <p:cNvPr id="25" name="Rounded Rectangle 24"/>
+          <p:cNvPr id="27" name="Rounded Rectangle 26"/>
           <p:cNvSpPr/>
           <p:nvPr/>
         </p:nvSpPr>
         <p:spPr>
           <a:xfrm>
-            <a:off x="7863840" y="3429000"/>
-            <a:ext cx="2514600" cy="1417320"/>
+            <a:off x="7680960" y="3200400"/>
+            <a:ext cx="2468880" cy="1463040"/>
           </a:xfrm>
           <a:prstGeom prst="roundRect">
             <a:avLst>
@@ -4183,14 +4228,14 @@
       </p:sp>
       <p:sp>
         <p:nvSpPr>
-          <p:cNvPr id="26" name="TextBox 25"/>
+          <p:cNvPr id="28" name="TextBox 27"/>
           <p:cNvSpPr txBox="1"/>
           <p:nvPr/>
         </p:nvSpPr>
         <p:spPr>
           <a:xfrm>
-            <a:off x="8083296" y="3611880"/>
-            <a:ext cx="2148840" cy="256032"/>
+            <a:off x="7882128" y="3364992"/>
+            <a:ext cx="2103120" cy="256032"/>
           </a:xfrm>
           <a:prstGeom prst="rect">
             <a:avLst/>
@@ -4222,14 +4267,14 @@
       </p:sp>
       <p:sp>
         <p:nvSpPr>
-          <p:cNvPr id="27" name="TextBox 26"/>
+          <p:cNvPr id="29" name="TextBox 28"/>
           <p:cNvSpPr txBox="1"/>
           <p:nvPr/>
         </p:nvSpPr>
         <p:spPr>
           <a:xfrm>
-            <a:off x="8083296" y="3867912"/>
-            <a:ext cx="2148840" cy="292608"/>
+            <a:off x="7882128" y="3621024"/>
+            <a:ext cx="2103120" cy="292608"/>
           </a:xfrm>
           <a:prstGeom prst="rect">
             <a:avLst/>
@@ -4248,27 +4293,27 @@
               </a:lnSpc>
             </a:pPr>
             <a:r>
-              <a:rPr sz="1450" b="1">
+              <a:rPr sz="1400" b="1">
                 <a:solidFill>
                   <a:srgbClr val="EDEBE4"/>
                 </a:solidFill>
                 <a:latin typeface="Segoe UI"/>
               </a:rPr>
-              <a:t>FastAPI on AWS ECS</a:t>
-            </a:r>
-          </a:p>
-        </p:txBody>
-      </p:sp>
-      <p:sp>
-        <p:nvSpPr>
-          <p:cNvPr id="28" name="TextBox 27"/>
+              <a:t>FastAPI · AWS ECS</a:t>
+            </a:r>
+          </a:p>
+        </p:txBody>
+      </p:sp>
+      <p:sp>
+        <p:nvSpPr>
+          <p:cNvPr id="30" name="TextBox 29"/>
           <p:cNvSpPr txBox="1"/>
           <p:nvPr/>
         </p:nvSpPr>
         <p:spPr>
           <a:xfrm>
-            <a:off x="8083296" y="4178808"/>
-            <a:ext cx="2130552" cy="640080"/>
+            <a:off x="7882128" y="3931920"/>
+            <a:ext cx="2121408" cy="685800"/>
           </a:xfrm>
           <a:prstGeom prst="rect">
             <a:avLst/>
@@ -4293,20 +4338,20 @@
                 </a:solidFill>
                 <a:latin typeface="Segoe UI"/>
               </a:rPr>
-              <a:t>C++ routing core, air-field builder, exposure model</a:t>
-            </a:r>
-          </a:p>
-        </p:txBody>
-      </p:sp>
-      <p:sp>
-        <p:nvSpPr>
-          <p:cNvPr id="29" name="Rounded Rectangle 28"/>
+              <a:t>C++ routing core, field builder, dose model</a:t>
+            </a:r>
+          </a:p>
+        </p:txBody>
+      </p:sp>
+      <p:sp>
+        <p:nvSpPr>
+          <p:cNvPr id="31" name="Rounded Rectangle 30"/>
           <p:cNvSpPr/>
           <p:nvPr/>
         </p:nvSpPr>
         <p:spPr>
           <a:xfrm>
-            <a:off x="1828800" y="5257800"/>
+            <a:off x="1828800" y="5074920"/>
             <a:ext cx="2542032" cy="365760"/>
           </a:xfrm>
           <a:prstGeom prst="roundRect">
@@ -4348,13 +4393,13 @@
       </p:sp>
       <p:sp>
         <p:nvSpPr>
-          <p:cNvPr id="30" name="TextBox 29"/>
+          <p:cNvPr id="32" name="TextBox 31"/>
           <p:cNvSpPr txBox="1"/>
           <p:nvPr/>
         </p:nvSpPr>
         <p:spPr>
           <a:xfrm>
-            <a:off x="1975104" y="5340096"/>
+            <a:off x="1975104" y="5157216"/>
             <a:ext cx="2542032" cy="274320"/>
           </a:xfrm>
           <a:prstGeom prst="rect">
@@ -4396,13 +4441,13 @@
       </p:sp>
       <p:sp>
         <p:nvSpPr>
-          <p:cNvPr id="31" name="Rounded Rectangle 30"/>
+          <p:cNvPr id="33" name="Rounded Rectangle 32"/>
           <p:cNvSpPr/>
           <p:nvPr/>
         </p:nvSpPr>
         <p:spPr>
           <a:xfrm>
-            <a:off x="4498848" y="5257800"/>
+            <a:off x="4489704" y="5074920"/>
             <a:ext cx="2317089" cy="365760"/>
           </a:xfrm>
           <a:prstGeom prst="roundRect">
@@ -4444,13 +4489,13 @@
       </p:sp>
       <p:sp>
         <p:nvSpPr>
-          <p:cNvPr id="32" name="TextBox 31"/>
+          <p:cNvPr id="34" name="TextBox 33"/>
           <p:cNvSpPr txBox="1"/>
           <p:nvPr/>
         </p:nvSpPr>
         <p:spPr>
           <a:xfrm>
-            <a:off x="4645152" y="5340096"/>
+            <a:off x="4636008" y="5157216"/>
             <a:ext cx="2317089" cy="274320"/>
           </a:xfrm>
           <a:prstGeom prst="rect">
@@ -4483,14 +4528,14 @@
       </p:sp>
       <p:sp>
         <p:nvSpPr>
-          <p:cNvPr id="33" name="Rounded Rectangle 32"/>
+          <p:cNvPr id="35" name="Rounded Rectangle 34"/>
           <p:cNvSpPr/>
           <p:nvPr/>
         </p:nvSpPr>
         <p:spPr>
           <a:xfrm>
-            <a:off x="6943953" y="5257800"/>
-            <a:ext cx="1867204" cy="365760"/>
+            <a:off x="6925665" y="5074920"/>
+            <a:ext cx="1117396" cy="365760"/>
           </a:xfrm>
           <a:prstGeom prst="roundRect">
             <a:avLst>
@@ -4531,14 +4576,14 @@
       </p:sp>
       <p:sp>
         <p:nvSpPr>
-          <p:cNvPr id="34" name="TextBox 33"/>
+          <p:cNvPr id="36" name="TextBox 35"/>
           <p:cNvSpPr txBox="1"/>
           <p:nvPr/>
         </p:nvSpPr>
         <p:spPr>
           <a:xfrm>
-            <a:off x="7090257" y="5340096"/>
-            <a:ext cx="1867204" cy="274320"/>
+            <a:off x="7071969" y="5157216"/>
+            <a:ext cx="1117396" cy="274320"/>
           </a:xfrm>
           <a:prstGeom prst="rect">
             <a:avLst/>
@@ -4563,21 +4608,21 @@
                 </a:solidFill>
                 <a:latin typeface="Segoe UI"/>
               </a:rPr>
-              <a:t>VIIRS fire detections</a:t>
-            </a:r>
-          </a:p>
-        </p:txBody>
-      </p:sp>
-      <p:sp>
-        <p:nvSpPr>
-          <p:cNvPr id="35" name="Rounded Rectangle 34"/>
+              <a:t>VIIRS fires</a:t>
+            </a:r>
+          </a:p>
+        </p:txBody>
+      </p:sp>
+      <p:sp>
+        <p:nvSpPr>
+          <p:cNvPr id="37" name="Rounded Rectangle 36"/>
           <p:cNvSpPr/>
           <p:nvPr/>
         </p:nvSpPr>
         <p:spPr>
           <a:xfrm>
-            <a:off x="8939173" y="5257800"/>
-            <a:ext cx="1717243" cy="365760"/>
+            <a:off x="8161933" y="5074920"/>
+            <a:ext cx="1942185" cy="365760"/>
           </a:xfrm>
           <a:prstGeom prst="roundRect">
             <a:avLst>
@@ -4618,14 +4663,14 @@
       </p:sp>
       <p:sp>
         <p:nvSpPr>
-          <p:cNvPr id="36" name="TextBox 35"/>
+          <p:cNvPr id="38" name="TextBox 37"/>
           <p:cNvSpPr txBox="1"/>
           <p:nvPr/>
         </p:nvSpPr>
         <p:spPr>
           <a:xfrm>
-            <a:off x="9085477" y="5340096"/>
-            <a:ext cx="1717243" cy="274320"/>
+            <a:off x="8308237" y="5157216"/>
+            <a:ext cx="1942185" cy="274320"/>
           </a:xfrm>
           <a:prstGeom prst="rect">
             <a:avLst/>
@@ -4644,27 +4689,36 @@
               </a:lnSpc>
             </a:pPr>
             <a:r>
+              <a:rPr sz="1150" b="1">
+                <a:solidFill>
+                  <a:srgbClr val="7FBF9A"/>
+                </a:solidFill>
+                <a:latin typeface="Segoe UI"/>
+              </a:rPr>
+              <a:t>1.07M</a:t>
+            </a:r>
+            <a:r>
               <a:rPr sz="1150" b="0">
                 <a:solidFill>
                   <a:srgbClr val="9AA0AA"/>
                 </a:solidFill>
                 <a:latin typeface="Segoe UI"/>
               </a:rPr>
-              <a:t>OpenStreetMap roads</a:t>
-            </a:r>
-          </a:p>
-        </p:txBody>
-      </p:sp>
-      <p:sp>
-        <p:nvSpPr>
-          <p:cNvPr id="37" name="Rounded Rectangle 36"/>
+              <a:t> road edges · OSM</a:t>
+            </a:r>
+          </a:p>
+        </p:txBody>
+      </p:sp>
+      <p:sp>
+        <p:nvSpPr>
+          <p:cNvPr id="39" name="Rounded Rectangle 38"/>
           <p:cNvSpPr/>
           <p:nvPr/>
         </p:nvSpPr>
         <p:spPr>
           <a:xfrm>
-            <a:off x="10784432" y="5257800"/>
-            <a:ext cx="1717243" cy="365760"/>
+            <a:off x="10222990" y="5074920"/>
+            <a:ext cx="1342339" cy="365760"/>
           </a:xfrm>
           <a:prstGeom prst="roundRect">
             <a:avLst>
@@ -4705,14 +4759,14 @@
       </p:sp>
       <p:sp>
         <p:nvSpPr>
-          <p:cNvPr id="38" name="TextBox 37"/>
+          <p:cNvPr id="40" name="TextBox 39"/>
           <p:cNvSpPr txBox="1"/>
           <p:nvPr/>
         </p:nvSpPr>
         <p:spPr>
           <a:xfrm>
-            <a:off x="10930736" y="5340096"/>
-            <a:ext cx="1717243" cy="274320"/>
+            <a:off x="10369294" y="5157216"/>
+            <a:ext cx="1342339" cy="274320"/>
           </a:xfrm>
           <a:prstGeom prst="rect">
             <a:avLst/>
@@ -4737,21 +4791,21 @@
                 </a:solidFill>
                 <a:latin typeface="Segoe UI"/>
               </a:rPr>
-              <a:t>TomTom live traffic</a:t>
-            </a:r>
-          </a:p>
-        </p:txBody>
-      </p:sp>
-      <p:sp>
-        <p:nvSpPr>
-          <p:cNvPr id="39" name="TextBox 38"/>
+              <a:t>TomTom traffic</a:t>
+            </a:r>
+          </a:p>
+        </p:txBody>
+      </p:sp>
+      <p:sp>
+        <p:nvSpPr>
+          <p:cNvPr id="41" name="TextBox 40"/>
           <p:cNvSpPr txBox="1"/>
           <p:nvPr/>
         </p:nvSpPr>
         <p:spPr>
           <a:xfrm>
-            <a:off x="1828800" y="6355080"/>
-            <a:ext cx="5486400" cy="274320"/>
+            <a:off x="1828800" y="5806440"/>
+            <a:ext cx="8229600" cy="365760"/>
           </a:xfrm>
           <a:prstGeom prst="rect">
             <a:avLst/>
@@ -4770,7 +4824,55 @@
               </a:lnSpc>
             </a:pPr>
             <a:r>
-              <a:rPr sz="1050" b="0">
+              <a:rPr sz="1200" b="0">
+                <a:solidFill>
+                  <a:srgbClr val="5C6470"/>
+                </a:solidFill>
+                <a:latin typeface="Segoe UI"/>
+              </a:rPr>
+              <a:t>Real numbers, today: </a:t>
+            </a:r>
+            <a:r>
+              <a:rPr sz="1200" b="0">
+                <a:solidFill>
+                  <a:srgbClr val="9AA0AA"/>
+                </a:solidFill>
+                <a:latin typeface="Segoe UI"/>
+              </a:rPr>
+              <a:t>24 routes scored in ~2.5 s incl. live traffic · field rebuilt every ~15 min</a:t>
+            </a:r>
+          </a:p>
+        </p:txBody>
+      </p:sp>
+      <p:sp>
+        <p:nvSpPr>
+          <p:cNvPr id="42" name="TextBox 41"/>
+          <p:cNvSpPr txBox="1"/>
+          <p:nvPr/>
+        </p:nvSpPr>
+        <p:spPr>
+          <a:xfrm>
+            <a:off x="1828800" y="6473952"/>
+            <a:ext cx="5486400" cy="274320"/>
+          </a:xfrm>
+          <a:prstGeom prst="rect">
+            <a:avLst/>
+          </a:prstGeom>
+          <a:noFill/>
+        </p:spPr>
+        <p:txBody>
+          <a:bodyPr wrap="square" anchor="t" lIns="0" rIns="0" tIns="0" bIns="0">
+            <a:spAutoFit/>
+          </a:bodyPr>
+          <a:lstStyle/>
+          <a:p>
+            <a:pPr algn="l">
+              <a:lnSpc>
+                <a:spcPct val="100000"/>
+              </a:lnSpc>
+            </a:pPr>
+            <a:r>
+              <a:rPr sz="1000" b="0">
                 <a:solidFill>
                   <a:srgbClr val="5C6470"/>
                 </a:solidFill>
@@ -4978,8 +5080,8 @@
         </p:nvSpPr>
         <p:spPr>
           <a:xfrm>
-            <a:off x="201168" y="5897880"/>
-            <a:ext cx="1143000" cy="731520"/>
+            <a:off x="201168" y="5806440"/>
+            <a:ext cx="1143000" cy="548640"/>
           </a:xfrm>
           <a:prstGeom prst="rect">
             <a:avLst/>
@@ -5006,15 +5108,6 @@
               </a:rPr>
               <a:t>App coming</a:t>
             </a:r>
-            <a:r>
-              <a:rPr sz="1050" b="1">
-                <a:solidFill>
-                  <a:srgbClr val="9AA0AA"/>
-                </a:solidFill>
-                <a:latin typeface="Segoe UI"/>
-              </a:rPr>
-              <a:t/>
-            </a:r>
           </a:p>
           <a:p>
             <a:pPr algn="l">
@@ -5042,7 +5135,7 @@
         </p:nvSpPr>
         <p:spPr>
           <a:xfrm>
-            <a:off x="201168" y="6400800"/>
+            <a:off x="201168" y="6382512"/>
             <a:ext cx="1188720" cy="384048"/>
           </a:xfrm>
           <a:prstGeom prst="rect">
@@ -5069,15 +5162,6 @@
                 <a:latin typeface="Segoe UI"/>
               </a:rPr>
               <a:t>Open Source</a:t>
-            </a:r>
-            <a:r>
-              <a:rPr sz="850" b="0">
-                <a:solidFill>
-                  <a:srgbClr val="5C6470"/>
-                </a:solidFill>
-                <a:latin typeface="Segoe UI"/>
-              </a:rPr>
-              <a:t/>
             </a:r>
           </a:p>
           <a:p>
@@ -5282,9 +5366,72 @@
           </a:p>
         </p:txBody>
       </p:sp>
-      <p:sp>
-        <p:nvSpPr>
-          <p:cNvPr id="12" name="TextBox 11"/>
+      <p:pic>
+        <p:nvPicPr>
+          <p:cNvPr id="12" name="Picture 11" descr="deckimg_motif.png"/>
+          <p:cNvPicPr>
+            <a:picLocks noChangeAspect="1"/>
+          </p:cNvPicPr>
+          <p:nvPr/>
+        </p:nvPicPr>
+        <p:blipFill>
+          <a:blip r:embed="rId2"/>
+          <a:stretch>
+            <a:fillRect/>
+          </a:stretch>
+        </p:blipFill>
+        <p:spPr>
+          <a:xfrm>
+            <a:off x="9646920" y="137160"/>
+            <a:ext cx="2468880" cy="2194560"/>
+          </a:xfrm>
+          <a:prstGeom prst="rect">
+            <a:avLst/>
+          </a:prstGeom>
+        </p:spPr>
+      </p:pic>
+      <p:sp>
+        <p:nvSpPr>
+          <p:cNvPr id="13" name="TextBox 12"/>
+          <p:cNvSpPr txBox="1"/>
+          <p:nvPr/>
+        </p:nvSpPr>
+        <p:spPr>
+          <a:xfrm>
+            <a:off x="9710928" y="566928"/>
+            <a:ext cx="1280160" cy="274320"/>
+          </a:xfrm>
+          <a:prstGeom prst="rect">
+            <a:avLst/>
+          </a:prstGeom>
+          <a:noFill/>
+        </p:spPr>
+        <p:txBody>
+          <a:bodyPr wrap="square" anchor="t" lIns="0" rIns="0" tIns="0" bIns="0">
+            <a:spAutoFit/>
+          </a:bodyPr>
+          <a:lstStyle/>
+          <a:p>
+            <a:pPr algn="r">
+              <a:lnSpc>
+                <a:spcPct val="100000"/>
+              </a:lnSpc>
+            </a:pPr>
+            <a:r>
+              <a:rPr sz="1000" b="0" spc="200">
+                <a:solidFill>
+                  <a:srgbClr val="5C6470"/>
+                </a:solidFill>
+                <a:latin typeface="Segoe UI"/>
+              </a:rPr>
+              <a:t>02 / 04</a:t>
+            </a:r>
+          </a:p>
+        </p:txBody>
+      </p:sp>
+      <p:sp>
+        <p:nvSpPr>
+          <p:cNvPr id="14" name="TextBox 13"/>
           <p:cNvSpPr txBox="1"/>
           <p:nvPr/>
         </p:nvSpPr>
@@ -5316,21 +5463,21 @@
                 </a:solidFill>
                 <a:latin typeface="Segoe UI"/>
               </a:rPr>
-              <a:t>02 · HOW A NUMBER IS BORN</a:t>
-            </a:r>
-          </a:p>
-        </p:txBody>
-      </p:sp>
-      <p:sp>
-        <p:nvSpPr>
-          <p:cNvPr id="13" name="TextBox 12"/>
+              <a:t>02 · THE FIELD ALGORITHM</a:t>
+            </a:r>
+          </a:p>
+        </p:txBody>
+      </p:sp>
+      <p:sp>
+        <p:nvSpPr>
+          <p:cNvPr id="15" name="TextBox 14"/>
           <p:cNvSpPr txBox="1"/>
           <p:nvPr/>
         </p:nvSpPr>
         <p:spPr>
           <a:xfrm>
-            <a:off x="1828800" y="960120"/>
-            <a:ext cx="8778240" cy="1554480"/>
+            <a:off x="1828800" y="914400"/>
+            <a:ext cx="7589520" cy="1554480"/>
           </a:xfrm>
           <a:prstGeom prst="rect">
             <a:avLst/>
@@ -5349,13 +5496,13 @@
               </a:lnSpc>
             </a:pPr>
             <a:r>
-              <a:rPr sz="3300" b="1">
+              <a:rPr sz="3200" b="1">
                 <a:solidFill>
                   <a:srgbClr val="EDEBE4"/>
                 </a:solidFill>
                 <a:latin typeface="Segoe UI"/>
               </a:rPr>
-              <a:t>From a station's readout</a:t>
+              <a:t>53 stations →</a:t>
             </a:r>
           </a:p>
           <a:p>
@@ -5365,27 +5512,27 @@
               </a:lnSpc>
             </a:pPr>
             <a:r>
-              <a:rPr sz="3300" b="1">
+              <a:rPr sz="3200" b="1">
                 <a:solidFill>
                   <a:srgbClr val="EDEBE4"/>
                 </a:solidFill>
                 <a:latin typeface="Segoe UI"/>
               </a:rPr>
-              <a:t>to the air at your feet</a:t>
-            </a:r>
-          </a:p>
-        </p:txBody>
-      </p:sp>
-      <p:sp>
-        <p:nvSpPr>
-          <p:cNvPr id="14" name="TextBox 13"/>
+              <a:t>14,155 living cells</a:t>
+            </a:r>
+          </a:p>
+        </p:txBody>
+      </p:sp>
+      <p:sp>
+        <p:nvSpPr>
+          <p:cNvPr id="16" name="TextBox 15"/>
           <p:cNvSpPr txBox="1"/>
           <p:nvPr/>
         </p:nvSpPr>
         <p:spPr>
           <a:xfrm>
-            <a:off x="1828800" y="2331720"/>
-            <a:ext cx="7680960" cy="822960"/>
+            <a:off x="1828800" y="2286000"/>
+            <a:ext cx="4572000" cy="685800"/>
           </a:xfrm>
           <a:prstGeom prst="rect">
             <a:avLst/>
@@ -5404,45 +5551,45 @@
               </a:lnSpc>
             </a:pPr>
             <a:r>
-              <a:rPr sz="1450" b="0">
+              <a:rPr sz="1300" b="0">
                 <a:solidFill>
                   <a:srgbClr val="9AA0AA"/>
                 </a:solidFill>
                 <a:latin typeface="Segoe UI"/>
               </a:rPr>
-              <a:t>Station readings + the satellite field are </a:t>
-            </a:r>
-            <a:r>
-              <a:rPr sz="1450" b="1">
+              <a:t>Stations and the CAMS satellite prior are </a:t>
+            </a:r>
+            <a:r>
+              <a:rPr sz="1300" b="1">
                 <a:solidFill>
                   <a:srgbClr val="EDEBE4"/>
                 </a:solidFill>
                 <a:latin typeface="Segoe UI"/>
               </a:rPr>
-              <a:t>interpolated onto ~14,000 hex cells</a:t>
-            </a:r>
-            <a:r>
-              <a:rPr sz="1450" b="0">
+              <a:t>distance-blended onto an H3 hex grid</a:t>
+            </a:r>
+            <a:r>
+              <a:rPr sz="1300" b="0">
                 <a:solidFill>
                   <a:srgbClr val="9AA0AA"/>
                 </a:solidFill>
                 <a:latin typeface="Segoe UI"/>
               </a:rPr>
-              <a:t> across Delhi/NCR — then run through India's official CPCB breakpoints, the same table every monitor uses.</a:t>
-            </a:r>
-          </a:p>
-        </p:txBody>
-      </p:sp>
-      <p:sp>
-        <p:nvSpPr>
-          <p:cNvPr id="15" name="Rounded Rectangle 14"/>
+              <a:t> — the air is computed per cell, not per district.</a:t>
+            </a:r>
+          </a:p>
+        </p:txBody>
+      </p:sp>
+      <p:sp>
+        <p:nvSpPr>
+          <p:cNvPr id="17" name="Rounded Rectangle 16"/>
           <p:cNvSpPr/>
           <p:nvPr/>
         </p:nvSpPr>
         <p:spPr>
           <a:xfrm>
-            <a:off x="1828800" y="3383280"/>
-            <a:ext cx="8869680" cy="1371600"/>
+            <a:off x="1828800" y="3108960"/>
+            <a:ext cx="4480560" cy="1600200"/>
           </a:xfrm>
           <a:prstGeom prst="roundRect">
             <a:avLst>
@@ -5483,14 +5630,14 @@
       </p:sp>
       <p:sp>
         <p:nvSpPr>
-          <p:cNvPr id="16" name="TextBox 15"/>
+          <p:cNvPr id="18" name="TextBox 17"/>
           <p:cNvSpPr txBox="1"/>
           <p:nvPr/>
         </p:nvSpPr>
         <p:spPr>
           <a:xfrm>
-            <a:off x="2148840" y="3611880"/>
-            <a:ext cx="1554480" cy="365760"/>
+            <a:off x="2057400" y="3273552"/>
+            <a:ext cx="4023360" cy="274320"/>
           </a:xfrm>
           <a:prstGeom prst="rect">
             <a:avLst/>
@@ -5509,27 +5656,27 @@
               </a:lnSpc>
             </a:pPr>
             <a:r>
-              <a:rPr sz="1900" b="1">
-                <a:solidFill>
-                  <a:srgbClr val="EDEBE4"/>
+              <a:rPr sz="900" b="1" spc="200">
+                <a:solidFill>
+                  <a:srgbClr val="5C6470"/>
                 </a:solidFill>
                 <a:latin typeface="Segoe UI"/>
               </a:rPr>
-              <a:t>PM2.5 + PM10</a:t>
-            </a:r>
-          </a:p>
-        </p:txBody>
-      </p:sp>
-      <p:sp>
-        <p:nvSpPr>
-          <p:cNvPr id="17" name="TextBox 16"/>
+              <a:t>THE TWO FORMULAS THAT RUN THE MAP</a:t>
+            </a:r>
+          </a:p>
+        </p:txBody>
+      </p:sp>
+      <p:sp>
+        <p:nvSpPr>
+          <p:cNvPr id="19" name="TextBox 18"/>
           <p:cNvSpPr txBox="1"/>
           <p:nvPr/>
         </p:nvSpPr>
         <p:spPr>
           <a:xfrm>
-            <a:off x="2148840" y="3977639"/>
-            <a:ext cx="1554480" cy="548640"/>
+            <a:off x="2057400" y="3566160"/>
+            <a:ext cx="4023360" cy="502920"/>
           </a:xfrm>
           <a:prstGeom prst="rect">
             <a:avLst/>
@@ -5544,47 +5691,56 @@
           <a:p>
             <a:pPr algn="l">
               <a:lnSpc>
-                <a:spcPct val="105000"/>
+                <a:spcPct val="150000"/>
               </a:lnSpc>
             </a:pPr>
             <a:r>
-              <a:rPr sz="1000" b="0">
-                <a:solidFill>
-                  <a:srgbClr val="5C6470"/>
-                </a:solidFill>
-                <a:latin typeface="Segoe UI"/>
-              </a:rPr>
-              <a:t>stations &amp; satellite,</a:t>
+              <a:rPr sz="1250" b="0">
+                <a:solidFill>
+                  <a:srgbClr val="7FBF9A"/>
+                </a:solidFill>
+                <a:latin typeface="Cascadia Code"/>
+              </a:rPr>
+              <a:t>pm(x) = Σ pmᵢ·dᵢ⁻² / Σ dᵢ⁻²  + CAMS prior</a:t>
+            </a:r>
+            <a:r>
+              <a:rPr sz="1250" b="0">
+                <a:solidFill>
+                  <a:srgbClr val="8FB8D9"/>
+                </a:solidFill>
+                <a:latin typeface="Cascadia Code"/>
+              </a:rPr>
+              <a:t/>
             </a:r>
           </a:p>
           <a:p>
             <a:pPr algn="l">
               <a:lnSpc>
-                <a:spcPct val="105000"/>
+                <a:spcPct val="150000"/>
               </a:lnSpc>
             </a:pPr>
             <a:r>
-              <a:rPr sz="1000" b="0">
-                <a:solidFill>
-                  <a:srgbClr val="5C6470"/>
-                </a:solidFill>
-                <a:latin typeface="Segoe UI"/>
-              </a:rPr>
-              <a:t>blended per cell</a:t>
-            </a:r>
-          </a:p>
-        </p:txBody>
-      </p:sp>
-      <p:sp>
-        <p:nvSpPr>
-          <p:cNvPr id="18" name="TextBox 17"/>
+              <a:rPr sz="1250" b="0">
+                <a:solidFill>
+                  <a:srgbClr val="8FB8D9"/>
+                </a:solidFill>
+                <a:latin typeface="Cascadia Code"/>
+              </a:rPr>
+              <a:t>AQI = (I_hi−I_lo)·(c−BP_lo)/(BP_hi−BP_lo) + I_lo</a:t>
+            </a:r>
+          </a:p>
+        </p:txBody>
+      </p:sp>
+      <p:sp>
+        <p:nvSpPr>
+          <p:cNvPr id="20" name="TextBox 19"/>
           <p:cNvSpPr txBox="1"/>
           <p:nvPr/>
         </p:nvSpPr>
         <p:spPr>
           <a:xfrm>
-            <a:off x="3703320" y="3794760"/>
-            <a:ext cx="411480" cy="548640"/>
+            <a:off x="2057400" y="4315968"/>
+            <a:ext cx="4069080" cy="365760"/>
           </a:xfrm>
           <a:prstGeom prst="rect">
             <a:avLst/>
@@ -5597,393 +5753,33 @@
           </a:bodyPr>
           <a:lstStyle/>
           <a:p>
-            <a:pPr algn="ctr">
+            <a:pPr algn="l">
               <a:lnSpc>
-                <a:spcPct val="100000"/>
+                <a:spcPct val="110000"/>
               </a:lnSpc>
             </a:pPr>
             <a:r>
-              <a:rPr sz="2400" b="0">
-                <a:solidFill>
-                  <a:srgbClr val="5C6470"/>
+              <a:rPr sz="1000" b="0">
+                <a:solidFill>
+                  <a:srgbClr val="9AA0AA"/>
                 </a:solidFill>
                 <a:latin typeface="Segoe UI"/>
               </a:rPr>
-              <a:t>→</a:t>
-            </a:r>
-          </a:p>
-        </p:txBody>
-      </p:sp>
-      <p:sp>
-        <p:nvSpPr>
-          <p:cNvPr id="19" name="TextBox 18"/>
-          <p:cNvSpPr txBox="1"/>
-          <p:nvPr/>
-        </p:nvSpPr>
-        <p:spPr>
-          <a:xfrm>
-            <a:off x="4114800" y="3611880"/>
-            <a:ext cx="1371600" cy="365760"/>
-          </a:xfrm>
-          <a:prstGeom prst="rect">
-            <a:avLst/>
-          </a:prstGeom>
-          <a:noFill/>
-        </p:spPr>
-        <p:txBody>
-          <a:bodyPr wrap="square" anchor="t" lIns="0" rIns="0" tIns="0" bIns="0">
-            <a:spAutoFit/>
-          </a:bodyPr>
-          <a:lstStyle/>
-          <a:p>
-            <a:pPr algn="l">
-              <a:lnSpc>
-                <a:spcPct val="100000"/>
-              </a:lnSpc>
-            </a:pPr>
-            <a:r>
-              <a:rPr sz="1900" b="1">
-                <a:solidFill>
-                  <a:srgbClr val="EDEBE4"/>
-                </a:solidFill>
-                <a:latin typeface="Segoe UI"/>
-              </a:rPr>
-              <a:t>14,155</a:t>
-            </a:r>
-          </a:p>
-        </p:txBody>
-      </p:sp>
-      <p:sp>
-        <p:nvSpPr>
-          <p:cNvPr id="20" name="TextBox 19"/>
-          <p:cNvSpPr txBox="1"/>
-          <p:nvPr/>
-        </p:nvSpPr>
-        <p:spPr>
-          <a:xfrm>
-            <a:off x="4114800" y="3977639"/>
-            <a:ext cx="1371600" cy="548640"/>
-          </a:xfrm>
-          <a:prstGeom prst="rect">
-            <a:avLst/>
-          </a:prstGeom>
-          <a:noFill/>
-        </p:spPr>
-        <p:txBody>
-          <a:bodyPr wrap="square" anchor="t" lIns="0" rIns="0" tIns="0" bIns="0">
-            <a:spAutoFit/>
-          </a:bodyPr>
-          <a:lstStyle/>
-          <a:p>
-            <a:pPr algn="l">
-              <a:lnSpc>
-                <a:spcPct val="105000"/>
-              </a:lnSpc>
-            </a:pPr>
-            <a:r>
-              <a:rPr sz="1000" b="0">
-                <a:solidFill>
-                  <a:srgbClr val="5C6470"/>
-                </a:solidFill>
-                <a:latin typeface="Segoe UI"/>
-              </a:rPr>
-              <a:t>hex cells, rebuilt</a:t>
-            </a:r>
-          </a:p>
-          <a:p>
-            <a:pPr algn="l">
-              <a:lnSpc>
-                <a:spcPct val="105000"/>
-              </a:lnSpc>
-            </a:pPr>
-            <a:r>
-              <a:rPr sz="1000" b="0">
-                <a:solidFill>
-                  <a:srgbClr val="5C6470"/>
-                </a:solidFill>
-                <a:latin typeface="Segoe UI"/>
-              </a:rPr>
-              <a:t>every ~15 min</a:t>
-            </a:r>
-          </a:p>
-        </p:txBody>
-      </p:sp>
-      <p:sp>
-        <p:nvSpPr>
-          <p:cNvPr id="21" name="TextBox 20"/>
-          <p:cNvSpPr txBox="1"/>
-          <p:nvPr/>
-        </p:nvSpPr>
-        <p:spPr>
-          <a:xfrm>
-            <a:off x="5486400" y="3794760"/>
-            <a:ext cx="411480" cy="548640"/>
-          </a:xfrm>
-          <a:prstGeom prst="rect">
-            <a:avLst/>
-          </a:prstGeom>
-          <a:noFill/>
-        </p:spPr>
-        <p:txBody>
-          <a:bodyPr wrap="square" anchor="t" lIns="0" rIns="0" tIns="0" bIns="0">
-            <a:spAutoFit/>
-          </a:bodyPr>
-          <a:lstStyle/>
-          <a:p>
-            <a:pPr algn="ctr">
-              <a:lnSpc>
-                <a:spcPct val="100000"/>
-              </a:lnSpc>
-            </a:pPr>
-            <a:r>
-              <a:rPr sz="2400" b="0">
-                <a:solidFill>
-                  <a:srgbClr val="5C6470"/>
-                </a:solidFill>
-                <a:latin typeface="Segoe UI"/>
-              </a:rPr>
-              <a:t>→</a:t>
-            </a:r>
-          </a:p>
-        </p:txBody>
-      </p:sp>
-      <p:sp>
-        <p:nvSpPr>
-          <p:cNvPr id="22" name="TextBox 21"/>
-          <p:cNvSpPr txBox="1"/>
-          <p:nvPr/>
-        </p:nvSpPr>
-        <p:spPr>
-          <a:xfrm>
-            <a:off x="5897880" y="3611880"/>
-            <a:ext cx="1463040" cy="365760"/>
-          </a:xfrm>
-          <a:prstGeom prst="rect">
-            <a:avLst/>
-          </a:prstGeom>
-          <a:noFill/>
-        </p:spPr>
-        <p:txBody>
-          <a:bodyPr wrap="square" anchor="t" lIns="0" rIns="0" tIns="0" bIns="0">
-            <a:spAutoFit/>
-          </a:bodyPr>
-          <a:lstStyle/>
-          <a:p>
-            <a:pPr algn="l">
-              <a:lnSpc>
-                <a:spcPct val="100000"/>
-              </a:lnSpc>
-            </a:pPr>
-            <a:r>
-              <a:rPr sz="1900" b="1">
-                <a:solidFill>
-                  <a:srgbClr val="EDEBE4"/>
-                </a:solidFill>
-                <a:latin typeface="Segoe UI"/>
-              </a:rPr>
-              <a:t>CPCB table</a:t>
-            </a:r>
-          </a:p>
-        </p:txBody>
-      </p:sp>
-      <p:sp>
-        <p:nvSpPr>
-          <p:cNvPr id="23" name="TextBox 22"/>
-          <p:cNvSpPr txBox="1"/>
-          <p:nvPr/>
-        </p:nvSpPr>
-        <p:spPr>
-          <a:xfrm>
-            <a:off x="5897880" y="3977639"/>
-            <a:ext cx="1463040" cy="548640"/>
-          </a:xfrm>
-          <a:prstGeom prst="rect">
-            <a:avLst/>
-          </a:prstGeom>
-          <a:noFill/>
-        </p:spPr>
-        <p:txBody>
-          <a:bodyPr wrap="square" anchor="t" lIns="0" rIns="0" tIns="0" bIns="0">
-            <a:spAutoFit/>
-          </a:bodyPr>
-          <a:lstStyle/>
-          <a:p>
-            <a:pPr algn="l">
-              <a:lnSpc>
-                <a:spcPct val="105000"/>
-              </a:lnSpc>
-            </a:pPr>
-            <a:r>
-              <a:rPr sz="1000" b="0">
-                <a:solidFill>
-                  <a:srgbClr val="5C6470"/>
-                </a:solidFill>
-                <a:latin typeface="Segoe UI"/>
-              </a:rPr>
-              <a:t>India's official</a:t>
-            </a:r>
-          </a:p>
-          <a:p>
-            <a:pPr algn="l">
-              <a:lnSpc>
-                <a:spcPct val="105000"/>
-              </a:lnSpc>
-            </a:pPr>
-            <a:r>
-              <a:rPr sz="1000" b="0">
-                <a:solidFill>
-                  <a:srgbClr val="5C6470"/>
-                </a:solidFill>
-                <a:latin typeface="Segoe UI"/>
-              </a:rPr>
-              <a:t>AQI breakpoints</a:t>
-            </a:r>
-          </a:p>
-        </p:txBody>
-      </p:sp>
-      <p:sp>
-        <p:nvSpPr>
-          <p:cNvPr id="24" name="TextBox 23"/>
-          <p:cNvSpPr txBox="1"/>
-          <p:nvPr/>
-        </p:nvSpPr>
-        <p:spPr>
-          <a:xfrm>
-            <a:off x="7360920" y="3794760"/>
-            <a:ext cx="365760" cy="548640"/>
-          </a:xfrm>
-          <a:prstGeom prst="rect">
-            <a:avLst/>
-          </a:prstGeom>
-          <a:noFill/>
-        </p:spPr>
-        <p:txBody>
-          <a:bodyPr wrap="square" anchor="t" lIns="0" rIns="0" tIns="0" bIns="0">
-            <a:spAutoFit/>
-          </a:bodyPr>
-          <a:lstStyle/>
-          <a:p>
-            <a:pPr algn="ctr">
-              <a:lnSpc>
-                <a:spcPct val="100000"/>
-              </a:lnSpc>
-            </a:pPr>
-            <a:r>
-              <a:rPr sz="2400" b="0">
-                <a:solidFill>
-                  <a:srgbClr val="5C6470"/>
-                </a:solidFill>
-                <a:latin typeface="Segoe UI"/>
-              </a:rPr>
-              <a:t>=</a:t>
-            </a:r>
-          </a:p>
-        </p:txBody>
-      </p:sp>
-      <p:sp>
-        <p:nvSpPr>
-          <p:cNvPr id="25" name="TextBox 24"/>
-          <p:cNvSpPr txBox="1"/>
-          <p:nvPr/>
-        </p:nvSpPr>
-        <p:spPr>
-          <a:xfrm>
-            <a:off x="7726680" y="3611880"/>
-            <a:ext cx="1737360" cy="365760"/>
-          </a:xfrm>
-          <a:prstGeom prst="rect">
-            <a:avLst/>
-          </a:prstGeom>
-          <a:noFill/>
-        </p:spPr>
-        <p:txBody>
-          <a:bodyPr wrap="square" anchor="t" lIns="0" rIns="0" tIns="0" bIns="0">
-            <a:spAutoFit/>
-          </a:bodyPr>
-          <a:lstStyle/>
-          <a:p>
-            <a:pPr algn="l">
-              <a:lnSpc>
-                <a:spcPct val="100000"/>
-              </a:lnSpc>
-            </a:pPr>
-            <a:r>
-              <a:rPr sz="1900" b="1">
-                <a:solidFill>
-                  <a:srgbClr val="D9A86C"/>
-                </a:solidFill>
-                <a:latin typeface="Segoe UI"/>
-              </a:rPr>
-              <a:t>AQI anywhere</a:t>
-            </a:r>
-          </a:p>
-        </p:txBody>
-      </p:sp>
-      <p:sp>
-        <p:nvSpPr>
-          <p:cNvPr id="26" name="TextBox 25"/>
-          <p:cNvSpPr txBox="1"/>
-          <p:nvPr/>
-        </p:nvSpPr>
-        <p:spPr>
-          <a:xfrm>
-            <a:off x="7726680" y="3977639"/>
-            <a:ext cx="1737360" cy="548640"/>
-          </a:xfrm>
-          <a:prstGeom prst="rect">
-            <a:avLst/>
-          </a:prstGeom>
-          <a:noFill/>
-        </p:spPr>
-        <p:txBody>
-          <a:bodyPr wrap="square" anchor="t" lIns="0" rIns="0" tIns="0" bIns="0">
-            <a:spAutoFit/>
-          </a:bodyPr>
-          <a:lstStyle/>
-          <a:p>
-            <a:pPr algn="l">
-              <a:lnSpc>
-                <a:spcPct val="105000"/>
-              </a:lnSpc>
-            </a:pPr>
-            <a:r>
-              <a:rPr sz="1000" b="0">
-                <a:solidFill>
-                  <a:srgbClr val="5C6470"/>
-                </a:solidFill>
-                <a:latin typeface="Segoe UI"/>
-              </a:rPr>
-              <a:t>your street — not</a:t>
-            </a:r>
-          </a:p>
-          <a:p>
-            <a:pPr algn="l">
-              <a:lnSpc>
-                <a:spcPct val="105000"/>
-              </a:lnSpc>
-            </a:pPr>
-            <a:r>
-              <a:rPr sz="1000" b="0">
-                <a:solidFill>
-                  <a:srgbClr val="5C6470"/>
-                </a:solidFill>
-                <a:latin typeface="Segoe UI"/>
-              </a:rPr>
-              <a:t>the nearest station's</a:t>
-            </a:r>
-          </a:p>
-        </p:txBody>
-      </p:sp>
-      <p:sp>
-        <p:nvSpPr>
-          <p:cNvPr id="27" name="Rounded Rectangle 26"/>
+              <a:t>IDW blend per cell · then India's official CPCB breakpoints — the same table the monitors use.</a:t>
+            </a:r>
+          </a:p>
+        </p:txBody>
+      </p:sp>
+      <p:sp>
+        <p:nvSpPr>
+          <p:cNvPr id="21" name="Rounded Rectangle 20"/>
           <p:cNvSpPr/>
           <p:nvPr/>
         </p:nvSpPr>
         <p:spPr>
           <a:xfrm>
-            <a:off x="1828800" y="5074920"/>
-            <a:ext cx="4297680" cy="1234440"/>
+            <a:off x="1828800" y="4937760"/>
+            <a:ext cx="4480560" cy="1325880"/>
           </a:xfrm>
           <a:prstGeom prst="roundRect">
             <a:avLst>
@@ -6024,13 +5820,13 @@
       </p:sp>
       <p:sp>
         <p:nvSpPr>
-          <p:cNvPr id="28" name="Rounded Rectangle 27"/>
+          <p:cNvPr id="22" name="Rounded Rectangle 21"/>
           <p:cNvSpPr/>
           <p:nvPr/>
         </p:nvSpPr>
         <p:spPr>
           <a:xfrm>
-            <a:off x="2084832" y="5312664"/>
+            <a:off x="2084832" y="5175504"/>
             <a:ext cx="100584" cy="100584"/>
           </a:xfrm>
           <a:prstGeom prst="roundRect">
@@ -6039,7 +5835,7 @@
             </a:avLst>
           </a:prstGeom>
           <a:solidFill>
-            <a:srgbClr val="7FBF9A"/>
+            <a:srgbClr val="D9A86C"/>
           </a:solidFill>
           <a:ln>
             <a:noFill/>
@@ -6070,14 +5866,14 @@
       </p:sp>
       <p:sp>
         <p:nvSpPr>
-          <p:cNvPr id="29" name="TextBox 28"/>
+          <p:cNvPr id="23" name="TextBox 22"/>
           <p:cNvSpPr txBox="1"/>
           <p:nvPr/>
         </p:nvSpPr>
         <p:spPr>
           <a:xfrm>
-            <a:off x="2084832" y="5532120"/>
-            <a:ext cx="3840480" cy="320040"/>
+            <a:off x="2084832" y="5394960"/>
+            <a:ext cx="4023360" cy="320040"/>
           </a:xfrm>
           <a:prstGeom prst="rect">
             <a:avLst/>
@@ -6096,27 +5892,27 @@
               </a:lnSpc>
             </a:pPr>
             <a:r>
-              <a:rPr sz="1450" b="1">
+              <a:rPr sz="1400" b="1">
                 <a:solidFill>
                   <a:srgbClr val="EDEBE4"/>
                 </a:solidFill>
                 <a:latin typeface="Segoe UI"/>
               </a:rPr>
-              <a:t>Freshness is stated</a:t>
-            </a:r>
-          </a:p>
-        </p:txBody>
-      </p:sp>
-      <p:sp>
-        <p:nvSpPr>
-          <p:cNvPr id="30" name="TextBox 29"/>
+              <a:t>Every cell carries its confidence</a:t>
+            </a:r>
+          </a:p>
+        </p:txBody>
+      </p:sp>
+      <p:sp>
+        <p:nvSpPr>
+          <p:cNvPr id="24" name="TextBox 23"/>
           <p:cNvSpPr txBox="1"/>
           <p:nvPr/>
         </p:nvSpPr>
         <p:spPr>
           <a:xfrm>
-            <a:off x="2084832" y="5879592"/>
-            <a:ext cx="3840480" cy="320040"/>
+            <a:off x="2084832" y="5724144"/>
+            <a:ext cx="4023360" cy="429768"/>
           </a:xfrm>
           <a:prstGeom prst="rect">
             <a:avLst/>
@@ -6135,31 +5931,31 @@
               </a:lnSpc>
             </a:pPr>
             <a:r>
-              <a:rPr sz="1150" b="0">
+              <a:rPr sz="1100" b="0">
                 <a:solidFill>
                   <a:srgbClr val="9AA0AA"/>
                 </a:solidFill>
                 <a:latin typeface="Segoe UI"/>
               </a:rPr>
-              <a:t>Every read says its age — “updated 3 min ago”. Stale is called stale.</a:t>
-            </a:r>
-          </a:p>
-        </p:txBody>
-      </p:sp>
-      <p:sp>
-        <p:nvSpPr>
-          <p:cNvPr id="31" name="Rounded Rectangle 30"/>
+              <a:t>Near a monitor → “monitor-grade”. Model-only → the app says “satellite estimate”. Stale is called stale, never hidden.</a:t>
+            </a:r>
+          </a:p>
+        </p:txBody>
+      </p:sp>
+      <p:sp>
+        <p:nvSpPr>
+          <p:cNvPr id="25" name="Rounded Rectangle 24"/>
           <p:cNvSpPr/>
           <p:nvPr/>
         </p:nvSpPr>
         <p:spPr>
           <a:xfrm>
-            <a:off x="6355080" y="5074920"/>
-            <a:ext cx="4343400" cy="1234440"/>
+            <a:off x="6492240" y="3063240"/>
+            <a:ext cx="5394960" cy="3310128"/>
           </a:xfrm>
           <a:prstGeom prst="roundRect">
             <a:avLst>
-              <a:gd name="adj" fmla="val 7000"/>
+              <a:gd name="adj" fmla="val 5000"/>
             </a:avLst>
           </a:prstGeom>
           <a:solidFill>
@@ -6194,62 +5990,40 @@
           </a:p>
         </p:txBody>
       </p:sp>
-      <p:sp>
-        <p:nvSpPr>
-          <p:cNvPr id="32" name="Rounded Rectangle 31"/>
-          <p:cNvSpPr/>
-          <p:nvPr/>
-        </p:nvSpPr>
-        <p:spPr>
-          <a:xfrm>
-            <a:off x="6611112" y="5312664"/>
-            <a:ext cx="100584" cy="100584"/>
-          </a:xfrm>
-          <a:prstGeom prst="roundRect">
-            <a:avLst>
-              <a:gd name="adj" fmla="val 50000"/>
-            </a:avLst>
-          </a:prstGeom>
-          <a:solidFill>
-            <a:srgbClr val="D9A86C"/>
-          </a:solidFill>
-          <a:ln>
-            <a:noFill/>
-          </a:ln>
-          <a:effectLst/>
-        </p:spPr>
-        <p:style>
-          <a:lnRef idx="1">
-            <a:schemeClr val="accent1"/>
-          </a:lnRef>
-          <a:fillRef idx="3">
-            <a:schemeClr val="accent1"/>
-          </a:fillRef>
-          <a:effectRef idx="2">
-            <a:schemeClr val="accent1"/>
-          </a:effectRef>
-          <a:fontRef idx="minor">
-            <a:schemeClr val="lt1"/>
-          </a:fontRef>
-        </p:style>
-        <p:txBody>
-          <a:bodyPr rtlCol="0" anchor="ctr"/>
-          <a:lstStyle/>
-          <a:p>
-            <a:pPr algn="ctr"/>
-          </a:p>
-        </p:txBody>
-      </p:sp>
-      <p:sp>
-        <p:nvSpPr>
-          <p:cNvPr id="33" name="TextBox 32"/>
+      <p:pic>
+        <p:nvPicPr>
+          <p:cNvPr id="26" name="Picture 25" descr="deckimg_field.png"/>
+          <p:cNvPicPr>
+            <a:picLocks noChangeAspect="1"/>
+          </p:cNvPicPr>
+          <p:nvPr/>
+        </p:nvPicPr>
+        <p:blipFill>
+          <a:blip r:embed="rId3"/>
+          <a:stretch>
+            <a:fillRect/>
+          </a:stretch>
+        </p:blipFill>
+        <p:spPr>
+          <a:xfrm>
+            <a:off x="7459843" y="3200400"/>
+            <a:ext cx="3459753" cy="2697480"/>
+          </a:xfrm>
+          <a:prstGeom prst="rect">
+            <a:avLst/>
+          </a:prstGeom>
+        </p:spPr>
+      </p:pic>
+      <p:sp>
+        <p:nvSpPr>
+          <p:cNvPr id="27" name="TextBox 26"/>
           <p:cNvSpPr txBox="1"/>
           <p:nvPr/>
         </p:nvSpPr>
         <p:spPr>
           <a:xfrm>
-            <a:off x="6611112" y="5532120"/>
-            <a:ext cx="3886200" cy="320040"/>
+            <a:off x="6675120" y="6053328"/>
+            <a:ext cx="4937760" cy="274320"/>
           </a:xfrm>
           <a:prstGeom prst="rect">
             <a:avLst/>
@@ -6268,65 +6042,35 @@
               </a:lnSpc>
             </a:pPr>
             <a:r>
-              <a:rPr sz="1450" b="1">
-                <a:solidFill>
-                  <a:srgbClr val="EDEBE4"/>
+              <a:rPr sz="1050" b="0">
+                <a:solidFill>
+                  <a:srgbClr val="5C6470"/>
                 </a:solidFill>
                 <a:latin typeface="Segoe UI"/>
               </a:rPr>
-              <a:t>Fallbacks are honest</a:t>
-            </a:r>
-          </a:p>
-        </p:txBody>
-      </p:sp>
-      <p:sp>
-        <p:nvSpPr>
-          <p:cNvPr id="34" name="TextBox 33"/>
+              <a:t>the live field, today — PM2.5 per cell · real range </a:t>
+            </a:r>
+            <a:r>
+              <a:rPr sz="1050" b="1">
+                <a:solidFill>
+                  <a:srgbClr val="9AA0AA"/>
+                </a:solidFill>
+                <a:latin typeface="Segoe UI"/>
+              </a:rPr>
+              <a:t>43–127 µg/m³</a:t>
+            </a:r>
+          </a:p>
+        </p:txBody>
+      </p:sp>
+      <p:sp>
+        <p:nvSpPr>
+          <p:cNvPr id="28" name="TextBox 27"/>
           <p:cNvSpPr txBox="1"/>
           <p:nvPr/>
         </p:nvSpPr>
         <p:spPr>
           <a:xfrm>
-            <a:off x="6611112" y="5879592"/>
-            <a:ext cx="3886200" cy="320040"/>
-          </a:xfrm>
-          <a:prstGeom prst="rect">
-            <a:avLst/>
-          </a:prstGeom>
-          <a:noFill/>
-        </p:spPr>
-        <p:txBody>
-          <a:bodyPr wrap="square" anchor="t" lIns="0" rIns="0" tIns="0" bIns="0">
-            <a:spAutoFit/>
-          </a:bodyPr>
-          <a:lstStyle/>
-          <a:p>
-            <a:pPr algn="l">
-              <a:lnSpc>
-                <a:spcPct val="112000"/>
-              </a:lnSpc>
-            </a:pPr>
-            <a:r>
-              <a:rPr sz="1150" b="0">
-                <a:solidFill>
-                  <a:srgbClr val="9AA0AA"/>
-                </a:solidFill>
-                <a:latin typeface="Segoe UI"/>
-              </a:rPr>
-              <a:t>Stations down? The app says “satellite estimate” instead of pretending.</a:t>
-            </a:r>
-          </a:p>
-        </p:txBody>
-      </p:sp>
-      <p:sp>
-        <p:nvSpPr>
-          <p:cNvPr id="35" name="TextBox 34"/>
-          <p:cNvSpPr txBox="1"/>
-          <p:nvPr/>
-        </p:nvSpPr>
-        <p:spPr>
-          <a:xfrm>
-            <a:off x="1828800" y="6355080"/>
+            <a:off x="1828800" y="6473952"/>
             <a:ext cx="5486400" cy="274320"/>
           </a:xfrm>
           <a:prstGeom prst="rect">
@@ -6346,7 +6090,7 @@
               </a:lnSpc>
             </a:pPr>
             <a:r>
-              <a:rPr sz="1050" b="0">
+              <a:rPr sz="1000" b="0">
                 <a:solidFill>
                   <a:srgbClr val="5C6470"/>
                 </a:solidFill>
@@ -6554,8 +6298,8 @@
         </p:nvSpPr>
         <p:spPr>
           <a:xfrm>
-            <a:off x="201168" y="5897880"/>
-            <a:ext cx="1143000" cy="731520"/>
+            <a:off x="201168" y="5806440"/>
+            <a:ext cx="1143000" cy="548640"/>
           </a:xfrm>
           <a:prstGeom prst="rect">
             <a:avLst/>
@@ -6582,15 +6326,6 @@
               </a:rPr>
               <a:t>App coming</a:t>
             </a:r>
-            <a:r>
-              <a:rPr sz="1050" b="1">
-                <a:solidFill>
-                  <a:srgbClr val="9AA0AA"/>
-                </a:solidFill>
-                <a:latin typeface="Segoe UI"/>
-              </a:rPr>
-              <a:t/>
-            </a:r>
           </a:p>
           <a:p>
             <a:pPr algn="l">
@@ -6618,7 +6353,7 @@
         </p:nvSpPr>
         <p:spPr>
           <a:xfrm>
-            <a:off x="201168" y="6400800"/>
+            <a:off x="201168" y="6382512"/>
             <a:ext cx="1188720" cy="384048"/>
           </a:xfrm>
           <a:prstGeom prst="rect">
@@ -6645,15 +6380,6 @@
                 <a:latin typeface="Segoe UI"/>
               </a:rPr>
               <a:t>Open Source</a:t>
-            </a:r>
-            <a:r>
-              <a:rPr sz="850" b="0">
-                <a:solidFill>
-                  <a:srgbClr val="5C6470"/>
-                </a:solidFill>
-                <a:latin typeface="Segoe UI"/>
-              </a:rPr>
-              <a:t/>
             </a:r>
           </a:p>
           <a:p>
@@ -6858,9 +6584,72 @@
           </a:p>
         </p:txBody>
       </p:sp>
-      <p:sp>
-        <p:nvSpPr>
-          <p:cNvPr id="12" name="TextBox 11"/>
+      <p:pic>
+        <p:nvPicPr>
+          <p:cNvPr id="12" name="Picture 11" descr="deckimg_motif.png"/>
+          <p:cNvPicPr>
+            <a:picLocks noChangeAspect="1"/>
+          </p:cNvPicPr>
+          <p:nvPr/>
+        </p:nvPicPr>
+        <p:blipFill>
+          <a:blip r:embed="rId2"/>
+          <a:stretch>
+            <a:fillRect/>
+          </a:stretch>
+        </p:blipFill>
+        <p:spPr>
+          <a:xfrm>
+            <a:off x="9646920" y="137160"/>
+            <a:ext cx="2468880" cy="2194560"/>
+          </a:xfrm>
+          <a:prstGeom prst="rect">
+            <a:avLst/>
+          </a:prstGeom>
+        </p:spPr>
+      </p:pic>
+      <p:sp>
+        <p:nvSpPr>
+          <p:cNvPr id="13" name="TextBox 12"/>
+          <p:cNvSpPr txBox="1"/>
+          <p:nvPr/>
+        </p:nvSpPr>
+        <p:spPr>
+          <a:xfrm>
+            <a:off x="9710928" y="566928"/>
+            <a:ext cx="1280160" cy="274320"/>
+          </a:xfrm>
+          <a:prstGeom prst="rect">
+            <a:avLst/>
+          </a:prstGeom>
+          <a:noFill/>
+        </p:spPr>
+        <p:txBody>
+          <a:bodyPr wrap="square" anchor="t" lIns="0" rIns="0" tIns="0" bIns="0">
+            <a:spAutoFit/>
+          </a:bodyPr>
+          <a:lstStyle/>
+          <a:p>
+            <a:pPr algn="r">
+              <a:lnSpc>
+                <a:spcPct val="100000"/>
+              </a:lnSpc>
+            </a:pPr>
+            <a:r>
+              <a:rPr sz="1000" b="0" spc="200">
+                <a:solidFill>
+                  <a:srgbClr val="5C6470"/>
+                </a:solidFill>
+                <a:latin typeface="Segoe UI"/>
+              </a:rPr>
+              <a:t>03 / 04</a:t>
+            </a:r>
+          </a:p>
+        </p:txBody>
+      </p:sp>
+      <p:sp>
+        <p:nvSpPr>
+          <p:cNvPr id="14" name="TextBox 13"/>
           <p:cNvSpPr txBox="1"/>
           <p:nvPr/>
         </p:nvSpPr>
@@ -6892,21 +6681,21 @@
                 </a:solidFill>
                 <a:latin typeface="Segoe UI"/>
               </a:rPr>
-              <a:t>03 · THE PUREST ROUTE</a:t>
-            </a:r>
-          </a:p>
-        </p:txBody>
-      </p:sp>
-      <p:sp>
-        <p:nvSpPr>
-          <p:cNvPr id="13" name="TextBox 12"/>
+              <a:t>03 · DOSE MATH</a:t>
+            </a:r>
+          </a:p>
+        </p:txBody>
+      </p:sp>
+      <p:sp>
+        <p:nvSpPr>
+          <p:cNvPr id="15" name="TextBox 14"/>
           <p:cNvSpPr txBox="1"/>
           <p:nvPr/>
         </p:nvSpPr>
         <p:spPr>
           <a:xfrm>
-            <a:off x="1828800" y="960120"/>
-            <a:ext cx="8778240" cy="1554480"/>
+            <a:off x="1828800" y="914400"/>
+            <a:ext cx="7589520" cy="1554480"/>
           </a:xfrm>
           <a:prstGeom prst="rect">
             <a:avLst/>
@@ -6925,13 +6714,13 @@
               </a:lnSpc>
             </a:pPr>
             <a:r>
-              <a:rPr sz="3300" b="1">
+              <a:rPr sz="3200" b="1">
                 <a:solidFill>
                   <a:srgbClr val="EDEBE4"/>
                 </a:solidFill>
                 <a:latin typeface="Segoe UI"/>
               </a:rPr>
-              <a:t>Routes priced in breath,</a:t>
+              <a:t>Priced in breath,</a:t>
             </a:r>
           </a:p>
           <a:p>
@@ -6941,7 +6730,7 @@
               </a:lnSpc>
             </a:pPr>
             <a:r>
-              <a:rPr sz="3300" b="1">
+              <a:rPr sz="3200" b="1">
                 <a:solidFill>
                   <a:srgbClr val="EDEBE4"/>
                 </a:solidFill>
@@ -6954,14 +6743,14 @@
       </p:sp>
       <p:sp>
         <p:nvSpPr>
-          <p:cNvPr id="14" name="TextBox 13"/>
+          <p:cNvPr id="16" name="TextBox 15"/>
           <p:cNvSpPr txBox="1"/>
           <p:nvPr/>
         </p:nvSpPr>
         <p:spPr>
           <a:xfrm>
-            <a:off x="1828800" y="2331720"/>
-            <a:ext cx="7680960" cy="822960"/>
+            <a:off x="1828800" y="2286000"/>
+            <a:ext cx="4572000" cy="685800"/>
           </a:xfrm>
           <a:prstGeom prst="rect">
             <a:avLst/>
@@ -6980,421 +6769,40 @@
               </a:lnSpc>
             </a:pPr>
             <a:r>
-              <a:rPr sz="1450" b="0">
+              <a:rPr sz="1300" b="0">
                 <a:solidFill>
                   <a:srgbClr val="9AA0AA"/>
                 </a:solidFill>
                 <a:latin typeface="Segoe UI"/>
               </a:rPr>
-              <a:t>Every road segment gets the field's PM2.5 painted onto it. Each candidate route integrates exposure along its length — </a:t>
-            </a:r>
-            <a:r>
-              <a:rPr sz="1450" b="1">
+              <a:t>Each road segment takes the field's PM2.5 at its path. The route's dose integrates it — </a:t>
+            </a:r>
+            <a:r>
+              <a:rPr sz="1300" b="1">
                 <a:solidFill>
                   <a:srgbClr val="EDEBE4"/>
                 </a:solidFill>
-                <a:latin typeface="Segoe UI"/>
-              </a:rPr>
-              <a:t>dose = ∫ PM2.5 × ventilation × time</a:t>
-            </a:r>
-            <a:r>
-              <a:rPr sz="1450" b="0">
-                <a:solidFill>
-                  <a:srgbClr val="9AA0AA"/>
-                </a:solidFill>
-                <a:latin typeface="Segoe UI"/>
-              </a:rPr>
-              <a:t> — so “best” means least inhaled, under your constraint.</a:t>
-            </a:r>
-          </a:p>
-        </p:txBody>
-      </p:sp>
-      <p:sp>
-        <p:nvSpPr>
-          <p:cNvPr id="15" name="TextBox 14"/>
-          <p:cNvSpPr txBox="1"/>
-          <p:nvPr/>
-        </p:nvSpPr>
-        <p:spPr>
-          <a:xfrm>
-            <a:off x="1828800" y="3538728"/>
-            <a:ext cx="1234440" cy="274320"/>
-          </a:xfrm>
-          <a:prstGeom prst="rect">
-            <a:avLst/>
-          </a:prstGeom>
-          <a:noFill/>
-        </p:spPr>
-        <p:txBody>
-          <a:bodyPr wrap="square" anchor="t" lIns="0" rIns="0" tIns="0" bIns="0">
-            <a:spAutoFit/>
-          </a:bodyPr>
-          <a:lstStyle/>
-          <a:p>
-            <a:pPr algn="r">
-              <a:lnSpc>
-                <a:spcPct val="100000"/>
-              </a:lnSpc>
-            </a:pPr>
-            <a:r>
-              <a:rPr sz="1250" b="0">
-                <a:solidFill>
-                  <a:srgbClr val="9AA0AA"/>
-                </a:solidFill>
-                <a:latin typeface="Segoe UI"/>
-              </a:rPr>
-              <a:t>fastest road</a:t>
-            </a:r>
-          </a:p>
-        </p:txBody>
-      </p:sp>
-      <p:sp>
-        <p:nvSpPr>
-          <p:cNvPr id="16" name="Rounded Rectangle 15"/>
+                <a:latin typeface="Cascadia Code"/>
+              </a:rPr>
+              <a:t>dose = Σ cᵢ · VE · tᵢ</a:t>
+            </a:r>
+          </a:p>
+        </p:txBody>
+      </p:sp>
+      <p:sp>
+        <p:nvSpPr>
+          <p:cNvPr id="17" name="Rounded Rectangle 16"/>
           <p:cNvSpPr/>
           <p:nvPr/>
         </p:nvSpPr>
         <p:spPr>
           <a:xfrm>
-            <a:off x="3246120" y="3557016"/>
-            <a:ext cx="5120640" cy="237744"/>
+            <a:off x="1828800" y="3108960"/>
+            <a:ext cx="4480560" cy="1737360"/>
           </a:xfrm>
           <a:prstGeom prst="roundRect">
             <a:avLst>
-              <a:gd name="adj" fmla="val 50000"/>
-            </a:avLst>
-          </a:prstGeom>
-          <a:solidFill>
-            <a:srgbClr val="C05F3A"/>
-          </a:solidFill>
-          <a:ln>
-            <a:noFill/>
-          </a:ln>
-          <a:effectLst/>
-        </p:spPr>
-        <p:style>
-          <a:lnRef idx="1">
-            <a:schemeClr val="accent1"/>
-          </a:lnRef>
-          <a:fillRef idx="3">
-            <a:schemeClr val="accent1"/>
-          </a:fillRef>
-          <a:effectRef idx="2">
-            <a:schemeClr val="accent1"/>
-          </a:effectRef>
-          <a:fontRef idx="minor">
-            <a:schemeClr val="lt1"/>
-          </a:fontRef>
-        </p:style>
-        <p:txBody>
-          <a:bodyPr rtlCol="0" anchor="ctr"/>
-          <a:lstStyle/>
-          <a:p>
-            <a:pPr algn="ctr"/>
-          </a:p>
-        </p:txBody>
-      </p:sp>
-      <p:sp>
-        <p:nvSpPr>
-          <p:cNvPr id="17" name="TextBox 16"/>
-          <p:cNvSpPr txBox="1"/>
-          <p:nvPr/>
-        </p:nvSpPr>
-        <p:spPr>
-          <a:xfrm>
-            <a:off x="8549640" y="3538728"/>
-            <a:ext cx="3108960" cy="274320"/>
-          </a:xfrm>
-          <a:prstGeom prst="rect">
-            <a:avLst/>
-          </a:prstGeom>
-          <a:noFill/>
-        </p:spPr>
-        <p:txBody>
-          <a:bodyPr wrap="square" anchor="t" lIns="0" rIns="0" tIns="0" bIns="0">
-            <a:spAutoFit/>
-          </a:bodyPr>
-          <a:lstStyle/>
-          <a:p>
-            <a:pPr algn="l">
-              <a:lnSpc>
-                <a:spcPct val="100000"/>
-              </a:lnSpc>
-            </a:pPr>
-            <a:r>
-              <a:rPr sz="1200" b="0">
-                <a:solidFill>
-                  <a:srgbClr val="9AA0AA"/>
-                </a:solidFill>
-                <a:latin typeface="Segoe UI"/>
-              </a:rPr>
-              <a:t>22 min · heavier air</a:t>
-            </a:r>
-          </a:p>
-        </p:txBody>
-      </p:sp>
-      <p:sp>
-        <p:nvSpPr>
-          <p:cNvPr id="18" name="TextBox 17"/>
-          <p:cNvSpPr txBox="1"/>
-          <p:nvPr/>
-        </p:nvSpPr>
-        <p:spPr>
-          <a:xfrm>
-            <a:off x="1828800" y="4014216"/>
-            <a:ext cx="1234440" cy="274320"/>
-          </a:xfrm>
-          <a:prstGeom prst="rect">
-            <a:avLst/>
-          </a:prstGeom>
-          <a:noFill/>
-        </p:spPr>
-        <p:txBody>
-          <a:bodyPr wrap="square" anchor="t" lIns="0" rIns="0" tIns="0" bIns="0">
-            <a:spAutoFit/>
-          </a:bodyPr>
-          <a:lstStyle/>
-          <a:p>
-            <a:pPr algn="r">
-              <a:lnSpc>
-                <a:spcPct val="100000"/>
-              </a:lnSpc>
-            </a:pPr>
-            <a:r>
-              <a:rPr sz="1250" b="0">
-                <a:solidFill>
-                  <a:srgbClr val="9AA0AA"/>
-                </a:solidFill>
-                <a:latin typeface="Segoe UI"/>
-              </a:rPr>
-              <a:t>ALive picks</a:t>
-            </a:r>
-          </a:p>
-        </p:txBody>
-      </p:sp>
-      <p:sp>
-        <p:nvSpPr>
-          <p:cNvPr id="19" name="Rounded Rectangle 18"/>
-          <p:cNvSpPr/>
-          <p:nvPr/>
-        </p:nvSpPr>
-        <p:spPr>
-          <a:xfrm>
-            <a:off x="3246120" y="4032504"/>
-            <a:ext cx="3840480" cy="237744"/>
-          </a:xfrm>
-          <a:prstGeom prst="roundRect">
-            <a:avLst>
-              <a:gd name="adj" fmla="val 50000"/>
-            </a:avLst>
-          </a:prstGeom>
-          <a:solidFill>
-            <a:srgbClr val="7FBF9A"/>
-          </a:solidFill>
-          <a:ln>
-            <a:noFill/>
-          </a:ln>
-          <a:effectLst/>
-        </p:spPr>
-        <p:style>
-          <a:lnRef idx="1">
-            <a:schemeClr val="accent1"/>
-          </a:lnRef>
-          <a:fillRef idx="3">
-            <a:schemeClr val="accent1"/>
-          </a:fillRef>
-          <a:effectRef idx="2">
-            <a:schemeClr val="accent1"/>
-          </a:effectRef>
-          <a:fontRef idx="minor">
-            <a:schemeClr val="lt1"/>
-          </a:fontRef>
-        </p:style>
-        <p:txBody>
-          <a:bodyPr rtlCol="0" anchor="ctr"/>
-          <a:lstStyle/>
-          <a:p>
-            <a:pPr algn="ctr"/>
-          </a:p>
-        </p:txBody>
-      </p:sp>
-      <p:sp>
-        <p:nvSpPr>
-          <p:cNvPr id="20" name="TextBox 19"/>
-          <p:cNvSpPr txBox="1"/>
-          <p:nvPr/>
-        </p:nvSpPr>
-        <p:spPr>
-          <a:xfrm>
-            <a:off x="7269480" y="4014216"/>
-            <a:ext cx="3108960" cy="274320"/>
-          </a:xfrm>
-          <a:prstGeom prst="rect">
-            <a:avLst/>
-          </a:prstGeom>
-          <a:noFill/>
-        </p:spPr>
-        <p:txBody>
-          <a:bodyPr wrap="square" anchor="t" lIns="0" rIns="0" tIns="0" bIns="0">
-            <a:spAutoFit/>
-          </a:bodyPr>
-          <a:lstStyle/>
-          <a:p>
-            <a:pPr algn="l">
-              <a:lnSpc>
-                <a:spcPct val="100000"/>
-              </a:lnSpc>
-            </a:pPr>
-            <a:r>
-              <a:rPr sz="1200" b="0">
-                <a:solidFill>
-                  <a:srgbClr val="9AA0AA"/>
-                </a:solidFill>
-                <a:latin typeface="Segoe UI"/>
-              </a:rPr>
-              <a:t>25 min · ≈40% less inhaled</a:t>
-            </a:r>
-          </a:p>
-        </p:txBody>
-      </p:sp>
-      <p:sp>
-        <p:nvSpPr>
-          <p:cNvPr id="21" name="TextBox 20"/>
-          <p:cNvSpPr txBox="1"/>
-          <p:nvPr/>
-        </p:nvSpPr>
-        <p:spPr>
-          <a:xfrm>
-            <a:off x="1828800" y="4489704"/>
-            <a:ext cx="1234440" cy="274320"/>
-          </a:xfrm>
-          <a:prstGeom prst="rect">
-            <a:avLst/>
-          </a:prstGeom>
-          <a:noFill/>
-        </p:spPr>
-        <p:txBody>
-          <a:bodyPr wrap="square" anchor="t" lIns="0" rIns="0" tIns="0" bIns="0">
-            <a:spAutoFit/>
-          </a:bodyPr>
-          <a:lstStyle/>
-          <a:p>
-            <a:pPr algn="r">
-              <a:lnSpc>
-                <a:spcPct val="100000"/>
-              </a:lnSpc>
-            </a:pPr>
-            <a:r>
-              <a:rPr sz="1250" b="0">
-                <a:solidFill>
-                  <a:srgbClr val="9AA0AA"/>
-                </a:solidFill>
-                <a:latin typeface="Segoe UI"/>
-              </a:rPr>
-              <a:t>a run</a:t>
-            </a:r>
-          </a:p>
-        </p:txBody>
-      </p:sp>
-      <p:sp>
-        <p:nvSpPr>
-          <p:cNvPr id="22" name="Rounded Rectangle 21"/>
-          <p:cNvSpPr/>
-          <p:nvPr/>
-        </p:nvSpPr>
-        <p:spPr>
-          <a:xfrm>
-            <a:off x="3246120" y="4507992"/>
-            <a:ext cx="3291840" cy="237744"/>
-          </a:xfrm>
-          <a:prstGeom prst="roundRect">
-            <a:avLst>
-              <a:gd name="adj" fmla="val 50000"/>
-            </a:avLst>
-          </a:prstGeom>
-          <a:solidFill>
-            <a:srgbClr val="8FB8D9"/>
-          </a:solidFill>
-          <a:ln>
-            <a:noFill/>
-          </a:ln>
-          <a:effectLst/>
-        </p:spPr>
-        <p:style>
-          <a:lnRef idx="1">
-            <a:schemeClr val="accent1"/>
-          </a:lnRef>
-          <a:fillRef idx="3">
-            <a:schemeClr val="accent1"/>
-          </a:fillRef>
-          <a:effectRef idx="2">
-            <a:schemeClr val="accent1"/>
-          </a:effectRef>
-          <a:fontRef idx="minor">
-            <a:schemeClr val="lt1"/>
-          </a:fontRef>
-        </p:style>
-        <p:txBody>
-          <a:bodyPr rtlCol="0" anchor="ctr"/>
-          <a:lstStyle/>
-          <a:p>
-            <a:pPr algn="ctr"/>
-          </a:p>
-        </p:txBody>
-      </p:sp>
-      <p:sp>
-        <p:nvSpPr>
-          <p:cNvPr id="23" name="TextBox 22"/>
-          <p:cNvSpPr txBox="1"/>
-          <p:nvPr/>
-        </p:nvSpPr>
-        <p:spPr>
-          <a:xfrm>
-            <a:off x="6720840" y="4489704"/>
-            <a:ext cx="3108960" cy="274320"/>
-          </a:xfrm>
-          <a:prstGeom prst="rect">
-            <a:avLst/>
-          </a:prstGeom>
-          <a:noFill/>
-        </p:spPr>
-        <p:txBody>
-          <a:bodyPr wrap="square" anchor="t" lIns="0" rIns="0" tIns="0" bIns="0">
-            <a:spAutoFit/>
-          </a:bodyPr>
-          <a:lstStyle/>
-          <a:p>
-            <a:pPr algn="l">
-              <a:lnSpc>
-                <a:spcPct val="100000"/>
-              </a:lnSpc>
-            </a:pPr>
-            <a:r>
-              <a:rPr sz="1200" b="0">
-                <a:solidFill>
-                  <a:srgbClr val="9AA0AA"/>
-                </a:solidFill>
-                <a:latin typeface="Segoe UI"/>
-              </a:rPr>
-              <a:t>on foot · dose-ranked first</a:t>
-            </a:r>
-          </a:p>
-        </p:txBody>
-      </p:sp>
-      <p:sp>
-        <p:nvSpPr>
-          <p:cNvPr id="24" name="Rounded Rectangle 23"/>
-          <p:cNvSpPr/>
-          <p:nvPr/>
-        </p:nvSpPr>
-        <p:spPr>
-          <a:xfrm>
-            <a:off x="1828800" y="5257800"/>
-            <a:ext cx="4297680" cy="1188720"/>
-          </a:xfrm>
-          <a:prstGeom prst="roundRect">
-            <a:avLst>
-              <a:gd name="adj" fmla="val 7000"/>
+              <a:gd name="adj" fmla="val 8000"/>
             </a:avLst>
           </a:prstGeom>
           <a:solidFill>
@@ -7431,60 +6839,14 @@
       </p:sp>
       <p:sp>
         <p:nvSpPr>
-          <p:cNvPr id="25" name="Rounded Rectangle 24"/>
-          <p:cNvSpPr/>
-          <p:nvPr/>
-        </p:nvSpPr>
-        <p:spPr>
-          <a:xfrm>
-            <a:off x="2084832" y="5495544"/>
-            <a:ext cx="100584" cy="100584"/>
-          </a:xfrm>
-          <a:prstGeom prst="roundRect">
-            <a:avLst>
-              <a:gd name="adj" fmla="val 50000"/>
-            </a:avLst>
-          </a:prstGeom>
-          <a:solidFill>
-            <a:srgbClr val="8FB8D9"/>
-          </a:solidFill>
-          <a:ln>
-            <a:noFill/>
-          </a:ln>
-          <a:effectLst/>
-        </p:spPr>
-        <p:style>
-          <a:lnRef idx="1">
-            <a:schemeClr val="accent1"/>
-          </a:lnRef>
-          <a:fillRef idx="3">
-            <a:schemeClr val="accent1"/>
-          </a:fillRef>
-          <a:effectRef idx="2">
-            <a:schemeClr val="accent1"/>
-          </a:effectRef>
-          <a:fontRef idx="minor">
-            <a:schemeClr val="lt1"/>
-          </a:fontRef>
-        </p:style>
-        <p:txBody>
-          <a:bodyPr rtlCol="0" anchor="ctr"/>
-          <a:lstStyle/>
-          <a:p>
-            <a:pPr algn="ctr"/>
-          </a:p>
-        </p:txBody>
-      </p:sp>
-      <p:sp>
-        <p:nvSpPr>
-          <p:cNvPr id="26" name="TextBox 25"/>
+          <p:cNvPr id="18" name="TextBox 17"/>
           <p:cNvSpPr txBox="1"/>
           <p:nvPr/>
         </p:nvSpPr>
         <p:spPr>
           <a:xfrm>
-            <a:off x="2084832" y="5715000"/>
-            <a:ext cx="3840480" cy="320040"/>
+            <a:off x="2057400" y="3255264"/>
+            <a:ext cx="4023360" cy="274320"/>
           </a:xfrm>
           <a:prstGeom prst="rect">
             <a:avLst/>
@@ -7503,27 +6865,27 @@
               </a:lnSpc>
             </a:pPr>
             <a:r>
-              <a:rPr sz="1450" b="1">
-                <a:solidFill>
-                  <a:srgbClr val="EDEBE4"/>
+              <a:rPr sz="900" b="1" spc="200">
+                <a:solidFill>
+                  <a:srgbClr val="5C6470"/>
                 </a:solidFill>
                 <a:latin typeface="Segoe UI"/>
               </a:rPr>
-              <a:t>Breathing counts too</a:t>
-            </a:r>
-          </a:p>
-        </p:txBody>
-      </p:sp>
-      <p:sp>
-        <p:nvSpPr>
-          <p:cNvPr id="27" name="TextBox 26"/>
+              <a:t>VENTILATION · VE (L AIR / MIN)</a:t>
+            </a:r>
+          </a:p>
+        </p:txBody>
+      </p:sp>
+      <p:sp>
+        <p:nvSpPr>
+          <p:cNvPr id="19" name="TextBox 18"/>
           <p:cNvSpPr txBox="1"/>
           <p:nvPr/>
         </p:nvSpPr>
         <p:spPr>
           <a:xfrm>
-            <a:off x="2084832" y="6062472"/>
-            <a:ext cx="3840480" cy="274320"/>
+            <a:off x="2057400" y="3529584"/>
+            <a:ext cx="4114800" cy="1188720"/>
           </a:xfrm>
           <a:prstGeom prst="rect">
             <a:avLst/>
@@ -7538,31 +6900,86 @@
           <a:p>
             <a:pPr algn="l">
               <a:lnSpc>
-                <a:spcPct val="112000"/>
+                <a:spcPct val="160000"/>
               </a:lnSpc>
             </a:pPr>
             <a:r>
-              <a:rPr sz="1150" b="0">
+              <a:rPr sz="1300" b="0">
+                <a:solidFill>
+                  <a:srgbClr val="7FBF9A"/>
+                </a:solidFill>
+                <a:latin typeface="Cascadia Code"/>
+              </a:rPr>
+              <a:t>sitting ~8   ·   walking ~14   ·   cycling ~26</a:t>
+            </a:r>
+          </a:p>
+          <a:p>
+            <a:pPr algn="l">
+              <a:lnSpc>
+                <a:spcPct val="160000"/>
+              </a:lnSpc>
+            </a:pPr>
+            <a:r>
+              <a:rPr sz="1300" b="0">
+                <a:solidFill>
+                  <a:srgbClr val="7FBF9A"/>
+                </a:solidFill>
+                <a:latin typeface="Cascadia Code"/>
+              </a:rPr>
+              <a:t>running ~45   ·   car cabin ≈ ÷2.5 filtered</a:t>
+            </a:r>
+          </a:p>
+        </p:txBody>
+      </p:sp>
+      <p:sp>
+        <p:nvSpPr>
+          <p:cNvPr id="20" name="TextBox 19"/>
+          <p:cNvSpPr txBox="1"/>
+          <p:nvPr/>
+        </p:nvSpPr>
+        <p:spPr>
+          <a:xfrm>
+            <a:off x="2057400" y="4517136"/>
+            <a:ext cx="4114800" cy="320040"/>
+          </a:xfrm>
+          <a:prstGeom prst="rect">
+            <a:avLst/>
+          </a:prstGeom>
+          <a:noFill/>
+        </p:spPr>
+        <p:txBody>
+          <a:bodyPr wrap="square" anchor="t" lIns="0" rIns="0" tIns="0" bIns="0">
+            <a:spAutoFit/>
+          </a:bodyPr>
+          <a:lstStyle/>
+          <a:p>
+            <a:pPr algn="l">
+              <a:lnSpc>
+                <a:spcPct val="110000"/>
+              </a:lnSpc>
+            </a:pPr>
+            <a:r>
+              <a:rPr sz="1050" b="0">
                 <a:solidFill>
                   <a:srgbClr val="9AA0AA"/>
                 </a:solidFill>
                 <a:latin typeface="Segoe UI"/>
               </a:rPr>
-              <a:t>A runner breathes ~3× a walker — the model knows the difference.</a:t>
-            </a:r>
-          </a:p>
-        </p:txBody>
-      </p:sp>
-      <p:sp>
-        <p:nvSpPr>
-          <p:cNvPr id="28" name="Rounded Rectangle 27"/>
+              <a:t>A runner breathes ~3× a walker — the mode changes the dose, not just the time.</a:t>
+            </a:r>
+          </a:p>
+        </p:txBody>
+      </p:sp>
+      <p:sp>
+        <p:nvSpPr>
+          <p:cNvPr id="21" name="Rounded Rectangle 20"/>
           <p:cNvSpPr/>
           <p:nvPr/>
         </p:nvSpPr>
         <p:spPr>
           <a:xfrm>
-            <a:off x="6355080" y="5257800"/>
-            <a:ext cx="4343400" cy="1188720"/>
+            <a:off x="1828800" y="5074920"/>
+            <a:ext cx="4480560" cy="1234440"/>
           </a:xfrm>
           <a:prstGeom prst="roundRect">
             <a:avLst>
@@ -7603,13 +7020,13 @@
       </p:sp>
       <p:sp>
         <p:nvSpPr>
-          <p:cNvPr id="29" name="Rounded Rectangle 28"/>
+          <p:cNvPr id="22" name="Rounded Rectangle 21"/>
           <p:cNvSpPr/>
           <p:nvPr/>
         </p:nvSpPr>
         <p:spPr>
           <a:xfrm>
-            <a:off x="6611112" y="5495544"/>
+            <a:off x="2084832" y="5312664"/>
             <a:ext cx="100584" cy="100584"/>
           </a:xfrm>
           <a:prstGeom prst="roundRect">
@@ -7618,7 +7035,7 @@
             </a:avLst>
           </a:prstGeom>
           <a:solidFill>
-            <a:srgbClr val="7FBF9A"/>
+            <a:srgbClr val="8FB8D9"/>
           </a:solidFill>
           <a:ln>
             <a:noFill/>
@@ -7649,14 +7066,14 @@
       </p:sp>
       <p:sp>
         <p:nvSpPr>
-          <p:cNvPr id="30" name="TextBox 29"/>
+          <p:cNvPr id="23" name="TextBox 22"/>
           <p:cNvSpPr txBox="1"/>
           <p:nvPr/>
         </p:nvSpPr>
         <p:spPr>
           <a:xfrm>
-            <a:off x="6611112" y="5715000"/>
-            <a:ext cx="3886200" cy="320040"/>
+            <a:off x="2084832" y="5532120"/>
+            <a:ext cx="4023360" cy="320040"/>
           </a:xfrm>
           <a:prstGeom prst="rect">
             <a:avLst/>
@@ -7675,27 +7092,27 @@
               </a:lnSpc>
             </a:pPr>
             <a:r>
-              <a:rPr sz="1450" b="1">
+              <a:rPr sz="1400" b="1">
                 <a:solidFill>
                   <a:srgbClr val="EDEBE4"/>
                 </a:solidFill>
                 <a:latin typeface="Segoe UI"/>
               </a:rPr>
-              <a:t>Receipts are real</a:t>
-            </a:r>
-          </a:p>
-        </p:txBody>
-      </p:sp>
-      <p:sp>
-        <p:nvSpPr>
-          <p:cNvPr id="31" name="TextBox 30"/>
+              <a:t>The engine behind it</a:t>
+            </a:r>
+          </a:p>
+        </p:txBody>
+      </p:sp>
+      <p:sp>
+        <p:nvSpPr>
+          <p:cNvPr id="24" name="TextBox 23"/>
           <p:cNvSpPr txBox="1"/>
           <p:nvPr/>
         </p:nvSpPr>
         <p:spPr>
           <a:xfrm>
-            <a:off x="6611112" y="6062472"/>
-            <a:ext cx="3886200" cy="274320"/>
+            <a:off x="2084832" y="5861304"/>
+            <a:ext cx="4023360" cy="338328"/>
           </a:xfrm>
           <a:prstGeom prst="rect">
             <a:avLst/>
@@ -7714,27 +7131,99 @@
               </a:lnSpc>
             </a:pPr>
             <a:r>
-              <a:rPr sz="1150" b="0">
+              <a:rPr sz="1100" b="0">
                 <a:solidFill>
                   <a:srgbClr val="9AA0AA"/>
                 </a:solidFill>
                 <a:latin typeface="Segoe UI"/>
               </a:rPr>
-              <a:t>The trip's dose comes from your GPS track × live air — measured, not assumed.</a:t>
-            </a:r>
-          </a:p>
-        </p:txBody>
-      </p:sp>
-      <p:sp>
-        <p:nvSpPr>
-          <p:cNvPr id="32" name="TextBox 31"/>
+              <a:t>C++ core over 1,070,459 OSM edges — candidate paths generated, each re-scored on the field, strictly-worse ones collapsed.</a:t>
+            </a:r>
+          </a:p>
+        </p:txBody>
+      </p:sp>
+      <p:sp>
+        <p:nvSpPr>
+          <p:cNvPr id="25" name="Rounded Rectangle 24"/>
+          <p:cNvSpPr/>
+          <p:nvPr/>
+        </p:nvSpPr>
+        <p:spPr>
+          <a:xfrm>
+            <a:off x="6492240" y="1188720"/>
+            <a:ext cx="5394960" cy="5138928"/>
+          </a:xfrm>
+          <a:prstGeom prst="roundRect">
+            <a:avLst>
+              <a:gd name="adj" fmla="val 4000"/>
+            </a:avLst>
+          </a:prstGeom>
+          <a:solidFill>
+            <a:srgbClr val="15181E"/>
+          </a:solidFill>
+          <a:ln w="9525">
+            <a:solidFill>
+              <a:srgbClr val="262B33"/>
+            </a:solidFill>
+          </a:ln>
+          <a:effectLst/>
+        </p:spPr>
+        <p:style>
+          <a:lnRef idx="1">
+            <a:schemeClr val="accent1"/>
+          </a:lnRef>
+          <a:fillRef idx="3">
+            <a:schemeClr val="accent1"/>
+          </a:fillRef>
+          <a:effectRef idx="2">
+            <a:schemeClr val="accent1"/>
+          </a:effectRef>
+          <a:fontRef idx="minor">
+            <a:schemeClr val="lt1"/>
+          </a:fontRef>
+        </p:style>
+        <p:txBody>
+          <a:bodyPr rtlCol="0" anchor="ctr"/>
+          <a:lstStyle/>
+          <a:p>
+            <a:pPr algn="ctr"/>
+          </a:p>
+        </p:txBody>
+      </p:sp>
+      <p:pic>
+        <p:nvPicPr>
+          <p:cNvPr id="26" name="Picture 25" descr="deckimg_routes.png"/>
+          <p:cNvPicPr>
+            <a:picLocks noChangeAspect="1"/>
+          </p:cNvPicPr>
+          <p:nvPr/>
+        </p:nvPicPr>
+        <p:blipFill>
+          <a:blip r:embed="rId3"/>
+          <a:stretch>
+            <a:fillRect/>
+          </a:stretch>
+        </p:blipFill>
+        <p:spPr>
+          <a:xfrm>
+            <a:off x="8175950" y="1353312"/>
+            <a:ext cx="2027539" cy="2880360"/>
+          </a:xfrm>
+          <a:prstGeom prst="rect">
+            <a:avLst/>
+          </a:prstGeom>
+        </p:spPr>
+      </p:pic>
+      <p:sp>
+        <p:nvSpPr>
+          <p:cNvPr id="27" name="TextBox 26"/>
           <p:cNvSpPr txBox="1"/>
           <p:nvPr/>
         </p:nvSpPr>
         <p:spPr>
           <a:xfrm>
-            <a:off x="1828800" y="6355080"/>
-            <a:ext cx="5486400" cy="274320"/>
+            <a:off x="6675120" y="4224528"/>
+            <a:ext cx="4937760" cy="274320"/>
           </a:xfrm>
           <a:prstGeom prst="rect">
             <a:avLst/>
@@ -7754,6 +7243,161 @@
             </a:pPr>
             <a:r>
               <a:rPr sz="1050" b="0">
+                <a:solidFill>
+                  <a:srgbClr val="5C6470"/>
+                </a:solidFill>
+                <a:latin typeface="Segoe UI"/>
+              </a:rPr>
+              <a:t>one real OD pair — green is the pick, </a:t>
+            </a:r>
+            <a:r>
+              <a:rPr sz="1050" b="1">
+                <a:solidFill>
+                  <a:srgbClr val="C05F3A"/>
+                </a:solidFill>
+                <a:latin typeface="Segoe UI"/>
+              </a:rPr>
+              <a:t>+81% dose on the main road</a:t>
+            </a:r>
+          </a:p>
+        </p:txBody>
+      </p:sp>
+      <p:sp>
+        <p:nvSpPr>
+          <p:cNvPr id="28" name="Rectangle 27"/>
+          <p:cNvSpPr/>
+          <p:nvPr/>
+        </p:nvSpPr>
+        <p:spPr>
+          <a:xfrm>
+            <a:off x="6675120" y="4526280"/>
+            <a:ext cx="5029200" cy="15240"/>
+          </a:xfrm>
+          <a:prstGeom prst="rect">
+            <a:avLst/>
+          </a:prstGeom>
+          <a:solidFill>
+            <a:srgbClr val="262B33"/>
+          </a:solidFill>
+          <a:ln>
+            <a:noFill/>
+          </a:ln>
+          <a:effectLst/>
+        </p:spPr>
+        <p:style>
+          <a:lnRef idx="1">
+            <a:schemeClr val="accent1"/>
+          </a:lnRef>
+          <a:fillRef idx="3">
+            <a:schemeClr val="accent1"/>
+          </a:fillRef>
+          <a:effectRef idx="2">
+            <a:schemeClr val="accent1"/>
+          </a:effectRef>
+          <a:fontRef idx="minor">
+            <a:schemeClr val="lt1"/>
+          </a:fontRef>
+        </p:style>
+        <p:txBody>
+          <a:bodyPr rtlCol="0" anchor="ctr"/>
+          <a:lstStyle/>
+          <a:p>
+            <a:pPr algn="ctr"/>
+          </a:p>
+        </p:txBody>
+      </p:sp>
+      <p:pic>
+        <p:nvPicPr>
+          <p:cNvPr id="29" name="Picture 28" descr="deckimg_dose.png"/>
+          <p:cNvPicPr>
+            <a:picLocks noChangeAspect="1"/>
+          </p:cNvPicPr>
+          <p:nvPr/>
+        </p:nvPicPr>
+        <p:blipFill>
+          <a:blip r:embed="rId4"/>
+          <a:stretch>
+            <a:fillRect/>
+          </a:stretch>
+        </p:blipFill>
+        <p:spPr>
+          <a:xfrm>
+            <a:off x="6962304" y="4681728"/>
+            <a:ext cx="4454831" cy="1417320"/>
+          </a:xfrm>
+          <a:prstGeom prst="rect">
+            <a:avLst/>
+          </a:prstGeom>
+        </p:spPr>
+      </p:pic>
+      <p:sp>
+        <p:nvSpPr>
+          <p:cNvPr id="30" name="TextBox 29"/>
+          <p:cNvSpPr txBox="1"/>
+          <p:nvPr/>
+        </p:nvSpPr>
+        <p:spPr>
+          <a:xfrm>
+            <a:off x="6675120" y="6089904"/>
+            <a:ext cx="4937760" cy="274320"/>
+          </a:xfrm>
+          <a:prstGeom prst="rect">
+            <a:avLst/>
+          </a:prstGeom>
+          <a:noFill/>
+        </p:spPr>
+        <p:txBody>
+          <a:bodyPr wrap="square" anchor="t" lIns="0" rIns="0" tIns="0" bIns="0">
+            <a:spAutoFit/>
+          </a:bodyPr>
+          <a:lstStyle/>
+          <a:p>
+            <a:pPr algn="l">
+              <a:lnSpc>
+                <a:spcPct val="100000"/>
+              </a:lnSpc>
+            </a:pPr>
+            <a:r>
+              <a:rPr sz="1050" b="0">
+                <a:solidFill>
+                  <a:srgbClr val="5C6470"/>
+                </a:solidFill>
+                <a:latin typeface="Segoe UI"/>
+              </a:rPr>
+              <a:t>the air along the chosen path — peak 86 µg/m³ at km 11</a:t>
+            </a:r>
+          </a:p>
+        </p:txBody>
+      </p:sp>
+      <p:sp>
+        <p:nvSpPr>
+          <p:cNvPr id="31" name="TextBox 30"/>
+          <p:cNvSpPr txBox="1"/>
+          <p:nvPr/>
+        </p:nvSpPr>
+        <p:spPr>
+          <a:xfrm>
+            <a:off x="1828800" y="6473952"/>
+            <a:ext cx="5486400" cy="274320"/>
+          </a:xfrm>
+          <a:prstGeom prst="rect">
+            <a:avLst/>
+          </a:prstGeom>
+          <a:noFill/>
+        </p:spPr>
+        <p:txBody>
+          <a:bodyPr wrap="square" anchor="t" lIns="0" rIns="0" tIns="0" bIns="0">
+            <a:spAutoFit/>
+          </a:bodyPr>
+          <a:lstStyle/>
+          <a:p>
+            <a:pPr algn="l">
+              <a:lnSpc>
+                <a:spcPct val="100000"/>
+              </a:lnSpc>
+            </a:pPr>
+            <a:r>
+              <a:rPr sz="1000" b="0">
                 <a:solidFill>
                   <a:srgbClr val="5C6470"/>
                 </a:solidFill>
@@ -7961,8 +7605,8 @@
         </p:nvSpPr>
         <p:spPr>
           <a:xfrm>
-            <a:off x="201168" y="5897880"/>
-            <a:ext cx="1143000" cy="731520"/>
+            <a:off x="201168" y="5806440"/>
+            <a:ext cx="1143000" cy="548640"/>
           </a:xfrm>
           <a:prstGeom prst="rect">
             <a:avLst/>
@@ -7989,15 +7633,6 @@
               </a:rPr>
               <a:t>App coming</a:t>
             </a:r>
-            <a:r>
-              <a:rPr sz="1050" b="1">
-                <a:solidFill>
-                  <a:srgbClr val="9AA0AA"/>
-                </a:solidFill>
-                <a:latin typeface="Segoe UI"/>
-              </a:rPr>
-              <a:t/>
-            </a:r>
           </a:p>
           <a:p>
             <a:pPr algn="l">
@@ -8025,7 +7660,7 @@
         </p:nvSpPr>
         <p:spPr>
           <a:xfrm>
-            <a:off x="201168" y="6400800"/>
+            <a:off x="201168" y="6382512"/>
             <a:ext cx="1188720" cy="384048"/>
           </a:xfrm>
           <a:prstGeom prst="rect">
@@ -8052,15 +7687,6 @@
                 <a:latin typeface="Segoe UI"/>
               </a:rPr>
               <a:t>Open Source</a:t>
-            </a:r>
-            <a:r>
-              <a:rPr sz="850" b="0">
-                <a:solidFill>
-                  <a:srgbClr val="5C6470"/>
-                </a:solidFill>
-                <a:latin typeface="Segoe UI"/>
-              </a:rPr>
-              <a:t/>
             </a:r>
           </a:p>
           <a:p>
@@ -8265,9 +7891,72 @@
           </a:p>
         </p:txBody>
       </p:sp>
-      <p:sp>
-        <p:nvSpPr>
-          <p:cNvPr id="12" name="TextBox 11"/>
+      <p:pic>
+        <p:nvPicPr>
+          <p:cNvPr id="12" name="Picture 11" descr="deckimg_motif.png"/>
+          <p:cNvPicPr>
+            <a:picLocks noChangeAspect="1"/>
+          </p:cNvPicPr>
+          <p:nvPr/>
+        </p:nvPicPr>
+        <p:blipFill>
+          <a:blip r:embed="rId2"/>
+          <a:stretch>
+            <a:fillRect/>
+          </a:stretch>
+        </p:blipFill>
+        <p:spPr>
+          <a:xfrm>
+            <a:off x="9646920" y="137160"/>
+            <a:ext cx="2468880" cy="2194560"/>
+          </a:xfrm>
+          <a:prstGeom prst="rect">
+            <a:avLst/>
+          </a:prstGeom>
+        </p:spPr>
+      </p:pic>
+      <p:sp>
+        <p:nvSpPr>
+          <p:cNvPr id="13" name="TextBox 12"/>
+          <p:cNvSpPr txBox="1"/>
+          <p:nvPr/>
+        </p:nvSpPr>
+        <p:spPr>
+          <a:xfrm>
+            <a:off x="9710928" y="566928"/>
+            <a:ext cx="1280160" cy="274320"/>
+          </a:xfrm>
+          <a:prstGeom prst="rect">
+            <a:avLst/>
+          </a:prstGeom>
+          <a:noFill/>
+        </p:spPr>
+        <p:txBody>
+          <a:bodyPr wrap="square" anchor="t" lIns="0" rIns="0" tIns="0" bIns="0">
+            <a:spAutoFit/>
+          </a:bodyPr>
+          <a:lstStyle/>
+          <a:p>
+            <a:pPr algn="r">
+              <a:lnSpc>
+                <a:spcPct val="100000"/>
+              </a:lnSpc>
+            </a:pPr>
+            <a:r>
+              <a:rPr sz="1000" b="0" spc="200">
+                <a:solidFill>
+                  <a:srgbClr val="5C6470"/>
+                </a:solidFill>
+                <a:latin typeface="Segoe UI"/>
+              </a:rPr>
+              <a:t>04 / 04</a:t>
+            </a:r>
+          </a:p>
+        </p:txBody>
+      </p:sp>
+      <p:sp>
+        <p:nvSpPr>
+          <p:cNvPr id="14" name="TextBox 13"/>
           <p:cNvSpPr txBox="1"/>
           <p:nvPr/>
         </p:nvSpPr>
@@ -8299,21 +7988,21 @@
                 </a:solidFill>
                 <a:latin typeface="Segoe UI"/>
               </a:rPr>
-              <a:t>04 · THE HARD PARTS</a:t>
-            </a:r>
-          </a:p>
-        </p:txBody>
-      </p:sp>
-      <p:sp>
-        <p:nvSpPr>
-          <p:cNvPr id="13" name="TextBox 12"/>
+              <a:t>04 · THE FIGHT — BROWSER LIMITS</a:t>
+            </a:r>
+          </a:p>
+        </p:txBody>
+      </p:sp>
+      <p:sp>
+        <p:nvSpPr>
+          <p:cNvPr id="15" name="TextBox 14"/>
           <p:cNvSpPr txBox="1"/>
           <p:nvPr/>
         </p:nvSpPr>
         <p:spPr>
           <a:xfrm>
-            <a:off x="1828800" y="960120"/>
-            <a:ext cx="8778240" cy="914400"/>
+            <a:off x="1828800" y="914400"/>
+            <a:ext cx="7589520" cy="914400"/>
           </a:xfrm>
           <a:prstGeom prst="rect">
             <a:avLst/>
@@ -8328,70 +8017,47 @@
           <a:p>
             <a:pPr algn="l">
               <a:lnSpc>
-                <a:spcPct val="100000"/>
+                <a:spcPct val="102000"/>
               </a:lnSpc>
             </a:pPr>
             <a:r>
-              <a:rPr sz="3300" b="1">
+              <a:rPr sz="3200" b="1">
                 <a:solidFill>
                   <a:srgbClr val="EDEBE4"/>
                 </a:solidFill>
                 <a:latin typeface="Segoe UI"/>
               </a:rPr>
-              <a:t>What made Delhi hard</a:t>
-            </a:r>
-          </a:p>
-        </p:txBody>
-      </p:sp>
-      <p:sp>
-        <p:nvSpPr>
-          <p:cNvPr id="14" name="TextBox 13"/>
-          <p:cNvSpPr txBox="1"/>
-          <p:nvPr/>
-        </p:nvSpPr>
-        <p:spPr>
-          <a:xfrm>
-            <a:off x="1828800" y="1691640"/>
-            <a:ext cx="7680960" cy="365760"/>
-          </a:xfrm>
-          <a:prstGeom prst="rect">
-            <a:avLst/>
-          </a:prstGeom>
-          <a:noFill/>
-        </p:spPr>
-        <p:txBody>
-          <a:bodyPr wrap="square" anchor="t" lIns="0" rIns="0" tIns="0" bIns="0">
-            <a:spAutoFit/>
-          </a:bodyPr>
-          <a:lstStyle/>
+              <a:t>Fitting a city in</a:t>
+            </a:r>
+          </a:p>
           <a:p>
             <a:pPr algn="l">
               <a:lnSpc>
-                <a:spcPct val="100000"/>
+                <a:spcPct val="102000"/>
               </a:lnSpc>
             </a:pPr>
             <a:r>
-              <a:rPr sz="1450" b="0">
-                <a:solidFill>
-                  <a:srgbClr val="9AA0AA"/>
+              <a:rPr sz="3200" b="1">
+                <a:solidFill>
+                  <a:srgbClr val="EDEBE4"/>
                 </a:solidFill>
                 <a:latin typeface="Segoe UI"/>
               </a:rPr>
-              <a:t>Three problems decided whether this was a toy or a product.</a:t>
-            </a:r>
-          </a:p>
-        </p:txBody>
-      </p:sp>
-      <p:sp>
-        <p:nvSpPr>
-          <p:cNvPr id="15" name="Rounded Rectangle 14"/>
+              <a:t>a browser tab</a:t>
+            </a:r>
+          </a:p>
+        </p:txBody>
+      </p:sp>
+      <p:sp>
+        <p:nvSpPr>
+          <p:cNvPr id="16" name="Rounded Rectangle 15"/>
           <p:cNvSpPr/>
           <p:nvPr/>
         </p:nvSpPr>
         <p:spPr>
           <a:xfrm>
             <a:off x="1828800" y="2377440"/>
-            <a:ext cx="2788920" cy="2286000"/>
+            <a:ext cx="4892040" cy="1481328"/>
           </a:xfrm>
           <a:prstGeom prst="roundRect">
             <a:avLst>
@@ -8432,7 +8098,7 @@
       </p:sp>
       <p:sp>
         <p:nvSpPr>
-          <p:cNvPr id="16" name="Rounded Rectangle 15"/>
+          <p:cNvPr id="17" name="Rounded Rectangle 16"/>
           <p:cNvSpPr/>
           <p:nvPr/>
         </p:nvSpPr>
@@ -8478,14 +8144,14 @@
       </p:sp>
       <p:sp>
         <p:nvSpPr>
-          <p:cNvPr id="17" name="TextBox 16"/>
+          <p:cNvPr id="18" name="TextBox 17"/>
           <p:cNvSpPr txBox="1"/>
           <p:nvPr/>
         </p:nvSpPr>
         <p:spPr>
           <a:xfrm>
             <a:off x="2084832" y="2834640"/>
-            <a:ext cx="2331720" cy="320040"/>
+            <a:ext cx="4434840" cy="320040"/>
           </a:xfrm>
           <a:prstGeom prst="rect">
             <a:avLst/>
@@ -8504,27 +8170,27 @@
               </a:lnSpc>
             </a:pPr>
             <a:r>
-              <a:rPr sz="1450" b="1">
+              <a:rPr sz="1400" b="1">
                 <a:solidFill>
                   <a:srgbClr val="EDEBE4"/>
                 </a:solidFill>
                 <a:latin typeface="Segoe UI"/>
               </a:rPr>
-              <a:t>A grid is not a street</a:t>
-            </a:r>
-          </a:p>
-        </p:txBody>
-      </p:sp>
-      <p:sp>
-        <p:nvSpPr>
-          <p:cNvPr id="18" name="TextBox 17"/>
+              <a:t>No WebGL? No pretending.</a:t>
+            </a:r>
+          </a:p>
+        </p:txBody>
+      </p:sp>
+      <p:sp>
+        <p:nvSpPr>
+          <p:cNvPr id="19" name="TextBox 18"/>
           <p:cNvSpPr txBox="1"/>
           <p:nvPr/>
         </p:nvSpPr>
         <p:spPr>
           <a:xfrm>
-            <a:off x="2084832" y="3182112"/>
-            <a:ext cx="2331720" cy="1371600"/>
+            <a:off x="2084832" y="3163824"/>
+            <a:ext cx="4434840" cy="585216"/>
           </a:xfrm>
           <a:prstGeom prst="rect">
             <a:avLst/>
@@ -8543,27 +8209,27 @@
               </a:lnSpc>
             </a:pPr>
             <a:r>
-              <a:rPr sz="1150" b="0">
+              <a:rPr sz="1100" b="0">
                 <a:solidFill>
                   <a:srgbClr val="9AA0AA"/>
                 </a:solidFill>
                 <a:latin typeface="Segoe UI"/>
               </a:rPr>
-              <a:t>Satellite cells are ~1 km². We interpolate stations + model onto street-level hexes so the map reads per-road, not per-district.</a:t>
-            </a:r>
-          </a:p>
-        </p:txBody>
-      </p:sp>
-      <p:sp>
-        <p:nvSpPr>
-          <p:cNvPr id="19" name="Rounded Rectangle 18"/>
+              <a:t>Phones that can't do 3D get an honest raster map — flat, labelled, still real. We never fake tilt.</a:t>
+            </a:r>
+          </a:p>
+        </p:txBody>
+      </p:sp>
+      <p:sp>
+        <p:nvSpPr>
+          <p:cNvPr id="20" name="Rounded Rectangle 19"/>
           <p:cNvSpPr/>
           <p:nvPr/>
         </p:nvSpPr>
         <p:spPr>
           <a:xfrm>
-            <a:off x="4873752" y="2377440"/>
-            <a:ext cx="2788920" cy="2286000"/>
+            <a:off x="6995160" y="2377440"/>
+            <a:ext cx="4892040" cy="1481328"/>
           </a:xfrm>
           <a:prstGeom prst="roundRect">
             <a:avLst>
@@ -8604,13 +8270,13 @@
       </p:sp>
       <p:sp>
         <p:nvSpPr>
-          <p:cNvPr id="20" name="Rounded Rectangle 19"/>
+          <p:cNvPr id="21" name="Rounded Rectangle 20"/>
           <p:cNvSpPr/>
           <p:nvPr/>
         </p:nvSpPr>
         <p:spPr>
           <a:xfrm>
-            <a:off x="5129784" y="2615184"/>
+            <a:off x="7251192" y="2615184"/>
             <a:ext cx="100584" cy="100584"/>
           </a:xfrm>
           <a:prstGeom prst="roundRect">
@@ -8619,7 +8285,7 @@
             </a:avLst>
           </a:prstGeom>
           <a:solidFill>
-            <a:srgbClr val="C05F3A"/>
+            <a:srgbClr val="7FBF9A"/>
           </a:solidFill>
           <a:ln>
             <a:noFill/>
@@ -8650,14 +8316,14 @@
       </p:sp>
       <p:sp>
         <p:nvSpPr>
-          <p:cNvPr id="21" name="TextBox 20"/>
+          <p:cNvPr id="22" name="TextBox 21"/>
           <p:cNvSpPr txBox="1"/>
           <p:nvPr/>
         </p:nvSpPr>
         <p:spPr>
           <a:xfrm>
-            <a:off x="5129784" y="2834640"/>
-            <a:ext cx="2331720" cy="320040"/>
+            <a:off x="7251192" y="2834640"/>
+            <a:ext cx="4434840" cy="320040"/>
           </a:xfrm>
           <a:prstGeom prst="rect">
             <a:avLst/>
@@ -8676,27 +8342,27 @@
               </a:lnSpc>
             </a:pPr>
             <a:r>
-              <a:rPr sz="1450" b="1">
+              <a:rPr sz="1400" b="1">
                 <a:solidFill>
                   <a:srgbClr val="EDEBE4"/>
                 </a:solidFill>
                 <a:latin typeface="Segoe UI"/>
               </a:rPr>
-              <a:t>Feeds die mid-demo</a:t>
-            </a:r>
-          </a:p>
-        </p:txBody>
-      </p:sp>
-      <p:sp>
-        <p:nvSpPr>
-          <p:cNvPr id="22" name="TextBox 21"/>
+              <a:t>GPS lies politely.</a:t>
+            </a:r>
+          </a:p>
+        </p:txBody>
+      </p:sp>
+      <p:sp>
+        <p:nvSpPr>
+          <p:cNvPr id="23" name="TextBox 22"/>
           <p:cNvSpPr txBox="1"/>
           <p:nvPr/>
         </p:nvSpPr>
         <p:spPr>
           <a:xfrm>
-            <a:off x="5129784" y="3182112"/>
-            <a:ext cx="2331720" cy="1371600"/>
+            <a:off x="7251192" y="3163824"/>
+            <a:ext cx="4434840" cy="585216"/>
           </a:xfrm>
           <a:prstGeom prst="rect">
             <a:avLst/>
@@ -8715,27 +8381,27 @@
               </a:lnSpc>
             </a:pPr>
             <a:r>
-              <a:rPr sz="1150" b="0">
+              <a:rPr sz="1100" b="0">
                 <a:solidFill>
                   <a:srgbClr val="9AA0AA"/>
                 </a:solidFill>
                 <a:latin typeface="Segoe UI"/>
               </a:rPr>
-              <a:t>Station APIs drop keys and go dark. The app degrades honestly — satellite mode, labelled — instead of freezing or faking.</a:t>
-            </a:r>
-          </a:p>
-        </p:txBody>
-      </p:sp>
-      <p:sp>
-        <p:nvSpPr>
-          <p:cNvPr id="23" name="Rounded Rectangle 22"/>
+              <a:t>±50 m wobble near the finish could fake “done” — arrival must hold 4 s. Closed-tab restores re-probe, not stale fixes.</a:t>
+            </a:r>
+          </a:p>
+        </p:txBody>
+      </p:sp>
+      <p:sp>
+        <p:nvSpPr>
+          <p:cNvPr id="24" name="Rounded Rectangle 23"/>
           <p:cNvSpPr/>
           <p:nvPr/>
         </p:nvSpPr>
         <p:spPr>
           <a:xfrm>
-            <a:off x="7918704" y="2377440"/>
-            <a:ext cx="2788920" cy="2286000"/>
+            <a:off x="1828800" y="4133088"/>
+            <a:ext cx="4892040" cy="1481328"/>
           </a:xfrm>
           <a:prstGeom prst="roundRect">
             <a:avLst>
@@ -8776,13 +8442,13 @@
       </p:sp>
       <p:sp>
         <p:nvSpPr>
-          <p:cNvPr id="24" name="Rounded Rectangle 23"/>
+          <p:cNvPr id="25" name="Rounded Rectangle 24"/>
           <p:cNvSpPr/>
           <p:nvPr/>
         </p:nvSpPr>
         <p:spPr>
           <a:xfrm>
-            <a:off x="8174736" y="2615184"/>
+            <a:off x="2084832" y="4370832"/>
             <a:ext cx="100584" cy="100584"/>
           </a:xfrm>
           <a:prstGeom prst="roundRect">
@@ -8791,7 +8457,7 @@
             </a:avLst>
           </a:prstGeom>
           <a:solidFill>
-            <a:srgbClr val="7FBF9A"/>
+            <a:srgbClr val="8FB8D9"/>
           </a:solidFill>
           <a:ln>
             <a:noFill/>
@@ -8822,14 +8488,14 @@
       </p:sp>
       <p:sp>
         <p:nvSpPr>
-          <p:cNvPr id="25" name="TextBox 24"/>
+          <p:cNvPr id="26" name="TextBox 25"/>
           <p:cNvSpPr txBox="1"/>
           <p:nvPr/>
         </p:nvSpPr>
         <p:spPr>
           <a:xfrm>
-            <a:off x="8174736" y="2834640"/>
-            <a:ext cx="2331720" cy="320040"/>
+            <a:off x="2084832" y="4590288"/>
+            <a:ext cx="4434840" cy="320040"/>
           </a:xfrm>
           <a:prstGeom prst="rect">
             <a:avLst/>
@@ -8848,27 +8514,27 @@
               </a:lnSpc>
             </a:pPr>
             <a:r>
-              <a:rPr sz="1450" b="1">
+              <a:rPr sz="1400" b="1">
                 <a:solidFill>
                   <a:srgbClr val="EDEBE4"/>
                 </a:solidFill>
                 <a:latin typeface="Segoe UI"/>
               </a:rPr>
-              <a:t>Privacy vs. proof</a:t>
-            </a:r>
-          </a:p>
-        </p:txBody>
-      </p:sp>
-      <p:sp>
-        <p:nvSpPr>
-          <p:cNvPr id="26" name="TextBox 25"/>
+              <a:t>14k cells ≠ 14k nodes.</a:t>
+            </a:r>
+          </a:p>
+        </p:txBody>
+      </p:sp>
+      <p:sp>
+        <p:nvSpPr>
+          <p:cNvPr id="27" name="TextBox 26"/>
           <p:cNvSpPr txBox="1"/>
           <p:nvPr/>
         </p:nvSpPr>
         <p:spPr>
           <a:xfrm>
-            <a:off x="8174736" y="3182112"/>
-            <a:ext cx="2331720" cy="1371600"/>
+            <a:off x="2084832" y="4919472"/>
+            <a:ext cx="4434840" cy="585216"/>
           </a:xfrm>
           <a:prstGeom prst="rect">
             <a:avLst/>
@@ -8887,66 +8553,121 @@
               </a:lnSpc>
             </a:pPr>
             <a:r>
-              <a:rPr sz="1150" b="0">
+              <a:rPr sz="1100" b="0">
                 <a:solidFill>
                   <a:srgbClr val="9AA0AA"/>
                 </a:solidFill>
                 <a:latin typeface="Segoe UI"/>
               </a:rPr>
-              <a:t>Dose needs your track; tracking people is creepy. So the GPS trail stays on the phone — only anonymous counters leave.</a:t>
-            </a:r>
-          </a:p>
-        </p:txBody>
-      </p:sp>
-      <p:sp>
-        <p:nvSpPr>
-          <p:cNvPr id="27" name="TextBox 26"/>
+              <a:t>The field paints as one tinted layer over the vector basemap; route lines re-assert after every style reload.</a:t>
+            </a:r>
+          </a:p>
+        </p:txBody>
+      </p:sp>
+      <p:sp>
+        <p:nvSpPr>
+          <p:cNvPr id="28" name="Rounded Rectangle 27"/>
+          <p:cNvSpPr/>
+          <p:nvPr/>
+        </p:nvSpPr>
+        <p:spPr>
+          <a:xfrm>
+            <a:off x="6995160" y="4133088"/>
+            <a:ext cx="4892040" cy="1481328"/>
+          </a:xfrm>
+          <a:prstGeom prst="roundRect">
+            <a:avLst>
+              <a:gd name="adj" fmla="val 7000"/>
+            </a:avLst>
+          </a:prstGeom>
+          <a:solidFill>
+            <a:srgbClr val="15181E"/>
+          </a:solidFill>
+          <a:ln w="9525">
+            <a:solidFill>
+              <a:srgbClr val="262B33"/>
+            </a:solidFill>
+          </a:ln>
+          <a:effectLst/>
+        </p:spPr>
+        <p:style>
+          <a:lnRef idx="1">
+            <a:schemeClr val="accent1"/>
+          </a:lnRef>
+          <a:fillRef idx="3">
+            <a:schemeClr val="accent1"/>
+          </a:fillRef>
+          <a:effectRef idx="2">
+            <a:schemeClr val="accent1"/>
+          </a:effectRef>
+          <a:fontRef idx="minor">
+            <a:schemeClr val="lt1"/>
+          </a:fontRef>
+        </p:style>
+        <p:txBody>
+          <a:bodyPr rtlCol="0" anchor="ctr"/>
+          <a:lstStyle/>
+          <a:p>
+            <a:pPr algn="ctr"/>
+          </a:p>
+        </p:txBody>
+      </p:sp>
+      <p:sp>
+        <p:nvSpPr>
+          <p:cNvPr id="29" name="Rounded Rectangle 28"/>
+          <p:cNvSpPr/>
+          <p:nvPr/>
+        </p:nvSpPr>
+        <p:spPr>
+          <a:xfrm>
+            <a:off x="7251192" y="4370832"/>
+            <a:ext cx="100584" cy="100584"/>
+          </a:xfrm>
+          <a:prstGeom prst="roundRect">
+            <a:avLst>
+              <a:gd name="adj" fmla="val 50000"/>
+            </a:avLst>
+          </a:prstGeom>
+          <a:solidFill>
+            <a:srgbClr val="C05F3A"/>
+          </a:solidFill>
+          <a:ln>
+            <a:noFill/>
+          </a:ln>
+          <a:effectLst/>
+        </p:spPr>
+        <p:style>
+          <a:lnRef idx="1">
+            <a:schemeClr val="accent1"/>
+          </a:lnRef>
+          <a:fillRef idx="3">
+            <a:schemeClr val="accent1"/>
+          </a:fillRef>
+          <a:effectRef idx="2">
+            <a:schemeClr val="accent1"/>
+          </a:effectRef>
+          <a:fontRef idx="minor">
+            <a:schemeClr val="lt1"/>
+          </a:fontRef>
+        </p:style>
+        <p:txBody>
+          <a:bodyPr rtlCol="0" anchor="ctr"/>
+          <a:lstStyle/>
+          <a:p>
+            <a:pPr algn="ctr"/>
+          </a:p>
+        </p:txBody>
+      </p:sp>
+      <p:sp>
+        <p:nvSpPr>
+          <p:cNvPr id="30" name="TextBox 29"/>
           <p:cNvSpPr txBox="1"/>
           <p:nvPr/>
         </p:nvSpPr>
         <p:spPr>
           <a:xfrm>
-            <a:off x="1828800" y="5120640"/>
-            <a:ext cx="8229600" cy="914400"/>
-          </a:xfrm>
-          <a:prstGeom prst="rect">
-            <a:avLst/>
-          </a:prstGeom>
-          <a:noFill/>
-        </p:spPr>
-        <p:txBody>
-          <a:bodyPr wrap="square" anchor="t" lIns="0" rIns="0" tIns="0" bIns="0">
-            <a:spAutoFit/>
-          </a:bodyPr>
-          <a:lstStyle/>
-          <a:p>
-            <a:pPr algn="l">
-              <a:lnSpc>
-                <a:spcPct val="120000"/>
-              </a:lnSpc>
-            </a:pPr>
-            <a:r>
-              <a:rPr sz="1400" b="0">
-                <a:solidFill>
-                  <a:srgbClr val="9AA0AA"/>
-                </a:solidFill>
-                <a:latin typeface="Segoe UI"/>
-              </a:rPr>
-              <a:t>Built on open data — OSM, OpenFreeMap, Open-Meteo/CAMS, CPCB/WAQI/DPCC, TomTom — and a C++ engine that answers in milliseconds, not seconds.</a:t>
-            </a:r>
-          </a:p>
-        </p:txBody>
-      </p:sp>
-      <p:sp>
-        <p:nvSpPr>
-          <p:cNvPr id="28" name="TextBox 27"/>
-          <p:cNvSpPr txBox="1"/>
-          <p:nvPr/>
-        </p:nvSpPr>
-        <p:spPr>
-          <a:xfrm>
-            <a:off x="1828800" y="6355080"/>
-            <a:ext cx="5486400" cy="274320"/>
+            <a:off x="7251192" y="4590288"/>
+            <a:ext cx="4434840" cy="320040"/>
           </a:xfrm>
           <a:prstGeom prst="rect">
             <a:avLst/>
@@ -8965,7 +8686,133 @@
               </a:lnSpc>
             </a:pPr>
             <a:r>
-              <a:rPr sz="1050" b="0">
+              <a:rPr sz="1400" b="1">
+                <a:solidFill>
+                  <a:srgbClr val="EDEBE4"/>
+                </a:solidFill>
+                <a:latin typeface="Segoe UI"/>
+              </a:rPr>
+              <a:t>Your track stays yours.</a:t>
+            </a:r>
+          </a:p>
+        </p:txBody>
+      </p:sp>
+      <p:sp>
+        <p:nvSpPr>
+          <p:cNvPr id="31" name="TextBox 30"/>
+          <p:cNvSpPr txBox="1"/>
+          <p:nvPr/>
+        </p:nvSpPr>
+        <p:spPr>
+          <a:xfrm>
+            <a:off x="7251192" y="4919472"/>
+            <a:ext cx="4434840" cy="585216"/>
+          </a:xfrm>
+          <a:prstGeom prst="rect">
+            <a:avLst/>
+          </a:prstGeom>
+          <a:noFill/>
+        </p:spPr>
+        <p:txBody>
+          <a:bodyPr wrap="square" anchor="t" lIns="0" rIns="0" tIns="0" bIns="0">
+            <a:spAutoFit/>
+          </a:bodyPr>
+          <a:lstStyle/>
+          <a:p>
+            <a:pPr algn="l">
+              <a:lnSpc>
+                <a:spcPct val="112000"/>
+              </a:lnSpc>
+            </a:pPr>
+            <a:r>
+              <a:rPr sz="1100" b="0">
+                <a:solidFill>
+                  <a:srgbClr val="9AA0AA"/>
+                </a:solidFill>
+                <a:latin typeface="Segoe UI"/>
+              </a:rPr>
+              <a:t>Dose needs the path; tracking people is creepy. The GPS trail never leaves the phone — only anonymous counters leave.</a:t>
+            </a:r>
+          </a:p>
+        </p:txBody>
+      </p:sp>
+      <p:sp>
+        <p:nvSpPr>
+          <p:cNvPr id="32" name="TextBox 31"/>
+          <p:cNvSpPr txBox="1"/>
+          <p:nvPr/>
+        </p:nvSpPr>
+        <p:spPr>
+          <a:xfrm>
+            <a:off x="1828800" y="5943600"/>
+            <a:ext cx="8686800" cy="457200"/>
+          </a:xfrm>
+          <a:prstGeom prst="rect">
+            <a:avLst/>
+          </a:prstGeom>
+          <a:noFill/>
+        </p:spPr>
+        <p:txBody>
+          <a:bodyPr wrap="square" anchor="t" lIns="0" rIns="0" tIns="0" bIns="0">
+            <a:spAutoFit/>
+          </a:bodyPr>
+          <a:lstStyle/>
+          <a:p>
+            <a:pPr algn="l">
+              <a:lnSpc>
+                <a:spcPct val="100000"/>
+              </a:lnSpc>
+            </a:pPr>
+            <a:r>
+              <a:rPr sz="1200" b="0">
+                <a:solidFill>
+                  <a:srgbClr val="9AA0AA"/>
+                </a:solidFill>
+                <a:latin typeface="Segoe UI"/>
+              </a:rPr>
+              <a:t>Open data, open stack — OSM · OpenFreeMap · Open-Meteo/CAMS · CPCB/WAQI/DPCC · TomTom — </a:t>
+            </a:r>
+            <a:r>
+              <a:rPr sz="1200" b="1">
+                <a:solidFill>
+                  <a:srgbClr val="8FB8D9"/>
+                </a:solidFill>
+                <a:latin typeface="Segoe UI"/>
+              </a:rPr>
+              <a:t>delhi-is-alive.vercel.app</a:t>
+            </a:r>
+          </a:p>
+        </p:txBody>
+      </p:sp>
+      <p:sp>
+        <p:nvSpPr>
+          <p:cNvPr id="33" name="TextBox 32"/>
+          <p:cNvSpPr txBox="1"/>
+          <p:nvPr/>
+        </p:nvSpPr>
+        <p:spPr>
+          <a:xfrm>
+            <a:off x="1828800" y="6473952"/>
+            <a:ext cx="5486400" cy="274320"/>
+          </a:xfrm>
+          <a:prstGeom prst="rect">
+            <a:avLst/>
+          </a:prstGeom>
+          <a:noFill/>
+        </p:spPr>
+        <p:txBody>
+          <a:bodyPr wrap="square" anchor="t" lIns="0" rIns="0" tIns="0" bIns="0">
+            <a:spAutoFit/>
+          </a:bodyPr>
+          <a:lstStyle/>
+          <a:p>
+            <a:pPr algn="l">
+              <a:lnSpc>
+                <a:spcPct val="100000"/>
+              </a:lnSpc>
+            </a:pPr>
+            <a:r>
+              <a:rPr sz="1000" b="0">
                 <a:solidFill>
                   <a:srgbClr val="5C6470"/>
                 </a:solidFill>

</xml_diff>

<commit_message>
deck v3: four explainable slides — AWS story, stack in plain words, data sources, clean-route + hard parts
</commit_message>
<xml_diff>
--- a/docs/deck/ALive-tech.pptx
+++ b/docs/deck/ALive-tech.pptx
@@ -3653,7 +3653,7 @@
                 </a:solidFill>
                 <a:latin typeface="Segoe UI"/>
               </a:rPr>
-              <a:t>01 · SYSTEM</a:t>
+              <a:t>01 · RUNNING ON AWS</a:t>
             </a:r>
           </a:p>
         </p:txBody>
@@ -3686,13 +3686,13 @@
               </a:lnSpc>
             </a:pPr>
             <a:r>
-              <a:rPr sz="3200" b="1">
+              <a:rPr sz="3100" b="1">
                 <a:solidFill>
                   <a:srgbClr val="EDEBE4"/>
                 </a:solidFill>
                 <a:latin typeface="Segoe UI"/>
               </a:rPr>
-              <a:t>A live exposure engine,</a:t>
+              <a:t>A real engine in the cloud —</a:t>
             </a:r>
           </a:p>
           <a:p>
@@ -3702,13 +3702,13 @@
               </a:lnSpc>
             </a:pPr>
             <a:r>
-              <a:rPr sz="3200" b="1">
+              <a:rPr sz="3100" b="1">
                 <a:solidFill>
                   <a:srgbClr val="EDEBE4"/>
                 </a:solidFill>
                 <a:latin typeface="Segoe UI"/>
               </a:rPr>
-              <a:t>not a dashboard</a:t>
+              <a:t>always on, always fresh</a:t>
             </a:r>
           </a:p>
         </p:txBody>
@@ -3721,8 +3721,8 @@
         </p:nvSpPr>
         <p:spPr>
           <a:xfrm>
-            <a:off x="1828800" y="2286000"/>
-            <a:ext cx="7498079" cy="822960"/>
+            <a:off x="1828800" y="2331720"/>
+            <a:ext cx="7680960" cy="731520"/>
           </a:xfrm>
           <a:prstGeom prst="rect">
             <a:avLst/>
@@ -3747,25 +3747,7 @@
                 </a:solidFill>
                 <a:latin typeface="Segoe UI"/>
               </a:rPr>
-              <a:t>One question in — </a:t>
-            </a:r>
-            <a:r>
-              <a:rPr sz="1400" b="1">
-                <a:solidFill>
-                  <a:srgbClr val="EDEBE4"/>
-                </a:solidFill>
-                <a:latin typeface="Segoe UI"/>
-              </a:rPr>
-              <a:t>“what did this air do to me?”</a:t>
-            </a:r>
-            <a:r>
-              <a:rPr sz="1400" b="0">
-                <a:solidFill>
-                  <a:srgbClr val="9AA0AA"/>
-                </a:solidFill>
-                <a:latin typeface="Segoe UI"/>
-              </a:rPr>
-              <a:t> — answered per-request from live feeds. No screenshots, no canned numbers.</a:t>
+              <a:t>ALive doesn't sit on your phone. It lives on AWS in Mumbai — close to Delhi, so every answer is quick and every number is freshly computed.</a:t>
             </a:r>
           </a:p>
         </p:txBody>
@@ -3778,8 +3760,8 @@
         </p:nvSpPr>
         <p:spPr>
           <a:xfrm>
-            <a:off x="1828800" y="3200400"/>
-            <a:ext cx="2468880" cy="1463040"/>
+            <a:off x="1828800" y="3291840"/>
+            <a:ext cx="2880360" cy="1965960"/>
           </a:xfrm>
           <a:prstGeom prst="roundRect">
             <a:avLst>
@@ -3826,8 +3808,8 @@
         </p:nvSpPr>
         <p:spPr>
           <a:xfrm>
-            <a:off x="2029968" y="3364992"/>
-            <a:ext cx="2103120" cy="256032"/>
+            <a:off x="2048256" y="3474720"/>
+            <a:ext cx="2514600" cy="256032"/>
           </a:xfrm>
           <a:prstGeom prst="rect">
             <a:avLst/>
@@ -3852,7 +3834,7 @@
                 </a:solidFill>
                 <a:latin typeface="Segoe UI"/>
               </a:rPr>
-              <a:t>YOU</a:t>
+              <a:t>ALWAYS ON</a:t>
             </a:r>
           </a:p>
         </p:txBody>
@@ -3865,8 +3847,8 @@
         </p:nvSpPr>
         <p:spPr>
           <a:xfrm>
-            <a:off x="2029968" y="3621024"/>
-            <a:ext cx="2103120" cy="292608"/>
+            <a:off x="2048256" y="3749040"/>
+            <a:ext cx="2514600" cy="320040"/>
           </a:xfrm>
           <a:prstGeom prst="rect">
             <a:avLst/>
@@ -3885,13 +3867,13 @@
               </a:lnSpc>
             </a:pPr>
             <a:r>
-              <a:rPr sz="1400" b="1">
+              <a:rPr sz="1450" b="1">
                 <a:solidFill>
                   <a:srgbClr val="EDEBE4"/>
                 </a:solidFill>
                 <a:latin typeface="Segoe UI"/>
               </a:rPr>
-              <a:t>Phone browser</a:t>
+              <a:t>It never sleeps</a:t>
             </a:r>
           </a:p>
         </p:txBody>
@@ -3904,8 +3886,8 @@
         </p:nvSpPr>
         <p:spPr>
           <a:xfrm>
-            <a:off x="2029968" y="3931920"/>
-            <a:ext cx="2121408" cy="685800"/>
+            <a:off x="2048256" y="4133088"/>
+            <a:ext cx="2496312" cy="1005840"/>
           </a:xfrm>
           <a:prstGeom prst="rect">
             <a:avLst/>
@@ -3920,70 +3902,31 @@
           <a:p>
             <a:pPr algn="l">
               <a:lnSpc>
-                <a:spcPct val="110000"/>
+                <a:spcPct val="115000"/>
               </a:lnSpc>
             </a:pPr>
             <a:r>
-              <a:rPr sz="1050" b="0">
+              <a:rPr sz="1100" b="0">
                 <a:solidFill>
                   <a:srgbClr val="9AA0AA"/>
                 </a:solidFill>
                 <a:latin typeface="Segoe UI"/>
               </a:rPr>
-              <a:t>GPS, map, trip math — your track never leaves the device</a:t>
-            </a:r>
-          </a:p>
-        </p:txBody>
-      </p:sp>
-      <p:sp>
-        <p:nvSpPr>
-          <p:cNvPr id="21" name="TextBox 20"/>
-          <p:cNvSpPr txBox="1"/>
-          <p:nvPr/>
-        </p:nvSpPr>
-        <p:spPr>
-          <a:xfrm>
-            <a:off x="4361688" y="3749040"/>
-            <a:ext cx="365760" cy="457200"/>
-          </a:xfrm>
-          <a:prstGeom prst="rect">
-            <a:avLst/>
-          </a:prstGeom>
-          <a:noFill/>
-        </p:spPr>
-        <p:txBody>
-          <a:bodyPr wrap="square" anchor="t" lIns="0" rIns="0" tIns="0" bIns="0">
-            <a:spAutoFit/>
-          </a:bodyPr>
-          <a:lstStyle/>
-          <a:p>
-            <a:pPr algn="l">
-              <a:lnSpc>
-                <a:spcPct val="100000"/>
-              </a:lnSpc>
-            </a:pPr>
-            <a:r>
-              <a:rPr sz="1900" b="0">
-                <a:solidFill>
-                  <a:srgbClr val="5C6470"/>
-                </a:solidFill>
-                <a:latin typeface="Segoe UI"/>
-              </a:rPr>
-              <a:t>→</a:t>
-            </a:r>
-          </a:p>
-        </p:txBody>
-      </p:sp>
-      <p:sp>
-        <p:nvSpPr>
-          <p:cNvPr id="22" name="Rounded Rectangle 21"/>
+              <a:t>Amazon's servers rebuild the air picture every ~15 minutes — even when nobody opens the app</a:t>
+            </a:r>
+          </a:p>
+        </p:txBody>
+      </p:sp>
+      <p:sp>
+        <p:nvSpPr>
+          <p:cNvPr id="21" name="Rounded Rectangle 20"/>
           <p:cNvSpPr/>
           <p:nvPr/>
         </p:nvSpPr>
         <p:spPr>
           <a:xfrm>
-            <a:off x="4754880" y="3200400"/>
-            <a:ext cx="2468880" cy="1463040"/>
+            <a:off x="5074920" y="3291840"/>
+            <a:ext cx="2880360" cy="1965960"/>
           </a:xfrm>
           <a:prstGeom prst="roundRect">
             <a:avLst>
@@ -4024,14 +3967,14 @@
       </p:sp>
       <p:sp>
         <p:nvSpPr>
-          <p:cNvPr id="23" name="TextBox 22"/>
+          <p:cNvPr id="22" name="TextBox 21"/>
           <p:cNvSpPr txBox="1"/>
           <p:nvPr/>
         </p:nvSpPr>
         <p:spPr>
           <a:xfrm>
-            <a:off x="4956048" y="3364992"/>
-            <a:ext cx="2103120" cy="256032"/>
+            <a:off x="5294376" y="3474720"/>
+            <a:ext cx="2514600" cy="256032"/>
           </a:xfrm>
           <a:prstGeom prst="rect">
             <a:avLst/>
@@ -4056,21 +3999,21 @@
                 </a:solidFill>
                 <a:latin typeface="Segoe UI"/>
               </a:rPr>
-              <a:t>EDGE</a:t>
-            </a:r>
-          </a:p>
-        </p:txBody>
-      </p:sp>
-      <p:sp>
-        <p:nvSpPr>
-          <p:cNvPr id="24" name="TextBox 23"/>
+              <a:t>AUTO-SCALE</a:t>
+            </a:r>
+          </a:p>
+        </p:txBody>
+      </p:sp>
+      <p:sp>
+        <p:nvSpPr>
+          <p:cNvPr id="23" name="TextBox 22"/>
           <p:cNvSpPr txBox="1"/>
           <p:nvPr/>
         </p:nvSpPr>
         <p:spPr>
           <a:xfrm>
-            <a:off x="4956048" y="3621024"/>
-            <a:ext cx="2103120" cy="292608"/>
+            <a:off x="5294376" y="3749040"/>
+            <a:ext cx="2514600" cy="320040"/>
           </a:xfrm>
           <a:prstGeom prst="rect">
             <a:avLst/>
@@ -4089,27 +4032,27 @@
               </a:lnSpc>
             </a:pPr>
             <a:r>
-              <a:rPr sz="1400" b="1">
+              <a:rPr sz="1450" b="1">
                 <a:solidFill>
                   <a:srgbClr val="EDEBE4"/>
                 </a:solidFill>
                 <a:latin typeface="Segoe UI"/>
               </a:rPr>
-              <a:t>Vercel → CloudFront</a:t>
-            </a:r>
-          </a:p>
-        </p:txBody>
-      </p:sp>
-      <p:sp>
-        <p:nvSpPr>
-          <p:cNvPr id="25" name="TextBox 24"/>
+              <a:t>It scales itself</a:t>
+            </a:r>
+          </a:p>
+        </p:txBody>
+      </p:sp>
+      <p:sp>
+        <p:nvSpPr>
+          <p:cNvPr id="24" name="TextBox 23"/>
           <p:cNvSpPr txBox="1"/>
           <p:nvPr/>
         </p:nvSpPr>
         <p:spPr>
           <a:xfrm>
-            <a:off x="4956048" y="3931920"/>
-            <a:ext cx="2121408" cy="685800"/>
+            <a:off x="5294376" y="4133088"/>
+            <a:ext cx="2496312" cy="1005840"/>
           </a:xfrm>
           <a:prstGeom prst="rect">
             <a:avLst/>
@@ -4124,70 +4067,31 @@
           <a:p>
             <a:pPr algn="l">
               <a:lnSpc>
-                <a:spcPct val="110000"/>
+                <a:spcPct val="115000"/>
               </a:lnSpc>
             </a:pPr>
             <a:r>
-              <a:rPr sz="1050" b="0">
+              <a:rPr sz="1100" b="0">
                 <a:solidFill>
                   <a:srgbClr val="9AA0AA"/>
                 </a:solidFill>
                 <a:latin typeface="Segoe UI"/>
               </a:rPr>
-              <a:t>static shell + API proxy to the engine</a:t>
-            </a:r>
-          </a:p>
-        </p:txBody>
-      </p:sp>
-      <p:sp>
-        <p:nvSpPr>
-          <p:cNvPr id="26" name="TextBox 25"/>
-          <p:cNvSpPr txBox="1"/>
-          <p:nvPr/>
-        </p:nvSpPr>
-        <p:spPr>
-          <a:xfrm>
-            <a:off x="7287768" y="3749040"/>
-            <a:ext cx="365760" cy="457200"/>
-          </a:xfrm>
-          <a:prstGeom prst="rect">
-            <a:avLst/>
-          </a:prstGeom>
-          <a:noFill/>
-        </p:spPr>
-        <p:txBody>
-          <a:bodyPr wrap="square" anchor="t" lIns="0" rIns="0" tIns="0" bIns="0">
-            <a:spAutoFit/>
-          </a:bodyPr>
-          <a:lstStyle/>
-          <a:p>
-            <a:pPr algn="l">
-              <a:lnSpc>
-                <a:spcPct val="100000"/>
-              </a:lnSpc>
-            </a:pPr>
-            <a:r>
-              <a:rPr sz="1900" b="0">
-                <a:solidFill>
-                  <a:srgbClr val="5C6470"/>
-                </a:solidFill>
-                <a:latin typeface="Segoe UI"/>
-              </a:rPr>
-              <a:t>→</a:t>
-            </a:r>
-          </a:p>
-        </p:txBody>
-      </p:sp>
-      <p:sp>
-        <p:nvSpPr>
-          <p:cNvPr id="27" name="Rounded Rectangle 26"/>
+              <a:t>AWS starts more copies of the engine when many people use it at once — demo day can't melt it</a:t>
+            </a:r>
+          </a:p>
+        </p:txBody>
+      </p:sp>
+      <p:sp>
+        <p:nvSpPr>
+          <p:cNvPr id="25" name="Rounded Rectangle 24"/>
           <p:cNvSpPr/>
           <p:nvPr/>
         </p:nvSpPr>
         <p:spPr>
           <a:xfrm>
-            <a:off x="7680960" y="3200400"/>
-            <a:ext cx="2468880" cy="1463040"/>
+            <a:off x="8321040" y="3291840"/>
+            <a:ext cx="2880360" cy="1965960"/>
           </a:xfrm>
           <a:prstGeom prst="roundRect">
             <a:avLst>
@@ -4228,14 +4132,14 @@
       </p:sp>
       <p:sp>
         <p:nvSpPr>
-          <p:cNvPr id="28" name="TextBox 27"/>
+          <p:cNvPr id="26" name="TextBox 25"/>
           <p:cNvSpPr txBox="1"/>
           <p:nvPr/>
         </p:nvSpPr>
         <p:spPr>
           <a:xfrm>
-            <a:off x="7882128" y="3364992"/>
-            <a:ext cx="2103120" cy="256032"/>
+            <a:off x="8540496" y="3474720"/>
+            <a:ext cx="2514600" cy="256032"/>
           </a:xfrm>
           <a:prstGeom prst="rect">
             <a:avLst/>
@@ -4260,21 +4164,21 @@
                 </a:solidFill>
                 <a:latin typeface="Segoe UI"/>
               </a:rPr>
-              <a:t>ENGINE</a:t>
-            </a:r>
-          </a:p>
-        </p:txBody>
-      </p:sp>
-      <p:sp>
-        <p:nvSpPr>
-          <p:cNvPr id="29" name="TextBox 28"/>
+              <a:t>SECURE</a:t>
+            </a:r>
+          </a:p>
+        </p:txBody>
+      </p:sp>
+      <p:sp>
+        <p:nvSpPr>
+          <p:cNvPr id="27" name="TextBox 26"/>
           <p:cNvSpPr txBox="1"/>
           <p:nvPr/>
         </p:nvSpPr>
         <p:spPr>
           <a:xfrm>
-            <a:off x="7882128" y="3621024"/>
-            <a:ext cx="2103120" cy="292608"/>
+            <a:off x="8540496" y="3749040"/>
+            <a:ext cx="2514600" cy="320040"/>
           </a:xfrm>
           <a:prstGeom prst="rect">
             <a:avLst/>
@@ -4293,27 +4197,27 @@
               </a:lnSpc>
             </a:pPr>
             <a:r>
-              <a:rPr sz="1400" b="1">
+              <a:rPr sz="1450" b="1">
                 <a:solidFill>
                   <a:srgbClr val="EDEBE4"/>
                 </a:solidFill>
                 <a:latin typeface="Segoe UI"/>
               </a:rPr>
-              <a:t>FastAPI · AWS ECS</a:t>
-            </a:r>
-          </a:p>
-        </p:txBody>
-      </p:sp>
-      <p:sp>
-        <p:nvSpPr>
-          <p:cNvPr id="30" name="TextBox 29"/>
+              <a:t>It stays honest</a:t>
+            </a:r>
+          </a:p>
+        </p:txBody>
+      </p:sp>
+      <p:sp>
+        <p:nvSpPr>
+          <p:cNvPr id="28" name="TextBox 27"/>
           <p:cNvSpPr txBox="1"/>
           <p:nvPr/>
         </p:nvSpPr>
         <p:spPr>
           <a:xfrm>
-            <a:off x="7882128" y="3931920"/>
-            <a:ext cx="2121408" cy="685800"/>
+            <a:off x="8540496" y="4133088"/>
+            <a:ext cx="2496312" cy="1005840"/>
           </a:xfrm>
           <a:prstGeom prst="rect">
             <a:avLst/>
@@ -4328,79 +4232,31 @@
           <a:p>
             <a:pPr algn="l">
               <a:lnSpc>
-                <a:spcPct val="110000"/>
+                <a:spcPct val="115000"/>
               </a:lnSpc>
             </a:pPr>
             <a:r>
-              <a:rPr sz="1050" b="0">
+              <a:rPr sz="1100" b="0">
                 <a:solidFill>
                   <a:srgbClr val="9AA0AA"/>
                 </a:solidFill>
                 <a:latin typeface="Segoe UI"/>
               </a:rPr>
-              <a:t>C++ routing core, field builder, dose model</a:t>
-            </a:r>
-          </a:p>
-        </p:txBody>
-      </p:sp>
-      <p:sp>
-        <p:nvSpPr>
-          <p:cNvPr id="31" name="Rounded Rectangle 30"/>
-          <p:cNvSpPr/>
-          <p:nvPr/>
-        </p:nvSpPr>
-        <p:spPr>
-          <a:xfrm>
-            <a:off x="1828800" y="5074920"/>
-            <a:ext cx="2542032" cy="365760"/>
-          </a:xfrm>
-          <a:prstGeom prst="roundRect">
-            <a:avLst>
-              <a:gd name="adj" fmla="val 50000"/>
-            </a:avLst>
-          </a:prstGeom>
-          <a:solidFill>
-            <a:srgbClr val="15181E"/>
-          </a:solidFill>
-          <a:ln w="9525">
-            <a:solidFill>
-              <a:srgbClr val="262B33"/>
-            </a:solidFill>
-          </a:ln>
-          <a:effectLst/>
-        </p:spPr>
-        <p:style>
-          <a:lnRef idx="1">
-            <a:schemeClr val="accent1"/>
-          </a:lnRef>
-          <a:fillRef idx="3">
-            <a:schemeClr val="accent1"/>
-          </a:fillRef>
-          <a:effectRef idx="2">
-            <a:schemeClr val="accent1"/>
-          </a:effectRef>
-          <a:fontRef idx="minor">
-            <a:schemeClr val="lt1"/>
-          </a:fontRef>
-        </p:style>
-        <p:txBody>
-          <a:bodyPr rtlCol="0" anchor="ctr"/>
-          <a:lstStyle/>
-          <a:p>
-            <a:pPr algn="ctr"/>
-          </a:p>
-        </p:txBody>
-      </p:sp>
-      <p:sp>
-        <p:nvSpPr>
-          <p:cNvPr id="32" name="TextBox 31"/>
+              <a:t>Station keys &amp; secrets live in AWS's vault — the app reads live data, nothing is faked on-device</a:t>
+            </a:r>
+          </a:p>
+        </p:txBody>
+      </p:sp>
+      <p:sp>
+        <p:nvSpPr>
+          <p:cNvPr id="29" name="TextBox 28"/>
           <p:cNvSpPr txBox="1"/>
           <p:nvPr/>
         </p:nvSpPr>
         <p:spPr>
           <a:xfrm>
-            <a:off x="1975104" y="5157216"/>
-            <a:ext cx="2542032" cy="274320"/>
+            <a:off x="1828800" y="5715000"/>
+            <a:ext cx="8686800" cy="365760"/>
           </a:xfrm>
           <a:prstGeom prst="rect">
             <a:avLst/>
@@ -4419,434 +4275,38 @@
               </a:lnSpc>
             </a:pPr>
             <a:r>
-              <a:rPr sz="1150" b="1">
-                <a:solidFill>
-                  <a:srgbClr val="7FBF9A"/>
-                </a:solidFill>
-                <a:latin typeface="Segoe UI"/>
-              </a:rPr>
-              <a:t>53</a:t>
-            </a:r>
-            <a:r>
-              <a:rPr sz="1150" b="0">
+              <a:rPr sz="1300" b="0">
                 <a:solidFill>
                   <a:srgbClr val="9AA0AA"/>
                 </a:solidFill>
                 <a:latin typeface="Segoe UI"/>
               </a:rPr>
-              <a:t> live stations · WAQI + DPCC</a:t>
-            </a:r>
-          </a:p>
-        </p:txBody>
-      </p:sp>
-      <p:sp>
-        <p:nvSpPr>
-          <p:cNvPr id="33" name="Rounded Rectangle 32"/>
-          <p:cNvSpPr/>
-          <p:nvPr/>
-        </p:nvSpPr>
-        <p:spPr>
-          <a:xfrm>
-            <a:off x="4489704" y="5074920"/>
-            <a:ext cx="2317089" cy="365760"/>
-          </a:xfrm>
-          <a:prstGeom prst="roundRect">
-            <a:avLst>
-              <a:gd name="adj" fmla="val 50000"/>
-            </a:avLst>
-          </a:prstGeom>
-          <a:solidFill>
-            <a:srgbClr val="15181E"/>
-          </a:solidFill>
-          <a:ln w="9525">
-            <a:solidFill>
-              <a:srgbClr val="262B33"/>
-            </a:solidFill>
-          </a:ln>
-          <a:effectLst/>
-        </p:spPr>
-        <p:style>
-          <a:lnRef idx="1">
-            <a:schemeClr val="accent1"/>
-          </a:lnRef>
-          <a:fillRef idx="3">
-            <a:schemeClr val="accent1"/>
-          </a:fillRef>
-          <a:effectRef idx="2">
-            <a:schemeClr val="accent1"/>
-          </a:effectRef>
-          <a:fontRef idx="minor">
-            <a:schemeClr val="lt1"/>
-          </a:fontRef>
-        </p:style>
-        <p:txBody>
-          <a:bodyPr rtlCol="0" anchor="ctr"/>
-          <a:lstStyle/>
-          <a:p>
-            <a:pPr algn="ctr"/>
-          </a:p>
-        </p:txBody>
-      </p:sp>
-      <p:sp>
-        <p:nvSpPr>
-          <p:cNvPr id="34" name="TextBox 33"/>
-          <p:cNvSpPr txBox="1"/>
-          <p:nvPr/>
-        </p:nvSpPr>
-        <p:spPr>
-          <a:xfrm>
-            <a:off x="4636008" y="5157216"/>
-            <a:ext cx="2317089" cy="274320"/>
-          </a:xfrm>
-          <a:prstGeom prst="rect">
-            <a:avLst/>
-          </a:prstGeom>
-          <a:noFill/>
-        </p:spPr>
-        <p:txBody>
-          <a:bodyPr wrap="square" anchor="t" lIns="0" rIns="0" tIns="0" bIns="0">
-            <a:spAutoFit/>
-          </a:bodyPr>
-          <a:lstStyle/>
-          <a:p>
-            <a:pPr algn="l">
-              <a:lnSpc>
-                <a:spcPct val="100000"/>
-              </a:lnSpc>
-            </a:pPr>
-            <a:r>
-              <a:rPr sz="1150" b="0">
+              <a:t>Your phone asks → </a:t>
+            </a:r>
+            <a:r>
+              <a:rPr sz="1300" b="1">
+                <a:solidFill>
+                  <a:srgbClr val="EDEBE4"/>
+                </a:solidFill>
+                <a:latin typeface="Segoe UI"/>
+              </a:rPr>
+              <a:t>AWS computes</a:t>
+            </a:r>
+            <a:r>
+              <a:rPr sz="1300" b="0">
                 <a:solidFill>
                   <a:srgbClr val="9AA0AA"/>
                 </a:solidFill>
                 <a:latin typeface="Segoe UI"/>
               </a:rPr>
-              <a:t>CAMS satellite · Open-Meteo</a:t>
-            </a:r>
-          </a:p>
-        </p:txBody>
-      </p:sp>
-      <p:sp>
-        <p:nvSpPr>
-          <p:cNvPr id="35" name="Rounded Rectangle 34"/>
-          <p:cNvSpPr/>
-          <p:nvPr/>
-        </p:nvSpPr>
-        <p:spPr>
-          <a:xfrm>
-            <a:off x="6925665" y="5074920"/>
-            <a:ext cx="1117396" cy="365760"/>
-          </a:xfrm>
-          <a:prstGeom prst="roundRect">
-            <a:avLst>
-              <a:gd name="adj" fmla="val 50000"/>
-            </a:avLst>
-          </a:prstGeom>
-          <a:solidFill>
-            <a:srgbClr val="15181E"/>
-          </a:solidFill>
-          <a:ln w="9525">
-            <a:solidFill>
-              <a:srgbClr val="262B33"/>
-            </a:solidFill>
-          </a:ln>
-          <a:effectLst/>
-        </p:spPr>
-        <p:style>
-          <a:lnRef idx="1">
-            <a:schemeClr val="accent1"/>
-          </a:lnRef>
-          <a:fillRef idx="3">
-            <a:schemeClr val="accent1"/>
-          </a:fillRef>
-          <a:effectRef idx="2">
-            <a:schemeClr val="accent1"/>
-          </a:effectRef>
-          <a:fontRef idx="minor">
-            <a:schemeClr val="lt1"/>
-          </a:fontRef>
-        </p:style>
-        <p:txBody>
-          <a:bodyPr rtlCol="0" anchor="ctr"/>
-          <a:lstStyle/>
-          <a:p>
-            <a:pPr algn="ctr"/>
-          </a:p>
-        </p:txBody>
-      </p:sp>
-      <p:sp>
-        <p:nvSpPr>
-          <p:cNvPr id="36" name="TextBox 35"/>
-          <p:cNvSpPr txBox="1"/>
-          <p:nvPr/>
-        </p:nvSpPr>
-        <p:spPr>
-          <a:xfrm>
-            <a:off x="7071969" y="5157216"/>
-            <a:ext cx="1117396" cy="274320"/>
-          </a:xfrm>
-          <a:prstGeom prst="rect">
-            <a:avLst/>
-          </a:prstGeom>
-          <a:noFill/>
-        </p:spPr>
-        <p:txBody>
-          <a:bodyPr wrap="square" anchor="t" lIns="0" rIns="0" tIns="0" bIns="0">
-            <a:spAutoFit/>
-          </a:bodyPr>
-          <a:lstStyle/>
-          <a:p>
-            <a:pPr algn="l">
-              <a:lnSpc>
-                <a:spcPct val="100000"/>
-              </a:lnSpc>
-            </a:pPr>
-            <a:r>
-              <a:rPr sz="1150" b="0">
-                <a:solidFill>
-                  <a:srgbClr val="9AA0AA"/>
-                </a:solidFill>
-                <a:latin typeface="Segoe UI"/>
-              </a:rPr>
-              <a:t>VIIRS fires</a:t>
-            </a:r>
-          </a:p>
-        </p:txBody>
-      </p:sp>
-      <p:sp>
-        <p:nvSpPr>
-          <p:cNvPr id="37" name="Rounded Rectangle 36"/>
-          <p:cNvSpPr/>
-          <p:nvPr/>
-        </p:nvSpPr>
-        <p:spPr>
-          <a:xfrm>
-            <a:off x="8161933" y="5074920"/>
-            <a:ext cx="1942185" cy="365760"/>
-          </a:xfrm>
-          <a:prstGeom prst="roundRect">
-            <a:avLst>
-              <a:gd name="adj" fmla="val 50000"/>
-            </a:avLst>
-          </a:prstGeom>
-          <a:solidFill>
-            <a:srgbClr val="15181E"/>
-          </a:solidFill>
-          <a:ln w="9525">
-            <a:solidFill>
-              <a:srgbClr val="262B33"/>
-            </a:solidFill>
-          </a:ln>
-          <a:effectLst/>
-        </p:spPr>
-        <p:style>
-          <a:lnRef idx="1">
-            <a:schemeClr val="accent1"/>
-          </a:lnRef>
-          <a:fillRef idx="3">
-            <a:schemeClr val="accent1"/>
-          </a:fillRef>
-          <a:effectRef idx="2">
-            <a:schemeClr val="accent1"/>
-          </a:effectRef>
-          <a:fontRef idx="minor">
-            <a:schemeClr val="lt1"/>
-          </a:fontRef>
-        </p:style>
-        <p:txBody>
-          <a:bodyPr rtlCol="0" anchor="ctr"/>
-          <a:lstStyle/>
-          <a:p>
-            <a:pPr algn="ctr"/>
-          </a:p>
-        </p:txBody>
-      </p:sp>
-      <p:sp>
-        <p:nvSpPr>
-          <p:cNvPr id="38" name="TextBox 37"/>
-          <p:cNvSpPr txBox="1"/>
-          <p:nvPr/>
-        </p:nvSpPr>
-        <p:spPr>
-          <a:xfrm>
-            <a:off x="8308237" y="5157216"/>
-            <a:ext cx="1942185" cy="274320"/>
-          </a:xfrm>
-          <a:prstGeom prst="rect">
-            <a:avLst/>
-          </a:prstGeom>
-          <a:noFill/>
-        </p:spPr>
-        <p:txBody>
-          <a:bodyPr wrap="square" anchor="t" lIns="0" rIns="0" tIns="0" bIns="0">
-            <a:spAutoFit/>
-          </a:bodyPr>
-          <a:lstStyle/>
-          <a:p>
-            <a:pPr algn="l">
-              <a:lnSpc>
-                <a:spcPct val="100000"/>
-              </a:lnSpc>
-            </a:pPr>
-            <a:r>
-              <a:rPr sz="1150" b="1">
-                <a:solidFill>
-                  <a:srgbClr val="7FBF9A"/>
-                </a:solidFill>
-                <a:latin typeface="Segoe UI"/>
-              </a:rPr>
-              <a:t>1.07M</a:t>
-            </a:r>
-            <a:r>
-              <a:rPr sz="1150" b="0">
-                <a:solidFill>
-                  <a:srgbClr val="9AA0AA"/>
-                </a:solidFill>
-                <a:latin typeface="Segoe UI"/>
-              </a:rPr>
-              <a:t> road edges · OSM</a:t>
-            </a:r>
-          </a:p>
-        </p:txBody>
-      </p:sp>
-      <p:sp>
-        <p:nvSpPr>
-          <p:cNvPr id="39" name="Rounded Rectangle 38"/>
-          <p:cNvSpPr/>
-          <p:nvPr/>
-        </p:nvSpPr>
-        <p:spPr>
-          <a:xfrm>
-            <a:off x="10222990" y="5074920"/>
-            <a:ext cx="1342339" cy="365760"/>
-          </a:xfrm>
-          <a:prstGeom prst="roundRect">
-            <a:avLst>
-              <a:gd name="adj" fmla="val 50000"/>
-            </a:avLst>
-          </a:prstGeom>
-          <a:solidFill>
-            <a:srgbClr val="15181E"/>
-          </a:solidFill>
-          <a:ln w="9525">
-            <a:solidFill>
-              <a:srgbClr val="262B33"/>
-            </a:solidFill>
-          </a:ln>
-          <a:effectLst/>
-        </p:spPr>
-        <p:style>
-          <a:lnRef idx="1">
-            <a:schemeClr val="accent1"/>
-          </a:lnRef>
-          <a:fillRef idx="3">
-            <a:schemeClr val="accent1"/>
-          </a:fillRef>
-          <a:effectRef idx="2">
-            <a:schemeClr val="accent1"/>
-          </a:effectRef>
-          <a:fontRef idx="minor">
-            <a:schemeClr val="lt1"/>
-          </a:fontRef>
-        </p:style>
-        <p:txBody>
-          <a:bodyPr rtlCol="0" anchor="ctr"/>
-          <a:lstStyle/>
-          <a:p>
-            <a:pPr algn="ctr"/>
-          </a:p>
-        </p:txBody>
-      </p:sp>
-      <p:sp>
-        <p:nvSpPr>
-          <p:cNvPr id="40" name="TextBox 39"/>
-          <p:cNvSpPr txBox="1"/>
-          <p:nvPr/>
-        </p:nvSpPr>
-        <p:spPr>
-          <a:xfrm>
-            <a:off x="10369294" y="5157216"/>
-            <a:ext cx="1342339" cy="274320"/>
-          </a:xfrm>
-          <a:prstGeom prst="rect">
-            <a:avLst/>
-          </a:prstGeom>
-          <a:noFill/>
-        </p:spPr>
-        <p:txBody>
-          <a:bodyPr wrap="square" anchor="t" lIns="0" rIns="0" tIns="0" bIns="0">
-            <a:spAutoFit/>
-          </a:bodyPr>
-          <a:lstStyle/>
-          <a:p>
-            <a:pPr algn="l">
-              <a:lnSpc>
-                <a:spcPct val="100000"/>
-              </a:lnSpc>
-            </a:pPr>
-            <a:r>
-              <a:rPr sz="1150" b="0">
-                <a:solidFill>
-                  <a:srgbClr val="9AA0AA"/>
-                </a:solidFill>
-                <a:latin typeface="Segoe UI"/>
-              </a:rPr>
-              <a:t>TomTom traffic</a:t>
-            </a:r>
-          </a:p>
-        </p:txBody>
-      </p:sp>
-      <p:sp>
-        <p:nvSpPr>
-          <p:cNvPr id="41" name="TextBox 40"/>
-          <p:cNvSpPr txBox="1"/>
-          <p:nvPr/>
-        </p:nvSpPr>
-        <p:spPr>
-          <a:xfrm>
-            <a:off x="1828800" y="5806440"/>
-            <a:ext cx="8229600" cy="365760"/>
-          </a:xfrm>
-          <a:prstGeom prst="rect">
-            <a:avLst/>
-          </a:prstGeom>
-          <a:noFill/>
-        </p:spPr>
-        <p:txBody>
-          <a:bodyPr wrap="square" anchor="t" lIns="0" rIns="0" tIns="0" bIns="0">
-            <a:spAutoFit/>
-          </a:bodyPr>
-          <a:lstStyle/>
-          <a:p>
-            <a:pPr algn="l">
-              <a:lnSpc>
-                <a:spcPct val="100000"/>
-              </a:lnSpc>
-            </a:pPr>
-            <a:r>
-              <a:rPr sz="1200" b="0">
-                <a:solidFill>
-                  <a:srgbClr val="5C6470"/>
-                </a:solidFill>
-                <a:latin typeface="Segoe UI"/>
-              </a:rPr>
-              <a:t>Real numbers, today: </a:t>
-            </a:r>
-            <a:r>
-              <a:rPr sz="1200" b="0">
-                <a:solidFill>
-                  <a:srgbClr val="9AA0AA"/>
-                </a:solidFill>
-                <a:latin typeface="Segoe UI"/>
-              </a:rPr>
-              <a:t>24 routes scored in ~2.5 s incl. live traffic · field rebuilt every ~15 min</a:t>
-            </a:r>
-          </a:p>
-        </p:txBody>
-      </p:sp>
-      <p:sp>
-        <p:nvSpPr>
-          <p:cNvPr id="42" name="TextBox 41"/>
+              <a:t> → your phone shows the answer in about a second.</a:t>
+            </a:r>
+          </a:p>
+        </p:txBody>
+      </p:sp>
+      <p:sp>
+        <p:nvSpPr>
+          <p:cNvPr id="30" name="TextBox 29"/>
           <p:cNvSpPr txBox="1"/>
           <p:nvPr/>
         </p:nvSpPr>
@@ -5463,7 +4923,7 @@
                 </a:solidFill>
                 <a:latin typeface="Segoe UI"/>
               </a:rPr>
-              <a:t>02 · THE FIELD ALGORITHM</a:t>
+              <a:t>02 · WHAT'S INSIDE</a:t>
             </a:r>
           </a:p>
         </p:txBody>
@@ -5496,13 +4956,13 @@
               </a:lnSpc>
             </a:pPr>
             <a:r>
-              <a:rPr sz="3200" b="1">
+              <a:rPr sz="3100" b="1">
                 <a:solidFill>
                   <a:srgbClr val="EDEBE4"/>
                 </a:solidFill>
                 <a:latin typeface="Segoe UI"/>
               </a:rPr>
-              <a:t>53 stations →</a:t>
+              <a:t>Three parts,</a:t>
             </a:r>
           </a:p>
           <a:p>
@@ -5512,13 +4972,13 @@
               </a:lnSpc>
             </a:pPr>
             <a:r>
-              <a:rPr sz="3200" b="1">
+              <a:rPr sz="3100" b="1">
                 <a:solidFill>
                   <a:srgbClr val="EDEBE4"/>
                 </a:solidFill>
                 <a:latin typeface="Segoe UI"/>
               </a:rPr>
-              <a:t>14,155 living cells</a:t>
+              <a:t>one job</a:t>
             </a:r>
           </a:p>
         </p:txBody>
@@ -5531,8 +4991,8 @@
         </p:nvSpPr>
         <p:spPr>
           <a:xfrm>
-            <a:off x="1828800" y="2286000"/>
-            <a:ext cx="4572000" cy="685800"/>
+            <a:off x="1828800" y="2240280"/>
+            <a:ext cx="7680960" cy="457200"/>
           </a:xfrm>
           <a:prstGeom prst="rect">
             <a:avLst/>
@@ -5547,35 +5007,17 @@
           <a:p>
             <a:pPr algn="l">
               <a:lnSpc>
-                <a:spcPct val="115000"/>
+                <a:spcPct val="100000"/>
               </a:lnSpc>
             </a:pPr>
             <a:r>
-              <a:rPr sz="1300" b="0">
+              <a:rPr sz="1400" b="0">
                 <a:solidFill>
                   <a:srgbClr val="9AA0AA"/>
                 </a:solidFill>
                 <a:latin typeface="Segoe UI"/>
               </a:rPr>
-              <a:t>Stations and the CAMS satellite prior are </a:t>
-            </a:r>
-            <a:r>
-              <a:rPr sz="1300" b="1">
-                <a:solidFill>
-                  <a:srgbClr val="EDEBE4"/>
-                </a:solidFill>
-                <a:latin typeface="Segoe UI"/>
-              </a:rPr>
-              <a:t>distance-blended onto an H3 hex grid</a:t>
-            </a:r>
-            <a:r>
-              <a:rPr sz="1300" b="0">
-                <a:solidFill>
-                  <a:srgbClr val="9AA0AA"/>
-                </a:solidFill>
-                <a:latin typeface="Segoe UI"/>
-              </a:rPr>
-              <a:t> — the air is computed per cell, not per district.</a:t>
+              <a:t>The tech stack is boring on purpose — the interesting part is what it does with real data.</a:t>
             </a:r>
           </a:p>
         </p:txBody>
@@ -5588,8 +5030,8 @@
         </p:nvSpPr>
         <p:spPr>
           <a:xfrm>
-            <a:off x="1828800" y="3108960"/>
-            <a:ext cx="4480560" cy="1600200"/>
+            <a:off x="1828800" y="2880360"/>
+            <a:ext cx="2880360" cy="2286000"/>
           </a:xfrm>
           <a:prstGeom prst="roundRect">
             <a:avLst>
@@ -5636,8 +5078,8 @@
         </p:nvSpPr>
         <p:spPr>
           <a:xfrm>
-            <a:off x="2057400" y="3273552"/>
-            <a:ext cx="4023360" cy="274320"/>
+            <a:off x="2048256" y="3081528"/>
+            <a:ext cx="2514600" cy="256032"/>
           </a:xfrm>
           <a:prstGeom prst="rect">
             <a:avLst/>
@@ -5656,13 +5098,13 @@
               </a:lnSpc>
             </a:pPr>
             <a:r>
-              <a:rPr sz="900" b="1" spc="200">
-                <a:solidFill>
-                  <a:srgbClr val="5C6470"/>
-                </a:solidFill>
-                <a:latin typeface="Segoe UI"/>
-              </a:rPr>
-              <a:t>THE TWO FORMULAS THAT RUN THE MAP</a:t>
+              <a:rPr sz="950" b="1" spc="200">
+                <a:solidFill>
+                  <a:srgbClr val="8FB8D9"/>
+                </a:solidFill>
+                <a:latin typeface="Segoe UI"/>
+              </a:rPr>
+              <a:t>YOU</a:t>
             </a:r>
           </a:p>
         </p:txBody>
@@ -5675,8 +5117,8 @@
         </p:nvSpPr>
         <p:spPr>
           <a:xfrm>
-            <a:off x="2057400" y="3566160"/>
-            <a:ext cx="4023360" cy="502920"/>
+            <a:off x="2048256" y="3383280"/>
+            <a:ext cx="2514600" cy="320040"/>
           </a:xfrm>
           <a:prstGeom prst="rect">
             <a:avLst/>
@@ -5691,42 +5133,17 @@
           <a:p>
             <a:pPr algn="l">
               <a:lnSpc>
-                <a:spcPct val="150000"/>
+                <a:spcPct val="100000"/>
               </a:lnSpc>
             </a:pPr>
             <a:r>
-              <a:rPr sz="1250" b="0">
-                <a:solidFill>
-                  <a:srgbClr val="7FBF9A"/>
-                </a:solidFill>
-                <a:latin typeface="Cascadia Code"/>
-              </a:rPr>
-              <a:t>pm(x) = Σ pmᵢ·dᵢ⁻² / Σ dᵢ⁻²  + CAMS prior</a:t>
-            </a:r>
-            <a:r>
-              <a:rPr sz="1250" b="0">
-                <a:solidFill>
-                  <a:srgbClr val="8FB8D9"/>
-                </a:solidFill>
-                <a:latin typeface="Cascadia Code"/>
-              </a:rPr>
-              <a:t/>
-            </a:r>
-          </a:p>
-          <a:p>
-            <a:pPr algn="l">
-              <a:lnSpc>
-                <a:spcPct val="150000"/>
-              </a:lnSpc>
-            </a:pPr>
-            <a:r>
-              <a:rPr sz="1250" b="0">
-                <a:solidFill>
-                  <a:srgbClr val="8FB8D9"/>
-                </a:solidFill>
-                <a:latin typeface="Cascadia Code"/>
-              </a:rPr>
-              <a:t>AQI = (I_hi−I_lo)·(c−BP_lo)/(BP_hi−BP_lo) + I_lo</a:t>
+              <a:rPr sz="1500" b="1">
+                <a:solidFill>
+                  <a:srgbClr val="EDEBE4"/>
+                </a:solidFill>
+                <a:latin typeface="Segoe UI"/>
+              </a:rPr>
+              <a:t>The app</a:t>
             </a:r>
           </a:p>
         </p:txBody>
@@ -5739,8 +5156,8 @@
         </p:nvSpPr>
         <p:spPr>
           <a:xfrm>
-            <a:off x="2057400" y="4315968"/>
-            <a:ext cx="4069080" cy="365760"/>
+            <a:off x="2048256" y="3749040"/>
+            <a:ext cx="2478024" cy="1280160"/>
           </a:xfrm>
           <a:prstGeom prst="rect">
             <a:avLst/>
@@ -5755,35 +5172,74 @@
           <a:p>
             <a:pPr algn="l">
               <a:lnSpc>
-                <a:spcPct val="110000"/>
+                <a:spcPct val="118000"/>
               </a:lnSpc>
             </a:pPr>
             <a:r>
-              <a:rPr sz="1000" b="0">
+              <a:rPr sz="1150" b="0">
                 <a:solidFill>
                   <a:srgbClr val="9AA0AA"/>
                 </a:solidFill>
                 <a:latin typeface="Segoe UI"/>
               </a:rPr>
-              <a:t>IDW blend per cell · then India's official CPCB breakpoints — the same table the monitors use.</a:t>
-            </a:r>
-          </a:p>
-        </p:txBody>
-      </p:sp>
-      <p:sp>
-        <p:nvSpPr>
-          <p:cNvPr id="21" name="Rounded Rectangle 20"/>
+              <a:t>A plain website — opens on any phone, no install. GPS, the map and your trip live here.</a:t>
+            </a:r>
+          </a:p>
+        </p:txBody>
+      </p:sp>
+      <p:sp>
+        <p:nvSpPr>
+          <p:cNvPr id="21" name="TextBox 20"/>
+          <p:cNvSpPr txBox="1"/>
+          <p:nvPr/>
+        </p:nvSpPr>
+        <p:spPr>
+          <a:xfrm>
+            <a:off x="4764024" y="3794760"/>
+            <a:ext cx="365760" cy="457200"/>
+          </a:xfrm>
+          <a:prstGeom prst="rect">
+            <a:avLst/>
+          </a:prstGeom>
+          <a:noFill/>
+        </p:spPr>
+        <p:txBody>
+          <a:bodyPr wrap="square" anchor="t" lIns="0" rIns="0" tIns="0" bIns="0">
+            <a:spAutoFit/>
+          </a:bodyPr>
+          <a:lstStyle/>
+          <a:p>
+            <a:pPr algn="l">
+              <a:lnSpc>
+                <a:spcPct val="100000"/>
+              </a:lnSpc>
+            </a:pPr>
+            <a:r>
+              <a:rPr sz="1900" b="0">
+                <a:solidFill>
+                  <a:srgbClr val="5C6470"/>
+                </a:solidFill>
+                <a:latin typeface="Segoe UI"/>
+              </a:rPr>
+              <a:t>→</a:t>
+            </a:r>
+          </a:p>
+        </p:txBody>
+      </p:sp>
+      <p:sp>
+        <p:nvSpPr>
+          <p:cNvPr id="22" name="Rounded Rectangle 21"/>
           <p:cNvSpPr/>
           <p:nvPr/>
         </p:nvSpPr>
         <p:spPr>
           <a:xfrm>
-            <a:off x="1828800" y="4937760"/>
-            <a:ext cx="4480560" cy="1325880"/>
+            <a:off x="5074920" y="2880360"/>
+            <a:ext cx="2880360" cy="2286000"/>
           </a:xfrm>
           <a:prstGeom prst="roundRect">
             <a:avLst>
-              <a:gd name="adj" fmla="val 7000"/>
+              <a:gd name="adj" fmla="val 8000"/>
             </a:avLst>
           </a:prstGeom>
           <a:solidFill>
@@ -5820,60 +5276,14 @@
       </p:sp>
       <p:sp>
         <p:nvSpPr>
-          <p:cNvPr id="22" name="Rounded Rectangle 21"/>
-          <p:cNvSpPr/>
-          <p:nvPr/>
-        </p:nvSpPr>
-        <p:spPr>
-          <a:xfrm>
-            <a:off x="2084832" y="5175504"/>
-            <a:ext cx="100584" cy="100584"/>
-          </a:xfrm>
-          <a:prstGeom prst="roundRect">
-            <a:avLst>
-              <a:gd name="adj" fmla="val 50000"/>
-            </a:avLst>
-          </a:prstGeom>
-          <a:solidFill>
-            <a:srgbClr val="D9A86C"/>
-          </a:solidFill>
-          <a:ln>
-            <a:noFill/>
-          </a:ln>
-          <a:effectLst/>
-        </p:spPr>
-        <p:style>
-          <a:lnRef idx="1">
-            <a:schemeClr val="accent1"/>
-          </a:lnRef>
-          <a:fillRef idx="3">
-            <a:schemeClr val="accent1"/>
-          </a:fillRef>
-          <a:effectRef idx="2">
-            <a:schemeClr val="accent1"/>
-          </a:effectRef>
-          <a:fontRef idx="minor">
-            <a:schemeClr val="lt1"/>
-          </a:fontRef>
-        </p:style>
-        <p:txBody>
-          <a:bodyPr rtlCol="0" anchor="ctr"/>
-          <a:lstStyle/>
-          <a:p>
-            <a:pPr algn="ctr"/>
-          </a:p>
-        </p:txBody>
-      </p:sp>
-      <p:sp>
-        <p:nvSpPr>
           <p:cNvPr id="23" name="TextBox 22"/>
           <p:cNvSpPr txBox="1"/>
           <p:nvPr/>
         </p:nvSpPr>
         <p:spPr>
           <a:xfrm>
-            <a:off x="2084832" y="5394960"/>
-            <a:ext cx="4023360" cy="320040"/>
+            <a:off x="5294376" y="3081528"/>
+            <a:ext cx="2514600" cy="256032"/>
           </a:xfrm>
           <a:prstGeom prst="rect">
             <a:avLst/>
@@ -5892,13 +5302,13 @@
               </a:lnSpc>
             </a:pPr>
             <a:r>
-              <a:rPr sz="1400" b="1">
-                <a:solidFill>
-                  <a:srgbClr val="EDEBE4"/>
-                </a:solidFill>
-                <a:latin typeface="Segoe UI"/>
-              </a:rPr>
-              <a:t>Every cell carries its confidence</a:t>
+              <a:rPr sz="950" b="1" spc="200">
+                <a:solidFill>
+                  <a:srgbClr val="8FB8D9"/>
+                </a:solidFill>
+                <a:latin typeface="Segoe UI"/>
+              </a:rPr>
+              <a:t>THE BRIDGE</a:t>
             </a:r>
           </a:p>
         </p:txBody>
@@ -5911,8 +5321,8 @@
         </p:nvSpPr>
         <p:spPr>
           <a:xfrm>
-            <a:off x="2084832" y="5724144"/>
-            <a:ext cx="4023360" cy="429768"/>
+            <a:off x="5294376" y="3383280"/>
+            <a:ext cx="2514600" cy="320040"/>
           </a:xfrm>
           <a:prstGeom prst="rect">
             <a:avLst/>
@@ -5927,35 +5337,113 @@
           <a:p>
             <a:pPr algn="l">
               <a:lnSpc>
-                <a:spcPct val="112000"/>
+                <a:spcPct val="100000"/>
               </a:lnSpc>
             </a:pPr>
             <a:r>
-              <a:rPr sz="1100" b="0">
+              <a:rPr sz="1500" b="1">
+                <a:solidFill>
+                  <a:srgbClr val="EDEBE4"/>
+                </a:solidFill>
+                <a:latin typeface="Segoe UI"/>
+              </a:rPr>
+              <a:t>The path between</a:t>
+            </a:r>
+          </a:p>
+        </p:txBody>
+      </p:sp>
+      <p:sp>
+        <p:nvSpPr>
+          <p:cNvPr id="25" name="TextBox 24"/>
+          <p:cNvSpPr txBox="1"/>
+          <p:nvPr/>
+        </p:nvSpPr>
+        <p:spPr>
+          <a:xfrm>
+            <a:off x="5294376" y="3749040"/>
+            <a:ext cx="2478024" cy="1280160"/>
+          </a:xfrm>
+          <a:prstGeom prst="rect">
+            <a:avLst/>
+          </a:prstGeom>
+          <a:noFill/>
+        </p:spPr>
+        <p:txBody>
+          <a:bodyPr wrap="square" anchor="t" lIns="0" rIns="0" tIns="0" bIns="0">
+            <a:spAutoFit/>
+          </a:bodyPr>
+          <a:lstStyle/>
+          <a:p>
+            <a:pPr algn="l">
+              <a:lnSpc>
+                <a:spcPct val="118000"/>
+              </a:lnSpc>
+            </a:pPr>
+            <a:r>
+              <a:rPr sz="1150" b="0">
                 <a:solidFill>
                   <a:srgbClr val="9AA0AA"/>
                 </a:solidFill>
                 <a:latin typeface="Segoe UI"/>
               </a:rPr>
-              <a:t>Near a monitor → “monitor-grade”. Model-only → the app says “satellite estimate”. Stale is called stale, never hidden.</a:t>
-            </a:r>
-          </a:p>
-        </p:txBody>
-      </p:sp>
-      <p:sp>
-        <p:nvSpPr>
-          <p:cNvPr id="25" name="Rounded Rectangle 24"/>
+              <a:t>Vercel + CloudFront carry your question to the engine and the answer back — fast, anywhere.</a:t>
+            </a:r>
+          </a:p>
+        </p:txBody>
+      </p:sp>
+      <p:sp>
+        <p:nvSpPr>
+          <p:cNvPr id="26" name="TextBox 25"/>
+          <p:cNvSpPr txBox="1"/>
+          <p:nvPr/>
+        </p:nvSpPr>
+        <p:spPr>
+          <a:xfrm>
+            <a:off x="8010144" y="3794760"/>
+            <a:ext cx="365760" cy="457200"/>
+          </a:xfrm>
+          <a:prstGeom prst="rect">
+            <a:avLst/>
+          </a:prstGeom>
+          <a:noFill/>
+        </p:spPr>
+        <p:txBody>
+          <a:bodyPr wrap="square" anchor="t" lIns="0" rIns="0" tIns="0" bIns="0">
+            <a:spAutoFit/>
+          </a:bodyPr>
+          <a:lstStyle/>
+          <a:p>
+            <a:pPr algn="l">
+              <a:lnSpc>
+                <a:spcPct val="100000"/>
+              </a:lnSpc>
+            </a:pPr>
+            <a:r>
+              <a:rPr sz="1900" b="0">
+                <a:solidFill>
+                  <a:srgbClr val="5C6470"/>
+                </a:solidFill>
+                <a:latin typeface="Segoe UI"/>
+              </a:rPr>
+              <a:t>→</a:t>
+            </a:r>
+          </a:p>
+        </p:txBody>
+      </p:sp>
+      <p:sp>
+        <p:nvSpPr>
+          <p:cNvPr id="27" name="Rounded Rectangle 26"/>
           <p:cNvSpPr/>
           <p:nvPr/>
         </p:nvSpPr>
         <p:spPr>
           <a:xfrm>
-            <a:off x="6492240" y="3063240"/>
-            <a:ext cx="5394960" cy="3310128"/>
+            <a:off x="8321040" y="2880360"/>
+            <a:ext cx="2880360" cy="2286000"/>
           </a:xfrm>
           <a:prstGeom prst="roundRect">
             <a:avLst>
-              <a:gd name="adj" fmla="val 5000"/>
+              <a:gd name="adj" fmla="val 8000"/>
             </a:avLst>
           </a:prstGeom>
           <a:solidFill>
@@ -5990,40 +5478,16 @@
           </a:p>
         </p:txBody>
       </p:sp>
-      <p:pic>
-        <p:nvPicPr>
-          <p:cNvPr id="26" name="Picture 25" descr="deckimg_field.png"/>
-          <p:cNvPicPr>
-            <a:picLocks noChangeAspect="1"/>
-          </p:cNvPicPr>
-          <p:nvPr/>
-        </p:nvPicPr>
-        <p:blipFill>
-          <a:blip r:embed="rId3"/>
-          <a:stretch>
-            <a:fillRect/>
-          </a:stretch>
-        </p:blipFill>
-        <p:spPr>
-          <a:xfrm>
-            <a:off x="7459843" y="3200400"/>
-            <a:ext cx="3459753" cy="2697480"/>
-          </a:xfrm>
-          <a:prstGeom prst="rect">
-            <a:avLst/>
-          </a:prstGeom>
-        </p:spPr>
-      </p:pic>
-      <p:sp>
-        <p:nvSpPr>
-          <p:cNvPr id="27" name="TextBox 26"/>
+      <p:sp>
+        <p:nvSpPr>
+          <p:cNvPr id="28" name="TextBox 27"/>
           <p:cNvSpPr txBox="1"/>
           <p:nvPr/>
         </p:nvSpPr>
         <p:spPr>
           <a:xfrm>
-            <a:off x="6675120" y="6053328"/>
-            <a:ext cx="4937760" cy="274320"/>
+            <a:off x="8540496" y="3081528"/>
+            <a:ext cx="2514600" cy="256032"/>
           </a:xfrm>
           <a:prstGeom prst="rect">
             <a:avLst/>
@@ -6042,29 +5506,146 @@
               </a:lnSpc>
             </a:pPr>
             <a:r>
-              <a:rPr sz="1050" b="0">
-                <a:solidFill>
-                  <a:srgbClr val="5C6470"/>
-                </a:solidFill>
-                <a:latin typeface="Segoe UI"/>
-              </a:rPr>
-              <a:t>the live field, today — PM2.5 per cell · real range </a:t>
-            </a:r>
-            <a:r>
-              <a:rPr sz="1050" b="1">
+              <a:rPr sz="950" b="1" spc="200">
+                <a:solidFill>
+                  <a:srgbClr val="8FB8D9"/>
+                </a:solidFill>
+                <a:latin typeface="Segoe UI"/>
+              </a:rPr>
+              <a:t>THE BRAIN</a:t>
+            </a:r>
+          </a:p>
+        </p:txBody>
+      </p:sp>
+      <p:sp>
+        <p:nvSpPr>
+          <p:cNvPr id="29" name="TextBox 28"/>
+          <p:cNvSpPr txBox="1"/>
+          <p:nvPr/>
+        </p:nvSpPr>
+        <p:spPr>
+          <a:xfrm>
+            <a:off x="8540496" y="3383280"/>
+            <a:ext cx="2514600" cy="320040"/>
+          </a:xfrm>
+          <a:prstGeom prst="rect">
+            <a:avLst/>
+          </a:prstGeom>
+          <a:noFill/>
+        </p:spPr>
+        <p:txBody>
+          <a:bodyPr wrap="square" anchor="t" lIns="0" rIns="0" tIns="0" bIns="0">
+            <a:spAutoFit/>
+          </a:bodyPr>
+          <a:lstStyle/>
+          <a:p>
+            <a:pPr algn="l">
+              <a:lnSpc>
+                <a:spcPct val="100000"/>
+              </a:lnSpc>
+            </a:pPr>
+            <a:r>
+              <a:rPr sz="1500" b="1">
+                <a:solidFill>
+                  <a:srgbClr val="EDEBE4"/>
+                </a:solidFill>
+                <a:latin typeface="Segoe UI"/>
+              </a:rPr>
+              <a:t>The engine</a:t>
+            </a:r>
+          </a:p>
+        </p:txBody>
+      </p:sp>
+      <p:sp>
+        <p:nvSpPr>
+          <p:cNvPr id="30" name="TextBox 29"/>
+          <p:cNvSpPr txBox="1"/>
+          <p:nvPr/>
+        </p:nvSpPr>
+        <p:spPr>
+          <a:xfrm>
+            <a:off x="8540496" y="3749040"/>
+            <a:ext cx="2478024" cy="1280160"/>
+          </a:xfrm>
+          <a:prstGeom prst="rect">
+            <a:avLst/>
+          </a:prstGeom>
+          <a:noFill/>
+        </p:spPr>
+        <p:txBody>
+          <a:bodyPr wrap="square" anchor="t" lIns="0" rIns="0" tIns="0" bIns="0">
+            <a:spAutoFit/>
+          </a:bodyPr>
+          <a:lstStyle/>
+          <a:p>
+            <a:pPr algn="l">
+              <a:lnSpc>
+                <a:spcPct val="118000"/>
+              </a:lnSpc>
+            </a:pPr>
+            <a:r>
+              <a:rPr sz="1150" b="0">
                 <a:solidFill>
                   <a:srgbClr val="9AA0AA"/>
                 </a:solidFill>
                 <a:latin typeface="Segoe UI"/>
               </a:rPr>
-              <a:t>43–127 µg/m³</a:t>
-            </a:r>
-          </a:p>
-        </p:txBody>
-      </p:sp>
-      <p:sp>
-        <p:nvSpPr>
-          <p:cNvPr id="28" name="TextBox 27"/>
+              <a:t>Python thinks; a C++ core does the heavy math — a million road segments scored while you blink.</a:t>
+            </a:r>
+          </a:p>
+        </p:txBody>
+      </p:sp>
+      <p:sp>
+        <p:nvSpPr>
+          <p:cNvPr id="31" name="TextBox 30"/>
+          <p:cNvSpPr txBox="1"/>
+          <p:nvPr/>
+        </p:nvSpPr>
+        <p:spPr>
+          <a:xfrm>
+            <a:off x="1828800" y="5486400"/>
+            <a:ext cx="8686800" cy="685800"/>
+          </a:xfrm>
+          <a:prstGeom prst="rect">
+            <a:avLst/>
+          </a:prstGeom>
+          <a:noFill/>
+        </p:spPr>
+        <p:txBody>
+          <a:bodyPr wrap="square" anchor="t" lIns="0" rIns="0" tIns="0" bIns="0">
+            <a:spAutoFit/>
+          </a:bodyPr>
+          <a:lstStyle/>
+          <a:p>
+            <a:pPr algn="l">
+              <a:lnSpc>
+                <a:spcPct val="115000"/>
+              </a:lnSpc>
+            </a:pPr>
+            <a:r>
+              <a:rPr sz="1300" b="1">
+                <a:solidFill>
+                  <a:srgbClr val="EDEBE4"/>
+                </a:solidFill>
+                <a:latin typeface="Segoe UI"/>
+              </a:rPr>
+              <a:t>Why split it? </a:t>
+            </a:r>
+            <a:r>
+              <a:rPr sz="1300" b="0">
+                <a:solidFill>
+                  <a:srgbClr val="9AA0AA"/>
+                </a:solidFill>
+                <a:latin typeface="Segoe UI"/>
+              </a:rPr>
+              <a:t>Phones are for showing, servers are for knowing — air data, roads, traffic and math all live where the compute is.</a:t>
+            </a:r>
+          </a:p>
+        </p:txBody>
+      </p:sp>
+      <p:sp>
+        <p:nvSpPr>
+          <p:cNvPr id="32" name="TextBox 31"/>
           <p:cNvSpPr txBox="1"/>
           <p:nvPr/>
         </p:nvSpPr>
@@ -6681,7 +6262,7 @@
                 </a:solidFill>
                 <a:latin typeface="Segoe UI"/>
               </a:rPr>
-              <a:t>03 · DOSE MATH</a:t>
+              <a:t>03 · WHERE THE NUMBERS COME FROM</a:t>
             </a:r>
           </a:p>
         </p:txBody>
@@ -6714,13 +6295,13 @@
               </a:lnSpc>
             </a:pPr>
             <a:r>
-              <a:rPr sz="3200" b="1">
+              <a:rPr sz="3100" b="1">
                 <a:solidFill>
                   <a:srgbClr val="EDEBE4"/>
                 </a:solidFill>
                 <a:latin typeface="Segoe UI"/>
               </a:rPr>
-              <a:t>Priced in breath,</a:t>
+              <a:t>Real sensors,</a:t>
             </a:r>
           </a:p>
           <a:p>
@@ -6730,13 +6311,13 @@
               </a:lnSpc>
             </a:pPr>
             <a:r>
-              <a:rPr sz="3200" b="1">
+              <a:rPr sz="3100" b="1">
                 <a:solidFill>
                   <a:srgbClr val="EDEBE4"/>
                 </a:solidFill>
                 <a:latin typeface="Segoe UI"/>
               </a:rPr>
-              <a:t>not just minutes</a:t>
+              <a:t>not guesses</a:t>
             </a:r>
           </a:p>
         </p:txBody>
@@ -6749,8 +6330,8 @@
         </p:nvSpPr>
         <p:spPr>
           <a:xfrm>
-            <a:off x="1828800" y="2286000"/>
-            <a:ext cx="4572000" cy="685800"/>
+            <a:off x="1828800" y="2240280"/>
+            <a:ext cx="4754880" cy="1371600"/>
           </a:xfrm>
           <a:prstGeom prst="rect">
             <a:avLst/>
@@ -6765,26 +6346,42 @@
           <a:p>
             <a:pPr algn="l">
               <a:lnSpc>
-                <a:spcPct val="115000"/>
+                <a:spcPct val="120000"/>
               </a:lnSpc>
             </a:pPr>
             <a:r>
-              <a:rPr sz="1300" b="0">
+              <a:rPr sz="1400" b="0">
                 <a:solidFill>
                   <a:srgbClr val="9AA0AA"/>
                 </a:solidFill>
                 <a:latin typeface="Segoe UI"/>
               </a:rPr>
-              <a:t>Each road segment takes the field's PM2.5 at its path. The route's dose integrates it — </a:t>
-            </a:r>
-            <a:r>
-              <a:rPr sz="1300" b="1">
-                <a:solidFill>
-                  <a:srgbClr val="EDEBE4"/>
-                </a:solidFill>
-                <a:latin typeface="Cascadia Code"/>
-              </a:rPr>
-              <a:t>dose = Σ cᵢ · VE · tᵢ</a:t>
+              <a:t>53 pollution monitors across Delhi report every few minutes. Satellites fill the gaps between them. Traffic feeds watch the roads.</a:t>
+            </a:r>
+            <a:r>
+              <a:rPr sz="1400" b="0">
+                <a:solidFill>
+                  <a:srgbClr val="9AA0AA"/>
+                </a:solidFill>
+                <a:latin typeface="Segoe UI"/>
+              </a:rPr>
+              <a:t/>
+            </a:r>
+          </a:p>
+          <a:p>
+            <a:pPr algn="l">
+              <a:lnSpc>
+                <a:spcPct val="120000"/>
+              </a:lnSpc>
+            </a:pPr>
+            <a:r>
+              <a:rPr sz="1400" b="0">
+                <a:solidFill>
+                  <a:srgbClr val="9AA0AA"/>
+                </a:solidFill>
+                <a:latin typeface="Segoe UI"/>
+              </a:rPr>
+              <a:t>All of it lands on a fine grid covering the whole city — so ALive can tell you the air on YOUR street, not just the nearest station's.</a:t>
             </a:r>
           </a:p>
         </p:txBody>
@@ -6797,12 +6394,12 @@
         </p:nvSpPr>
         <p:spPr>
           <a:xfrm>
-            <a:off x="1828800" y="3108960"/>
-            <a:ext cx="4480560" cy="1737360"/>
+            <a:off x="1828800" y="4069080"/>
+            <a:ext cx="4572000" cy="960120"/>
           </a:xfrm>
           <a:prstGeom prst="roundRect">
             <a:avLst>
-              <a:gd name="adj" fmla="val 8000"/>
+              <a:gd name="adj" fmla="val 7000"/>
             </a:avLst>
           </a:prstGeom>
           <a:solidFill>
@@ -6839,14 +6436,60 @@
       </p:sp>
       <p:sp>
         <p:nvSpPr>
-          <p:cNvPr id="18" name="TextBox 17"/>
+          <p:cNvPr id="18" name="Rounded Rectangle 17"/>
+          <p:cNvSpPr/>
+          <p:nvPr/>
+        </p:nvSpPr>
+        <p:spPr>
+          <a:xfrm>
+            <a:off x="2084832" y="4306824"/>
+            <a:ext cx="100584" cy="100584"/>
+          </a:xfrm>
+          <a:prstGeom prst="roundRect">
+            <a:avLst>
+              <a:gd name="adj" fmla="val 50000"/>
+            </a:avLst>
+          </a:prstGeom>
+          <a:solidFill>
+            <a:srgbClr val="7FBF9A"/>
+          </a:solidFill>
+          <a:ln>
+            <a:noFill/>
+          </a:ln>
+          <a:effectLst/>
+        </p:spPr>
+        <p:style>
+          <a:lnRef idx="1">
+            <a:schemeClr val="accent1"/>
+          </a:lnRef>
+          <a:fillRef idx="3">
+            <a:schemeClr val="accent1"/>
+          </a:fillRef>
+          <a:effectRef idx="2">
+            <a:schemeClr val="accent1"/>
+          </a:effectRef>
+          <a:fontRef idx="minor">
+            <a:schemeClr val="lt1"/>
+          </a:fontRef>
+        </p:style>
+        <p:txBody>
+          <a:bodyPr rtlCol="0" anchor="ctr"/>
+          <a:lstStyle/>
+          <a:p>
+            <a:pPr algn="ctr"/>
+          </a:p>
+        </p:txBody>
+      </p:sp>
+      <p:sp>
+        <p:nvSpPr>
+          <p:cNvPr id="19" name="TextBox 18"/>
           <p:cNvSpPr txBox="1"/>
           <p:nvPr/>
         </p:nvSpPr>
         <p:spPr>
           <a:xfrm>
-            <a:off x="2057400" y="3255264"/>
-            <a:ext cx="4023360" cy="274320"/>
+            <a:off x="2084832" y="4526280"/>
+            <a:ext cx="4114800" cy="320040"/>
           </a:xfrm>
           <a:prstGeom prst="rect">
             <a:avLst/>
@@ -6865,27 +6508,27 @@
               </a:lnSpc>
             </a:pPr>
             <a:r>
-              <a:rPr sz="900" b="1" spc="200">
-                <a:solidFill>
-                  <a:srgbClr val="5C6470"/>
-                </a:solidFill>
-                <a:latin typeface="Segoe UI"/>
-              </a:rPr>
-              <a:t>VENTILATION · VE (L AIR / MIN)</a:t>
-            </a:r>
-          </a:p>
-        </p:txBody>
-      </p:sp>
-      <p:sp>
-        <p:nvSpPr>
-          <p:cNvPr id="19" name="TextBox 18"/>
+              <a:rPr sz="1400" b="1">
+                <a:solidFill>
+                  <a:srgbClr val="EDEBE4"/>
+                </a:solidFill>
+                <a:latin typeface="Segoe UI"/>
+              </a:rPr>
+              <a:t>53 live monitors</a:t>
+            </a:r>
+          </a:p>
+        </p:txBody>
+      </p:sp>
+      <p:sp>
+        <p:nvSpPr>
+          <p:cNvPr id="20" name="TextBox 19"/>
           <p:cNvSpPr txBox="1"/>
           <p:nvPr/>
         </p:nvSpPr>
         <p:spPr>
           <a:xfrm>
-            <a:off x="2057400" y="3529584"/>
-            <a:ext cx="4114800" cy="1188720"/>
+            <a:off x="2084832" y="4873752"/>
+            <a:ext cx="4114800" cy="45720"/>
           </a:xfrm>
           <a:prstGeom prst="rect">
             <a:avLst/>
@@ -6900,72 +6543,17 @@
           <a:p>
             <a:pPr algn="l">
               <a:lnSpc>
-                <a:spcPct val="160000"/>
+                <a:spcPct val="114000"/>
               </a:lnSpc>
             </a:pPr>
             <a:r>
-              <a:rPr sz="1300" b="0">
-                <a:solidFill>
-                  <a:srgbClr val="7FBF9A"/>
-                </a:solidFill>
-                <a:latin typeface="Cascadia Code"/>
-              </a:rPr>
-              <a:t>sitting ~8   ·   walking ~14   ·   cycling ~26</a:t>
-            </a:r>
-          </a:p>
-          <a:p>
-            <a:pPr algn="l">
-              <a:lnSpc>
-                <a:spcPct val="160000"/>
-              </a:lnSpc>
-            </a:pPr>
-            <a:r>
-              <a:rPr sz="1300" b="0">
-                <a:solidFill>
-                  <a:srgbClr val="7FBF9A"/>
-                </a:solidFill>
-                <a:latin typeface="Cascadia Code"/>
-              </a:rPr>
-              <a:t>running ~45   ·   car cabin ≈ ÷2.5 filtered</a:t>
-            </a:r>
-          </a:p>
-        </p:txBody>
-      </p:sp>
-      <p:sp>
-        <p:nvSpPr>
-          <p:cNvPr id="20" name="TextBox 19"/>
-          <p:cNvSpPr txBox="1"/>
-          <p:nvPr/>
-        </p:nvSpPr>
-        <p:spPr>
-          <a:xfrm>
-            <a:off x="2057400" y="4517136"/>
-            <a:ext cx="4114800" cy="320040"/>
-          </a:xfrm>
-          <a:prstGeom prst="rect">
-            <a:avLst/>
-          </a:prstGeom>
-          <a:noFill/>
-        </p:spPr>
-        <p:txBody>
-          <a:bodyPr wrap="square" anchor="t" lIns="0" rIns="0" tIns="0" bIns="0">
-            <a:spAutoFit/>
-          </a:bodyPr>
-          <a:lstStyle/>
-          <a:p>
-            <a:pPr algn="l">
-              <a:lnSpc>
-                <a:spcPct val="110000"/>
-              </a:lnSpc>
-            </a:pPr>
-            <a:r>
-              <a:rPr sz="1050" b="0">
+              <a:rPr sz="1150" b="0">
                 <a:solidFill>
                   <a:srgbClr val="9AA0AA"/>
                 </a:solidFill>
                 <a:latin typeface="Segoe UI"/>
               </a:rPr>
-              <a:t>A runner breathes ~3× a walker — the mode changes the dose, not just the time.</a:t>
+              <a:t>WAQI + DPCC government sensors, refreshed every few minutes</a:t>
             </a:r>
           </a:p>
         </p:txBody>
@@ -6978,8 +6566,8 @@
         </p:nvSpPr>
         <p:spPr>
           <a:xfrm>
-            <a:off x="1828800" y="5074920"/>
-            <a:ext cx="4480560" cy="1234440"/>
+            <a:off x="1828800" y="5166360"/>
+            <a:ext cx="4572000" cy="960120"/>
           </a:xfrm>
           <a:prstGeom prst="roundRect">
             <a:avLst>
@@ -7026,7 +6614,7 @@
         </p:nvSpPr>
         <p:spPr>
           <a:xfrm>
-            <a:off x="2084832" y="5312664"/>
+            <a:off x="2084832" y="5404104"/>
             <a:ext cx="100584" cy="100584"/>
           </a:xfrm>
           <a:prstGeom prst="roundRect">
@@ -7072,8 +6660,8 @@
         </p:nvSpPr>
         <p:spPr>
           <a:xfrm>
-            <a:off x="2084832" y="5532120"/>
-            <a:ext cx="4023360" cy="320040"/>
+            <a:off x="2084832" y="5623560"/>
+            <a:ext cx="4114800" cy="320040"/>
           </a:xfrm>
           <a:prstGeom prst="rect">
             <a:avLst/>
@@ -7098,7 +6686,7 @@
                 </a:solidFill>
                 <a:latin typeface="Segoe UI"/>
               </a:rPr>
-              <a:t>The engine behind it</a:t>
+              <a:t>Satellite + traffic</a:t>
             </a:r>
           </a:p>
         </p:txBody>
@@ -7111,8 +6699,8 @@
         </p:nvSpPr>
         <p:spPr>
           <a:xfrm>
-            <a:off x="2084832" y="5861304"/>
-            <a:ext cx="4023360" cy="338328"/>
+            <a:off x="2084832" y="5971032"/>
+            <a:ext cx="4114800" cy="45720"/>
           </a:xfrm>
           <a:prstGeom prst="rect">
             <a:avLst/>
@@ -7127,17 +6715,17 @@
           <a:p>
             <a:pPr algn="l">
               <a:lnSpc>
-                <a:spcPct val="112000"/>
+                <a:spcPct val="114000"/>
               </a:lnSpc>
             </a:pPr>
             <a:r>
-              <a:rPr sz="1100" b="0">
+              <a:rPr sz="1150" b="0">
                 <a:solidFill>
                   <a:srgbClr val="9AA0AA"/>
                 </a:solidFill>
                 <a:latin typeface="Segoe UI"/>
               </a:rPr>
-              <a:t>C++ core over 1,070,459 OSM edges — candidate paths generated, each re-scored on the field, strictly-worse ones collapsed.</a:t>
+              <a:t>CAMS satellite, fire spots, TomTom jams — all live</a:t>
             </a:r>
           </a:p>
         </p:txBody>
@@ -7150,8 +6738,8 @@
         </p:nvSpPr>
         <p:spPr>
           <a:xfrm>
-            <a:off x="6492240" y="1188720"/>
-            <a:ext cx="5394960" cy="5138928"/>
+            <a:off x="6537960" y="2103120"/>
+            <a:ext cx="5349240" cy="3794760"/>
           </a:xfrm>
           <a:prstGeom prst="roundRect">
             <a:avLst>
@@ -7192,7 +6780,7 @@
       </p:sp>
       <p:pic>
         <p:nvPicPr>
-          <p:cNvPr id="26" name="Picture 25" descr="deckimg_routes.png"/>
+          <p:cNvPr id="26" name="Picture 25" descr="deckimg_field.png"/>
           <p:cNvPicPr>
             <a:picLocks noChangeAspect="1"/>
           </p:cNvPicPr>
@@ -7206,8 +6794,8 @@
         </p:blipFill>
         <p:spPr>
           <a:xfrm>
-            <a:off x="8175950" y="1353312"/>
-            <a:ext cx="2027539" cy="2880360"/>
+            <a:off x="7306783" y="2240280"/>
+            <a:ext cx="3811592" cy="2971800"/>
           </a:xfrm>
           <a:prstGeom prst="rect">
             <a:avLst/>
@@ -7222,7 +6810,7 @@
         </p:nvSpPr>
         <p:spPr>
           <a:xfrm>
-            <a:off x="6675120" y="4224528"/>
+            <a:off x="6720840" y="5394960"/>
             <a:ext cx="4937760" cy="274320"/>
           </a:xfrm>
           <a:prstGeom prst="rect">
@@ -7248,97 +6836,20 @@
                 </a:solidFill>
                 <a:latin typeface="Segoe UI"/>
               </a:rPr>
-              <a:t>one real OD pair — green is the pick, </a:t>
-            </a:r>
-            <a:r>
-              <a:rPr sz="1050" b="1">
-                <a:solidFill>
-                  <a:srgbClr val="C05F3A"/>
-                </a:solidFill>
-                <a:latin typeface="Segoe UI"/>
-              </a:rPr>
-              <a:t>+81% dose on the main road</a:t>
-            </a:r>
-          </a:p>
-        </p:txBody>
-      </p:sp>
-      <p:sp>
-        <p:nvSpPr>
-          <p:cNvPr id="28" name="Rectangle 27"/>
-          <p:cNvSpPr/>
-          <p:nvPr/>
-        </p:nvSpPr>
-        <p:spPr>
-          <a:xfrm>
-            <a:off x="6675120" y="4526280"/>
-            <a:ext cx="5029200" cy="15240"/>
-          </a:xfrm>
-          <a:prstGeom prst="rect">
-            <a:avLst/>
-          </a:prstGeom>
-          <a:solidFill>
-            <a:srgbClr val="262B33"/>
-          </a:solidFill>
-          <a:ln>
-            <a:noFill/>
-          </a:ln>
-          <a:effectLst/>
-        </p:spPr>
-        <p:style>
-          <a:lnRef idx="1">
-            <a:schemeClr val="accent1"/>
-          </a:lnRef>
-          <a:fillRef idx="3">
-            <a:schemeClr val="accent1"/>
-          </a:fillRef>
-          <a:effectRef idx="2">
-            <a:schemeClr val="accent1"/>
-          </a:effectRef>
-          <a:fontRef idx="minor">
-            <a:schemeClr val="lt1"/>
-          </a:fontRef>
-        </p:style>
-        <p:txBody>
-          <a:bodyPr rtlCol="0" anchor="ctr"/>
-          <a:lstStyle/>
-          <a:p>
-            <a:pPr algn="ctr"/>
-          </a:p>
-        </p:txBody>
-      </p:sp>
-      <p:pic>
-        <p:nvPicPr>
-          <p:cNvPr id="29" name="Picture 28" descr="deckimg_dose.png"/>
-          <p:cNvPicPr>
-            <a:picLocks noChangeAspect="1"/>
-          </p:cNvPicPr>
-          <p:nvPr/>
-        </p:nvPicPr>
-        <p:blipFill>
-          <a:blip r:embed="rId4"/>
-          <a:stretch>
-            <a:fillRect/>
-          </a:stretch>
-        </p:blipFill>
-        <p:spPr>
-          <a:xfrm>
-            <a:off x="6962304" y="4681728"/>
-            <a:ext cx="4454831" cy="1417320"/>
-          </a:xfrm>
-          <a:prstGeom prst="rect">
-            <a:avLst/>
-          </a:prstGeom>
-        </p:spPr>
-      </p:pic>
-      <p:sp>
-        <p:nvSpPr>
-          <p:cNvPr id="30" name="TextBox 29"/>
+              <a:t>today's real air over Delhi — every square computed live</a:t>
+            </a:r>
+          </a:p>
+        </p:txBody>
+      </p:sp>
+      <p:sp>
+        <p:nvSpPr>
+          <p:cNvPr id="28" name="TextBox 27"/>
           <p:cNvSpPr txBox="1"/>
           <p:nvPr/>
         </p:nvSpPr>
         <p:spPr>
           <a:xfrm>
-            <a:off x="6675120" y="6089904"/>
+            <a:off x="6720840" y="5669280"/>
             <a:ext cx="4937760" cy="274320"/>
           </a:xfrm>
           <a:prstGeom prst="rect">
@@ -7364,14 +6875,14 @@
                 </a:solidFill>
                 <a:latin typeface="Segoe UI"/>
               </a:rPr>
-              <a:t>the air along the chosen path — peak 86 µg/m³ at km 11</a:t>
-            </a:r>
-          </a:p>
-        </p:txBody>
-      </p:sp>
-      <p:sp>
-        <p:nvSpPr>
-          <p:cNvPr id="31" name="TextBox 30"/>
+              <a:t>green breathes easy · red doesn't</a:t>
+            </a:r>
+          </a:p>
+        </p:txBody>
+      </p:sp>
+      <p:sp>
+        <p:nvSpPr>
+          <p:cNvPr id="29" name="TextBox 28"/>
           <p:cNvSpPr txBox="1"/>
           <p:nvPr/>
         </p:nvSpPr>
@@ -7988,7 +7499,7 @@
                 </a:solidFill>
                 <a:latin typeface="Segoe UI"/>
               </a:rPr>
-              <a:t>04 · THE FIGHT — BROWSER LIMITS</a:t>
+              <a:t>04 · THE CLEAN ROUTE — AND WHAT WAS HARD</a:t>
             </a:r>
           </a:p>
         </p:txBody>
@@ -8002,7 +7513,7 @@
         <p:spPr>
           <a:xfrm>
             <a:off x="1828800" y="914400"/>
-            <a:ext cx="7589520" cy="914400"/>
+            <a:ext cx="7589520" cy="1554480"/>
           </a:xfrm>
           <a:prstGeom prst="rect">
             <a:avLst/>
@@ -8021,13 +7532,13 @@
               </a:lnSpc>
             </a:pPr>
             <a:r>
-              <a:rPr sz="3200" b="1">
+              <a:rPr sz="3100" b="1">
                 <a:solidFill>
                   <a:srgbClr val="EDEBE4"/>
                 </a:solidFill>
                 <a:latin typeface="Segoe UI"/>
               </a:rPr>
-              <a:t>Fitting a city in</a:t>
+              <a:t>Same city,</a:t>
             </a:r>
           </a:p>
           <a:p>
@@ -8037,31 +7548,95 @@
               </a:lnSpc>
             </a:pPr>
             <a:r>
-              <a:rPr sz="3200" b="1">
+              <a:rPr sz="3100" b="1">
                 <a:solidFill>
                   <a:srgbClr val="EDEBE4"/>
                 </a:solidFill>
                 <a:latin typeface="Segoe UI"/>
               </a:rPr>
-              <a:t>a browser tab</a:t>
-            </a:r>
-          </a:p>
-        </p:txBody>
-      </p:sp>
-      <p:sp>
-        <p:nvSpPr>
-          <p:cNvPr id="16" name="Rounded Rectangle 15"/>
+              <a:t>less smoke in your lungs</a:t>
+            </a:r>
+          </a:p>
+        </p:txBody>
+      </p:sp>
+      <p:sp>
+        <p:nvSpPr>
+          <p:cNvPr id="16" name="TextBox 15"/>
+          <p:cNvSpPr txBox="1"/>
+          <p:nvPr/>
+        </p:nvSpPr>
+        <p:spPr>
+          <a:xfrm>
+            <a:off x="1828800" y="2286000"/>
+            <a:ext cx="4480560" cy="1371600"/>
+          </a:xfrm>
+          <a:prstGeom prst="rect">
+            <a:avLst/>
+          </a:prstGeom>
+          <a:noFill/>
+        </p:spPr>
+        <p:txBody>
+          <a:bodyPr wrap="square" anchor="t" lIns="0" rIns="0" tIns="0" bIns="0">
+            <a:spAutoFit/>
+          </a:bodyPr>
+          <a:lstStyle/>
+          <a:p>
+            <a:pPr algn="l">
+              <a:lnSpc>
+                <a:spcPct val="120000"/>
+              </a:lnSpc>
+            </a:pPr>
+            <a:r>
+              <a:rPr sz="1400" b="0">
+                <a:solidFill>
+                  <a:srgbClr val="9AA0AA"/>
+                </a:solidFill>
+                <a:latin typeface="Segoe UI"/>
+              </a:rPr>
+              <a:t>Every street borrows the air grid's reading. Then ALive compares the ways to go — and picks the one where you breathe the least, not just arrive fastest.</a:t>
+            </a:r>
+            <a:r>
+              <a:rPr sz="1400" b="1">
+                <a:solidFill>
+                  <a:srgbClr val="EDEBE4"/>
+                </a:solidFill>
+                <a:latin typeface="Segoe UI"/>
+              </a:rPr>
+              <a:t/>
+            </a:r>
+          </a:p>
+          <a:p>
+            <a:pPr algn="l">
+              <a:lnSpc>
+                <a:spcPct val="120000"/>
+              </a:lnSpc>
+            </a:pPr>
+            <a:r>
+              <a:rPr sz="1400" b="1">
+                <a:solidFill>
+                  <a:srgbClr val="EDEBE4"/>
+                </a:solidFill>
+                <a:latin typeface="Segoe UI"/>
+              </a:rPr>
+              <a:t>A run counts triple — you breathe ~3× harder.</a:t>
+            </a:r>
+          </a:p>
+        </p:txBody>
+      </p:sp>
+      <p:sp>
+        <p:nvSpPr>
+          <p:cNvPr id="17" name="Rounded Rectangle 16"/>
           <p:cNvSpPr/>
           <p:nvPr/>
         </p:nvSpPr>
         <p:spPr>
           <a:xfrm>
-            <a:off x="1828800" y="2377440"/>
-            <a:ext cx="4892040" cy="1481328"/>
+            <a:off x="1828800" y="3977639"/>
+            <a:ext cx="4480560" cy="1234440"/>
           </a:xfrm>
           <a:prstGeom prst="roundRect">
             <a:avLst>
-              <a:gd name="adj" fmla="val 7000"/>
+              <a:gd name="adj" fmla="val 8000"/>
             </a:avLst>
           </a:prstGeom>
           <a:solidFill>
@@ -8098,60 +7673,14 @@
       </p:sp>
       <p:sp>
         <p:nvSpPr>
-          <p:cNvPr id="17" name="Rounded Rectangle 16"/>
-          <p:cNvSpPr/>
-          <p:nvPr/>
-        </p:nvSpPr>
-        <p:spPr>
-          <a:xfrm>
-            <a:off x="2084832" y="2615184"/>
-            <a:ext cx="100584" cy="100584"/>
-          </a:xfrm>
-          <a:prstGeom prst="roundRect">
-            <a:avLst>
-              <a:gd name="adj" fmla="val 50000"/>
-            </a:avLst>
-          </a:prstGeom>
-          <a:solidFill>
-            <a:srgbClr val="D9A86C"/>
-          </a:solidFill>
-          <a:ln>
-            <a:noFill/>
-          </a:ln>
-          <a:effectLst/>
-        </p:spPr>
-        <p:style>
-          <a:lnRef idx="1">
-            <a:schemeClr val="accent1"/>
-          </a:lnRef>
-          <a:fillRef idx="3">
-            <a:schemeClr val="accent1"/>
-          </a:fillRef>
-          <a:effectRef idx="2">
-            <a:schemeClr val="accent1"/>
-          </a:effectRef>
-          <a:fontRef idx="minor">
-            <a:schemeClr val="lt1"/>
-          </a:fontRef>
-        </p:style>
-        <p:txBody>
-          <a:bodyPr rtlCol="0" anchor="ctr"/>
-          <a:lstStyle/>
-          <a:p>
-            <a:pPr algn="ctr"/>
-          </a:p>
-        </p:txBody>
-      </p:sp>
-      <p:sp>
-        <p:nvSpPr>
           <p:cNvPr id="18" name="TextBox 17"/>
           <p:cNvSpPr txBox="1"/>
           <p:nvPr/>
         </p:nvSpPr>
         <p:spPr>
           <a:xfrm>
-            <a:off x="2084832" y="2834640"/>
-            <a:ext cx="4434840" cy="320040"/>
+            <a:off x="2057400" y="4206240"/>
+            <a:ext cx="4023360" cy="822960"/>
           </a:xfrm>
           <a:prstGeom prst="rect">
             <a:avLst/>
@@ -8166,70 +7695,49 @@
           <a:p>
             <a:pPr algn="l">
               <a:lnSpc>
-                <a:spcPct val="100000"/>
+                <a:spcPct val="120000"/>
               </a:lnSpc>
             </a:pPr>
             <a:r>
+              <a:rPr sz="1400" b="0">
+                <a:solidFill>
+                  <a:srgbClr val="9AA0AA"/>
+                </a:solidFill>
+                <a:latin typeface="Segoe UI"/>
+              </a:rPr>
+              <a:t>how much you breathe </a:t>
+            </a:r>
+            <a:r>
+              <a:rPr sz="1400" b="0">
+                <a:solidFill>
+                  <a:srgbClr val="5C6470"/>
+                </a:solidFill>
+                <a:latin typeface="Segoe UI"/>
+              </a:rPr>
+              <a:t>=</a:t>
+            </a:r>
+            <a:r>
               <a:rPr sz="1400" b="1">
                 <a:solidFill>
-                  <a:srgbClr val="EDEBE4"/>
-                </a:solidFill>
-                <a:latin typeface="Segoe UI"/>
-              </a:rPr>
-              <a:t>No WebGL? No pretending.</a:t>
-            </a:r>
-          </a:p>
-        </p:txBody>
-      </p:sp>
-      <p:sp>
-        <p:nvSpPr>
-          <p:cNvPr id="19" name="TextBox 18"/>
-          <p:cNvSpPr txBox="1"/>
-          <p:nvPr/>
-        </p:nvSpPr>
-        <p:spPr>
-          <a:xfrm>
-            <a:off x="2084832" y="3163824"/>
-            <a:ext cx="4434840" cy="585216"/>
-          </a:xfrm>
-          <a:prstGeom prst="rect">
-            <a:avLst/>
-          </a:prstGeom>
-          <a:noFill/>
-        </p:spPr>
-        <p:txBody>
-          <a:bodyPr wrap="square" anchor="t" lIns="0" rIns="0" tIns="0" bIns="0">
-            <a:spAutoFit/>
-          </a:bodyPr>
-          <a:lstStyle/>
-          <a:p>
-            <a:pPr algn="l">
-              <a:lnSpc>
-                <a:spcPct val="112000"/>
-              </a:lnSpc>
-            </a:pPr>
-            <a:r>
-              <a:rPr sz="1100" b="0">
-                <a:solidFill>
-                  <a:srgbClr val="9AA0AA"/>
-                </a:solidFill>
-                <a:latin typeface="Segoe UI"/>
-              </a:rPr>
-              <a:t>Phones that can't do 3D get an honest raster map — flat, labelled, still real. We never fake tilt.</a:t>
-            </a:r>
-          </a:p>
-        </p:txBody>
-      </p:sp>
-      <p:sp>
-        <p:nvSpPr>
-          <p:cNvPr id="20" name="Rounded Rectangle 19"/>
+                  <a:srgbClr val="7FBF9A"/>
+                </a:solidFill>
+                <a:latin typeface="Segoe UI"/>
+              </a:rPr>
+              <a:t> the air × time × how hard you breathe</a:t>
+            </a:r>
+          </a:p>
+        </p:txBody>
+      </p:sp>
+      <p:sp>
+        <p:nvSpPr>
+          <p:cNvPr id="19" name="Rounded Rectangle 18"/>
           <p:cNvSpPr/>
           <p:nvPr/>
         </p:nvSpPr>
         <p:spPr>
           <a:xfrm>
-            <a:off x="6995160" y="2377440"/>
-            <a:ext cx="4892040" cy="1481328"/>
+            <a:off x="1828800" y="5230368"/>
+            <a:ext cx="4480560" cy="1097280"/>
           </a:xfrm>
           <a:prstGeom prst="roundRect">
             <a:avLst>
@@ -8270,13 +7778,13 @@
       </p:sp>
       <p:sp>
         <p:nvSpPr>
-          <p:cNvPr id="21" name="Rounded Rectangle 20"/>
+          <p:cNvPr id="20" name="Rounded Rectangle 19"/>
           <p:cNvSpPr/>
           <p:nvPr/>
         </p:nvSpPr>
         <p:spPr>
           <a:xfrm>
-            <a:off x="7251192" y="2615184"/>
+            <a:off x="2084832" y="5468112"/>
             <a:ext cx="100584" cy="100584"/>
           </a:xfrm>
           <a:prstGeom prst="roundRect">
@@ -8285,7 +7793,7 @@
             </a:avLst>
           </a:prstGeom>
           <a:solidFill>
-            <a:srgbClr val="7FBF9A"/>
+            <a:srgbClr val="D9A86C"/>
           </a:solidFill>
           <a:ln>
             <a:noFill/>
@@ -8316,14 +7824,14 @@
       </p:sp>
       <p:sp>
         <p:nvSpPr>
-          <p:cNvPr id="22" name="TextBox 21"/>
+          <p:cNvPr id="21" name="TextBox 20"/>
           <p:cNvSpPr txBox="1"/>
           <p:nvPr/>
         </p:nvSpPr>
         <p:spPr>
           <a:xfrm>
-            <a:off x="7251192" y="2834640"/>
-            <a:ext cx="4434840" cy="320040"/>
+            <a:off x="2084832" y="5687568"/>
+            <a:ext cx="4023360" cy="320040"/>
           </a:xfrm>
           <a:prstGeom prst="rect">
             <a:avLst/>
@@ -8348,21 +7856,21 @@
                 </a:solidFill>
                 <a:latin typeface="Segoe UI"/>
               </a:rPr>
-              <a:t>GPS lies politely.</a:t>
-            </a:r>
-          </a:p>
-        </p:txBody>
-      </p:sp>
-      <p:sp>
-        <p:nvSpPr>
-          <p:cNvPr id="23" name="TextBox 22"/>
+              <a:t>The hard part</a:t>
+            </a:r>
+          </a:p>
+        </p:txBody>
+      </p:sp>
+      <p:sp>
+        <p:nvSpPr>
+          <p:cNvPr id="22" name="TextBox 21"/>
           <p:cNvSpPr txBox="1"/>
           <p:nvPr/>
         </p:nvSpPr>
         <p:spPr>
           <a:xfrm>
-            <a:off x="7251192" y="3163824"/>
-            <a:ext cx="4434840" cy="585216"/>
+            <a:off x="2084832" y="6035040"/>
+            <a:ext cx="4023360" cy="182880"/>
           </a:xfrm>
           <a:prstGeom prst="rect">
             <a:avLst/>
@@ -8377,35 +7885,35 @@
           <a:p>
             <a:pPr algn="l">
               <a:lnSpc>
-                <a:spcPct val="112000"/>
+                <a:spcPct val="114000"/>
               </a:lnSpc>
             </a:pPr>
             <a:r>
-              <a:rPr sz="1100" b="0">
+              <a:rPr sz="1150" b="0">
                 <a:solidFill>
                   <a:srgbClr val="9AA0AA"/>
                 </a:solidFill>
                 <a:latin typeface="Segoe UI"/>
               </a:rPr>
-              <a:t>±50 m wobble near the finish could fake “done” — arrival must hold 4 s. Closed-tab restores re-probe, not stale fixes.</a:t>
-            </a:r>
-          </a:p>
-        </p:txBody>
-      </p:sp>
-      <p:sp>
-        <p:nvSpPr>
-          <p:cNvPr id="24" name="Rounded Rectangle 23"/>
+              <a:t>Street-by-street air, noisy GPS, flaky feeds — made honest anyway.</a:t>
+            </a:r>
+          </a:p>
+        </p:txBody>
+      </p:sp>
+      <p:sp>
+        <p:nvSpPr>
+          <p:cNvPr id="23" name="Rounded Rectangle 22"/>
           <p:cNvSpPr/>
           <p:nvPr/>
         </p:nvSpPr>
         <p:spPr>
           <a:xfrm>
-            <a:off x="1828800" y="4133088"/>
-            <a:ext cx="4892040" cy="1481328"/>
+            <a:off x="6537960" y="2103120"/>
+            <a:ext cx="5349240" cy="3794760"/>
           </a:xfrm>
           <a:prstGeom prst="roundRect">
             <a:avLst>
-              <a:gd name="adj" fmla="val 7000"/>
+              <a:gd name="adj" fmla="val 4000"/>
             </a:avLst>
           </a:prstGeom>
           <a:solidFill>
@@ -8440,62 +7948,40 @@
           </a:p>
         </p:txBody>
       </p:sp>
-      <p:sp>
-        <p:nvSpPr>
-          <p:cNvPr id="25" name="Rounded Rectangle 24"/>
-          <p:cNvSpPr/>
-          <p:nvPr/>
-        </p:nvSpPr>
-        <p:spPr>
-          <a:xfrm>
-            <a:off x="2084832" y="4370832"/>
-            <a:ext cx="100584" cy="100584"/>
-          </a:xfrm>
-          <a:prstGeom prst="roundRect">
-            <a:avLst>
-              <a:gd name="adj" fmla="val 50000"/>
-            </a:avLst>
-          </a:prstGeom>
-          <a:solidFill>
-            <a:srgbClr val="8FB8D9"/>
-          </a:solidFill>
-          <a:ln>
-            <a:noFill/>
-          </a:ln>
-          <a:effectLst/>
-        </p:spPr>
-        <p:style>
-          <a:lnRef idx="1">
-            <a:schemeClr val="accent1"/>
-          </a:lnRef>
-          <a:fillRef idx="3">
-            <a:schemeClr val="accent1"/>
-          </a:fillRef>
-          <a:effectRef idx="2">
-            <a:schemeClr val="accent1"/>
-          </a:effectRef>
-          <a:fontRef idx="minor">
-            <a:schemeClr val="lt1"/>
-          </a:fontRef>
-        </p:style>
-        <p:txBody>
-          <a:bodyPr rtlCol="0" anchor="ctr"/>
-          <a:lstStyle/>
-          <a:p>
-            <a:pPr algn="ctr"/>
-          </a:p>
-        </p:txBody>
-      </p:sp>
-      <p:sp>
-        <p:nvSpPr>
-          <p:cNvPr id="26" name="TextBox 25"/>
+      <p:pic>
+        <p:nvPicPr>
+          <p:cNvPr id="24" name="Picture 23" descr="deckimg_routes.png"/>
+          <p:cNvPicPr>
+            <a:picLocks noChangeAspect="1"/>
+          </p:cNvPicPr>
+          <p:nvPr/>
+        </p:nvPicPr>
+        <p:blipFill>
+          <a:blip r:embed="rId3"/>
+          <a:stretch>
+            <a:fillRect/>
+          </a:stretch>
+        </p:blipFill>
+        <p:spPr>
+          <a:xfrm>
+            <a:off x="8150535" y="2212848"/>
+            <a:ext cx="2124089" cy="3017520"/>
+          </a:xfrm>
+          <a:prstGeom prst="rect">
+            <a:avLst/>
+          </a:prstGeom>
+        </p:spPr>
+      </p:pic>
+      <p:sp>
+        <p:nvSpPr>
+          <p:cNvPr id="25" name="TextBox 24"/>
           <p:cNvSpPr txBox="1"/>
           <p:nvPr/>
         </p:nvSpPr>
         <p:spPr>
           <a:xfrm>
-            <a:off x="2084832" y="4590288"/>
-            <a:ext cx="4434840" cy="320040"/>
+            <a:off x="6720840" y="5349240"/>
+            <a:ext cx="4937760" cy="502920"/>
           </a:xfrm>
           <a:prstGeom prst="rect">
             <a:avLst/>
@@ -8514,279 +8000,38 @@
               </a:lnSpc>
             </a:pPr>
             <a:r>
-              <a:rPr sz="1400" b="1">
-                <a:solidFill>
-                  <a:srgbClr val="EDEBE4"/>
-                </a:solidFill>
-                <a:latin typeface="Segoe UI"/>
-              </a:rPr>
-              <a:t>14k cells ≠ 14k nodes.</a:t>
-            </a:r>
-          </a:p>
-        </p:txBody>
-      </p:sp>
-      <p:sp>
-        <p:nvSpPr>
-          <p:cNvPr id="27" name="TextBox 26"/>
-          <p:cNvSpPr txBox="1"/>
-          <p:nvPr/>
-        </p:nvSpPr>
-        <p:spPr>
-          <a:xfrm>
-            <a:off x="2084832" y="4919472"/>
-            <a:ext cx="4434840" cy="585216"/>
-          </a:xfrm>
-          <a:prstGeom prst="rect">
-            <a:avLst/>
-          </a:prstGeom>
-          <a:noFill/>
-        </p:spPr>
-        <p:txBody>
-          <a:bodyPr wrap="square" anchor="t" lIns="0" rIns="0" tIns="0" bIns="0">
-            <a:spAutoFit/>
-          </a:bodyPr>
-          <a:lstStyle/>
-          <a:p>
-            <a:pPr algn="l">
-              <a:lnSpc>
-                <a:spcPct val="112000"/>
-              </a:lnSpc>
-            </a:pPr>
-            <a:r>
-              <a:rPr sz="1100" b="0">
-                <a:solidFill>
-                  <a:srgbClr val="9AA0AA"/>
-                </a:solidFill>
-                <a:latin typeface="Segoe UI"/>
-              </a:rPr>
-              <a:t>The field paints as one tinted layer over the vector basemap; route lines re-assert after every style reload.</a:t>
-            </a:r>
-          </a:p>
-        </p:txBody>
-      </p:sp>
-      <p:sp>
-        <p:nvSpPr>
-          <p:cNvPr id="28" name="Rounded Rectangle 27"/>
-          <p:cNvSpPr/>
-          <p:nvPr/>
-        </p:nvSpPr>
-        <p:spPr>
-          <a:xfrm>
-            <a:off x="6995160" y="4133088"/>
-            <a:ext cx="4892040" cy="1481328"/>
-          </a:xfrm>
-          <a:prstGeom prst="roundRect">
-            <a:avLst>
-              <a:gd name="adj" fmla="val 7000"/>
-            </a:avLst>
-          </a:prstGeom>
-          <a:solidFill>
-            <a:srgbClr val="15181E"/>
-          </a:solidFill>
-          <a:ln w="9525">
-            <a:solidFill>
-              <a:srgbClr val="262B33"/>
-            </a:solidFill>
-          </a:ln>
-          <a:effectLst/>
-        </p:spPr>
-        <p:style>
-          <a:lnRef idx="1">
-            <a:schemeClr val="accent1"/>
-          </a:lnRef>
-          <a:fillRef idx="3">
-            <a:schemeClr val="accent1"/>
-          </a:fillRef>
-          <a:effectRef idx="2">
-            <a:schemeClr val="accent1"/>
-          </a:effectRef>
-          <a:fontRef idx="minor">
-            <a:schemeClr val="lt1"/>
-          </a:fontRef>
-        </p:style>
-        <p:txBody>
-          <a:bodyPr rtlCol="0" anchor="ctr"/>
-          <a:lstStyle/>
-          <a:p>
-            <a:pPr algn="ctr"/>
-          </a:p>
-        </p:txBody>
-      </p:sp>
-      <p:sp>
-        <p:nvSpPr>
-          <p:cNvPr id="29" name="Rounded Rectangle 28"/>
-          <p:cNvSpPr/>
-          <p:nvPr/>
-        </p:nvSpPr>
-        <p:spPr>
-          <a:xfrm>
-            <a:off x="7251192" y="4370832"/>
-            <a:ext cx="100584" cy="100584"/>
-          </a:xfrm>
-          <a:prstGeom prst="roundRect">
-            <a:avLst>
-              <a:gd name="adj" fmla="val 50000"/>
-            </a:avLst>
-          </a:prstGeom>
-          <a:solidFill>
-            <a:srgbClr val="C05F3A"/>
-          </a:solidFill>
-          <a:ln>
-            <a:noFill/>
-          </a:ln>
-          <a:effectLst/>
-        </p:spPr>
-        <p:style>
-          <a:lnRef idx="1">
-            <a:schemeClr val="accent1"/>
-          </a:lnRef>
-          <a:fillRef idx="3">
-            <a:schemeClr val="accent1"/>
-          </a:fillRef>
-          <a:effectRef idx="2">
-            <a:schemeClr val="accent1"/>
-          </a:effectRef>
-          <a:fontRef idx="minor">
-            <a:schemeClr val="lt1"/>
-          </a:fontRef>
-        </p:style>
-        <p:txBody>
-          <a:bodyPr rtlCol="0" anchor="ctr"/>
-          <a:lstStyle/>
-          <a:p>
-            <a:pPr algn="ctr"/>
-          </a:p>
-        </p:txBody>
-      </p:sp>
-      <p:sp>
-        <p:nvSpPr>
-          <p:cNvPr id="30" name="TextBox 29"/>
-          <p:cNvSpPr txBox="1"/>
-          <p:nvPr/>
-        </p:nvSpPr>
-        <p:spPr>
-          <a:xfrm>
-            <a:off x="7251192" y="4590288"/>
-            <a:ext cx="4434840" cy="320040"/>
-          </a:xfrm>
-          <a:prstGeom prst="rect">
-            <a:avLst/>
-          </a:prstGeom>
-          <a:noFill/>
-        </p:spPr>
-        <p:txBody>
-          <a:bodyPr wrap="square" anchor="t" lIns="0" rIns="0" tIns="0" bIns="0">
-            <a:spAutoFit/>
-          </a:bodyPr>
-          <a:lstStyle/>
-          <a:p>
-            <a:pPr algn="l">
-              <a:lnSpc>
-                <a:spcPct val="100000"/>
-              </a:lnSpc>
-            </a:pPr>
-            <a:r>
-              <a:rPr sz="1400" b="1">
-                <a:solidFill>
-                  <a:srgbClr val="EDEBE4"/>
-                </a:solidFill>
-                <a:latin typeface="Segoe UI"/>
-              </a:rPr>
-              <a:t>Your track stays yours.</a:t>
-            </a:r>
-          </a:p>
-        </p:txBody>
-      </p:sp>
-      <p:sp>
-        <p:nvSpPr>
-          <p:cNvPr id="31" name="TextBox 30"/>
-          <p:cNvSpPr txBox="1"/>
-          <p:nvPr/>
-        </p:nvSpPr>
-        <p:spPr>
-          <a:xfrm>
-            <a:off x="7251192" y="4919472"/>
-            <a:ext cx="4434840" cy="585216"/>
-          </a:xfrm>
-          <a:prstGeom prst="rect">
-            <a:avLst/>
-          </a:prstGeom>
-          <a:noFill/>
-        </p:spPr>
-        <p:txBody>
-          <a:bodyPr wrap="square" anchor="t" lIns="0" rIns="0" tIns="0" bIns="0">
-            <a:spAutoFit/>
-          </a:bodyPr>
-          <a:lstStyle/>
-          <a:p>
-            <a:pPr algn="l">
-              <a:lnSpc>
-                <a:spcPct val="112000"/>
-              </a:lnSpc>
-            </a:pPr>
-            <a:r>
-              <a:rPr sz="1100" b="0">
-                <a:solidFill>
-                  <a:srgbClr val="9AA0AA"/>
-                </a:solidFill>
-                <a:latin typeface="Segoe UI"/>
-              </a:rPr>
-              <a:t>Dose needs the path; tracking people is creepy. The GPS trail never leaves the phone — only anonymous counters leave.</a:t>
-            </a:r>
-          </a:p>
-        </p:txBody>
-      </p:sp>
-      <p:sp>
-        <p:nvSpPr>
-          <p:cNvPr id="32" name="TextBox 31"/>
-          <p:cNvSpPr txBox="1"/>
-          <p:nvPr/>
-        </p:nvSpPr>
-        <p:spPr>
-          <a:xfrm>
-            <a:off x="1828800" y="5943600"/>
-            <a:ext cx="8686800" cy="457200"/>
-          </a:xfrm>
-          <a:prstGeom prst="rect">
-            <a:avLst/>
-          </a:prstGeom>
-          <a:noFill/>
-        </p:spPr>
-        <p:txBody>
-          <a:bodyPr wrap="square" anchor="t" lIns="0" rIns="0" tIns="0" bIns="0">
-            <a:spAutoFit/>
-          </a:bodyPr>
-          <a:lstStyle/>
-          <a:p>
-            <a:pPr algn="l">
-              <a:lnSpc>
-                <a:spcPct val="100000"/>
-              </a:lnSpc>
-            </a:pPr>
-            <a:r>
-              <a:rPr sz="1200" b="0">
-                <a:solidFill>
-                  <a:srgbClr val="9AA0AA"/>
-                </a:solidFill>
-                <a:latin typeface="Segoe UI"/>
-              </a:rPr>
-              <a:t>Open data, open stack — OSM · OpenFreeMap · Open-Meteo/CAMS · CPCB/WAQI/DPCC · TomTom — </a:t>
-            </a:r>
-            <a:r>
-              <a:rPr sz="1200" b="1">
-                <a:solidFill>
-                  <a:srgbClr val="8FB8D9"/>
-                </a:solidFill>
-                <a:latin typeface="Segoe UI"/>
-              </a:rPr>
-              <a:t>delhi-is-alive.vercel.app</a:t>
-            </a:r>
-          </a:p>
-        </p:txBody>
-      </p:sp>
-      <p:sp>
-        <p:nvSpPr>
-          <p:cNvPr id="33" name="TextBox 32"/>
+              <a:rPr sz="1050" b="0">
+                <a:solidFill>
+                  <a:srgbClr val="5C6470"/>
+                </a:solidFill>
+                <a:latin typeface="Segoe UI"/>
+              </a:rPr>
+              <a:t>one real trip — </a:t>
+            </a:r>
+            <a:r>
+              <a:rPr sz="1050" b="1">
+                <a:solidFill>
+                  <a:srgbClr val="7FBF9A"/>
+                </a:solidFill>
+                <a:latin typeface="Segoe UI"/>
+              </a:rPr>
+              <a:t>green is ALive's pick, </a:t>
+            </a:r>
+            <a:r>
+              <a:rPr sz="1050" b="1">
+                <a:solidFill>
+                  <a:srgbClr val="C05F3A"/>
+                </a:solidFill>
+                <a:latin typeface="Segoe UI"/>
+              </a:rPr>
+              <a:t>red main road = +81% more smoke</a:t>
+            </a:r>
+          </a:p>
+        </p:txBody>
+      </p:sp>
+      <p:sp>
+        <p:nvSpPr>
+          <p:cNvPr id="26" name="TextBox 25"/>
           <p:cNvSpPr txBox="1"/>
           <p:nvPr/>
         </p:nvSpPr>

</xml_diff>